<commit_message>
feat(me3): localize Filipino voice pilot and verify Pi injection path
</commit_message>
<xml_diff>
--- a/Dumalaog_ME3 - Voice Duplex/docs/presentation/.build/candidate.pptx
+++ b/Dumalaog_ME3 - Voice Duplex/docs/presentation/.build/candidate.pptx
@@ -2,19 +2,20 @@
 <file path=ppt/presentation.xml><?xml version="1.0" encoding="utf-8"?>
 <p:presentation xmlns:p="http://schemas.openxmlformats.org/presentationml/2006/main">
   <p:sldMasterIdLst>
-    <p:sldMasterId xmlns:r="http://schemas.openxmlformats.org/officeDocument/2006/relationships" id="2147483648" r:id="R68e709bca9624e0c"/>
+    <p:sldMasterId xmlns:r="http://schemas.openxmlformats.org/officeDocument/2006/relationships" id="2147483648" r:id="R8e1461ffd21d4773"/>
   </p:sldMasterIdLst>
   <p:notesMasterIdLst>
-    <p:notesMasterId xmlns:r="http://schemas.openxmlformats.org/officeDocument/2006/relationships" r:id="R84b7fe917e3b4737"/>
+    <p:notesMasterId xmlns:r="http://schemas.openxmlformats.org/officeDocument/2006/relationships" r:id="Rdb8771b89a894692"/>
   </p:notesMasterIdLst>
   <p:sldIdLst>
-    <p:sldId xmlns:r="http://schemas.openxmlformats.org/officeDocument/2006/relationships" id="256" r:id="Rc9fd99fe87df4c23"/>
-    <p:sldId xmlns:r="http://schemas.openxmlformats.org/officeDocument/2006/relationships" id="257" r:id="R79916153df874f63"/>
-    <p:sldId xmlns:r="http://schemas.openxmlformats.org/officeDocument/2006/relationships" id="258" r:id="R5f3059c3dd9f4754"/>
-    <p:sldId xmlns:r="http://schemas.openxmlformats.org/officeDocument/2006/relationships" id="259" r:id="R44b995487ba14206"/>
-    <p:sldId xmlns:r="http://schemas.openxmlformats.org/officeDocument/2006/relationships" id="260" r:id="Re25715102c5c42e7"/>
-    <p:sldId xmlns:r="http://schemas.openxmlformats.org/officeDocument/2006/relationships" id="261" r:id="R0988280b45e64076"/>
-    <p:sldId xmlns:r="http://schemas.openxmlformats.org/officeDocument/2006/relationships" id="262" r:id="R8b2eeb7cb24a4add"/>
+    <p:sldId xmlns:r="http://schemas.openxmlformats.org/officeDocument/2006/relationships" id="256" r:id="Rb6c370e98c444fa2"/>
+    <p:sldId xmlns:r="http://schemas.openxmlformats.org/officeDocument/2006/relationships" id="257" r:id="Rd37ccd5913044242"/>
+    <p:sldId xmlns:r="http://schemas.openxmlformats.org/officeDocument/2006/relationships" id="258" r:id="Rcf747a6f1b544aba"/>
+    <p:sldId xmlns:r="http://schemas.openxmlformats.org/officeDocument/2006/relationships" id="259" r:id="Rcbcbb58d4b514d29"/>
+    <p:sldId xmlns:r="http://schemas.openxmlformats.org/officeDocument/2006/relationships" id="260" r:id="R4467d58f53264490"/>
+    <p:sldId xmlns:r="http://schemas.openxmlformats.org/officeDocument/2006/relationships" id="261" r:id="R590f65c8a3524efc"/>
+    <p:sldId xmlns:r="http://schemas.openxmlformats.org/officeDocument/2006/relationships" id="262" r:id="Re60624fc62fd42b9"/>
+    <p:sldId xmlns:r="http://schemas.openxmlformats.org/officeDocument/2006/relationships" id="263" r:id="Ra3ff6f7316fa48fb"/>
   </p:sldIdLst>
   <p:sldSz cx="12192000" cy="6858000"/>
   <p:notesSz cx="6858000" cy="9144000"/>
@@ -898,7 +899,7 @@
           <a:lstStyle xmlns:a="http://schemas.openxmlformats.org/drawingml/2006/main"/>
           <a:p xmlns:a="http://schemas.openxmlformats.org/drawingml/2006/main">
             <a:r>
-              <a:t>This slide protects the evidence boundary. The Pi now runs the verified release with a provisioned, mode-600 Qwen key, and a text-mode Qwen run built and served a web app on the Pi (LAN-verified). The remaining gates are physical Pi audio and a clean captured v1.5 overlap evaluation; local Windows evidence is not promoted into either claim.</a:t>
+              <a:t>This slide protects the evidence boundary. The Pi now has a visible Fifine capture device, and the voice-injection run made Qwen call tools and serve a generated web app. The split-device lane routes Pi capture to this workstation's speaker. The remaining gates are a physical Pi playback check, live Filipino provider credentials, and a clean captured v1.5 overlap evaluation.</a:t>
             </a:r>
           </a:p>
           <a:p xmlns:a="http://schemas.openxmlformats.org/drawingml/2006/main">
@@ -988,7 +989,97 @@
           <a:lstStyle xmlns:a="http://schemas.openxmlformats.org/drawingml/2006/main"/>
           <a:p xmlns:a="http://schemas.openxmlformats.org/drawingml/2006/main">
             <a:r>
-              <a:t>Close by returning to the user-visible promise: speak a request, let the model call bounded tools, and receive an answer backed by what the tools actually returned. The remaining work is hardware audio and benchmark evidence, not model training.</a:t>
+              <a:t>The Philippines profile localizes the existing Qwen/tool agent rather than replacing its reasoning model. ElevenLabs documents Filipino as fil and lists it for Flash v2.5. A matching voice ID is still an operator decision. The call-center framing is a supervised pilot: the system should answer low-risk requests, disclose that it is AI, and hand off uncertain or regulated cases to people. Sources: docs/PHILIPPINE_CALL_CENTER_PILOT.md; https://elevenlabs.io/docs/help-center/other/what-languages-do-you-support.</a:t>
+            </a:r>
+          </a:p>
+          <a:p xmlns:a="http://schemas.openxmlformats.org/drawingml/2006/main">
+            <a:r>
+              <a:t/>
+            </a:r>
+          </a:p>
+          <a:p xmlns:a="http://schemas.openxmlformats.org/drawingml/2006/main">
+            <a:r>
+              <a:t>[Sources]</a:t>
+            </a:r>
+          </a:p>
+          <a:p xmlns:a="http://schemas.openxmlformats.org/drawingml/2006/main">
+            <a:r>
+              <a:t>AI 231/Dumalaog_ME3 - Voice Duplex/README.md</a:t>
+            </a:r>
+          </a:p>
+          <a:p xmlns:a="http://schemas.openxmlformats.org/drawingml/2006/main">
+            <a:r>
+              <a:t>AI 231/Dumalaog_ME3 - Voice Duplex/docs/ME3_MANUAL_ELI5_AND_DEEP.md</a:t>
+            </a:r>
+          </a:p>
+        </p:txBody>
+      </p:sp>
+      <p:sp>
+        <p:nvSpPr>
+          <p:cNvPr id="4" name="Slide Number Placeholder 3"/>
+          <p:cNvSpPr>
+            <a:spLocks xmlns:a="http://schemas.openxmlformats.org/drawingml/2006/main" noGrp="1"/>
+          </p:cNvSpPr>
+          <p:nvPr>
+            <p:ph type="sldNum" idx="5"/>
+          </p:nvPr>
+        </p:nvSpPr>
+        <p:spPr/>
+        <p:txBody>
+          <a:bodyPr xmlns:a="http://schemas.openxmlformats.org/drawingml/2006/main"/>
+          <a:lstStyle xmlns:a="http://schemas.openxmlformats.org/drawingml/2006/main"/>
+          <a:p xmlns:a="http://schemas.openxmlformats.org/drawingml/2006/main"/>
+        </p:txBody>
+      </p:sp>
+    </p:spTree>
+  </p:cSld>
+  <p:clrMapOvr>
+    <a:masterClrMapping xmlns:a="http://schemas.openxmlformats.org/drawingml/2006/main"/>
+  </p:clrMapOvr>
+</p:notes>
+</file>
+
+<file path=ppt/notesSlides/notesSlide8.xml><?xml version="1.0" encoding="utf-8"?>
+<p:notes xmlns:p="http://schemas.openxmlformats.org/presentationml/2006/main">
+  <p:cSld>
+    <p:spTree>
+      <p:nvGrpSpPr>
+        <p:cNvPr id="1" name=""/>
+        <p:cNvGrpSpPr/>
+        <p:nvPr/>
+      </p:nvGrpSpPr>
+      <p:grpSpPr>
+        <a:xfrm xmlns:a="http://schemas.openxmlformats.org/drawingml/2006/main"/>
+      </p:grpSpPr>
+      <p:sp>
+        <p:nvSpPr>
+          <p:cNvPr id="2" name="Slide Image Placeholder 1"/>
+          <p:cNvSpPr>
+            <a:spLocks xmlns:a="http://schemas.openxmlformats.org/drawingml/2006/main" noGrp="1"/>
+          </p:cNvSpPr>
+          <p:nvPr>
+            <p:ph type="sldImg" idx="0"/>
+          </p:nvPr>
+        </p:nvSpPr>
+        <p:spPr/>
+      </p:sp>
+      <p:sp>
+        <p:nvSpPr>
+          <p:cNvPr id="3" name="Notes Placeholder 2"/>
+          <p:cNvSpPr>
+            <a:spLocks xmlns:a="http://schemas.openxmlformats.org/drawingml/2006/main" noGrp="1"/>
+          </p:cNvSpPr>
+          <p:nvPr>
+            <p:ph type="body" idx="1"/>
+          </p:nvPr>
+        </p:nvSpPr>
+        <p:spPr/>
+        <p:txBody>
+          <a:bodyPr xmlns:a="http://schemas.openxmlformats.org/drawingml/2006/main"/>
+          <a:lstStyle xmlns:a="http://schemas.openxmlformats.org/drawingml/2006/main"/>
+          <a:p xmlns:a="http://schemas.openxmlformats.org/drawingml/2006/main">
+            <a:r>
+              <a:t>Close by returning to the user-visible promise: speak a request, let the model call bounded tools, and receive an answer backed by what the tools actually returned. Filipino localization changes the voice and support policy, not the evidence boundary. The remaining work is secure provider provisioning, physical Pi playback, and benchmark evidence.</a:t>
             </a:r>
           </a:p>
           <a:p xmlns:a="http://schemas.openxmlformats.org/drawingml/2006/main">
@@ -1055,7 +1146,7 @@
           <p:cNvPr id="3" name="Title">
             <a:extLst xmlns:a="http://schemas.openxmlformats.org/drawingml/2006/main">
               <a:ext uri="{FF2B5EF4-FFF2-40B4-BE49-F238E27FC236}">
-                <a16:creationId xmlns:a16="http://schemas.microsoft.com/office/drawing/2014/main" id="{34CBA00E-83A4-49A5-9BAF-1E115402B1CC}"/>
+                <a16:creationId xmlns:a16="http://schemas.microsoft.com/office/drawing/2014/main" id="{A4FABE36-5F7A-4AB5-8C77-1627B704353C}"/>
               </a:ext>
             </a:extLst>
           </p:cNvPr>
@@ -1284,7 +1375,7 @@
           <p:cNvPr id="2" name="Subtitle">
             <a:extLst xmlns:a="http://schemas.openxmlformats.org/drawingml/2006/main">
               <a:ext uri="{FF2B5EF4-FFF2-40B4-BE49-F238E27FC236}">
-                <a16:creationId xmlns:a16="http://schemas.microsoft.com/office/drawing/2014/main" id="{B94545FE-2058-471D-9F0E-B0C2469334B9}"/>
+                <a16:creationId xmlns:a16="http://schemas.microsoft.com/office/drawing/2014/main" id="{C6C1C527-7658-4658-BE6C-F9943AA2890C}"/>
               </a:ext>
             </a:extLst>
           </p:cNvPr>
@@ -1530,7 +1621,7 @@
           <p:cNvPr id="2" name="Section title">
             <a:extLst xmlns:a="http://schemas.openxmlformats.org/drawingml/2006/main">
               <a:ext uri="{FF2B5EF4-FFF2-40B4-BE49-F238E27FC236}">
-                <a16:creationId xmlns:a16="http://schemas.microsoft.com/office/drawing/2014/main" id="{2E6D93D2-CDF5-4353-BE10-55BF957FCBB0}"/>
+                <a16:creationId xmlns:a16="http://schemas.microsoft.com/office/drawing/2014/main" id="{22A04970-A7AF-4829-B849-D326368B5610}"/>
               </a:ext>
             </a:extLst>
           </p:cNvPr>
@@ -1776,7 +1867,7 @@
           <p:cNvPr id="3" name="Title">
             <a:extLst xmlns:a="http://schemas.openxmlformats.org/drawingml/2006/main">
               <a:ext uri="{FF2B5EF4-FFF2-40B4-BE49-F238E27FC236}">
-                <a16:creationId xmlns:a16="http://schemas.microsoft.com/office/drawing/2014/main" id="{6C6ADE21-0906-4D52-9F4E-867AA9ABE857}"/>
+                <a16:creationId xmlns:a16="http://schemas.microsoft.com/office/drawing/2014/main" id="{A333FF18-CD47-4189-9FEC-417D24BCDC3B}"/>
               </a:ext>
             </a:extLst>
           </p:cNvPr>
@@ -2005,7 +2096,7 @@
           <p:cNvPr id="2" name="Body">
             <a:extLst xmlns:a="http://schemas.openxmlformats.org/drawingml/2006/main">
               <a:ext uri="{FF2B5EF4-FFF2-40B4-BE49-F238E27FC236}">
-                <a16:creationId xmlns:a16="http://schemas.microsoft.com/office/drawing/2014/main" id="{F5D001EF-AC70-442B-BB95-5F5E200F7AAA}"/>
+                <a16:creationId xmlns:a16="http://schemas.microsoft.com/office/drawing/2014/main" id="{018F28F3-E88B-4C61-A9D0-5636223E6E16}"/>
               </a:ext>
             </a:extLst>
           </p:cNvPr>
@@ -2251,7 +2342,7 @@
           <p:cNvPr id="4" name="Title">
             <a:extLst xmlns:a="http://schemas.openxmlformats.org/drawingml/2006/main">
               <a:ext uri="{FF2B5EF4-FFF2-40B4-BE49-F238E27FC236}">
-                <a16:creationId xmlns:a16="http://schemas.microsoft.com/office/drawing/2014/main" id="{9B21A88E-7DDD-4FEE-8249-AEF5DA77E65B}"/>
+                <a16:creationId xmlns:a16="http://schemas.microsoft.com/office/drawing/2014/main" id="{774EEFE1-6A65-4B8E-BB9A-9252D8C5F0AB}"/>
               </a:ext>
             </a:extLst>
           </p:cNvPr>
@@ -2480,7 +2571,7 @@
           <p:cNvPr id="2" name="Left column">
             <a:extLst xmlns:a="http://schemas.openxmlformats.org/drawingml/2006/main">
               <a:ext uri="{FF2B5EF4-FFF2-40B4-BE49-F238E27FC236}">
-                <a16:creationId xmlns:a16="http://schemas.microsoft.com/office/drawing/2014/main" id="{566B4DC6-5427-499A-B285-4360B72DFB12}"/>
+                <a16:creationId xmlns:a16="http://schemas.microsoft.com/office/drawing/2014/main" id="{CB80E886-C6C6-4D5C-A7A2-B159C8AD7970}"/>
               </a:ext>
             </a:extLst>
           </p:cNvPr>
@@ -2709,7 +2800,7 @@
           <p:cNvPr id="3" name="Right column">
             <a:extLst xmlns:a="http://schemas.openxmlformats.org/drawingml/2006/main">
               <a:ext uri="{FF2B5EF4-FFF2-40B4-BE49-F238E27FC236}">
-                <a16:creationId xmlns:a16="http://schemas.microsoft.com/office/drawing/2014/main" id="{A9019303-F50D-4388-87F5-9D6047A7B432}"/>
+                <a16:creationId xmlns:a16="http://schemas.microsoft.com/office/drawing/2014/main" id="{0A15956D-60E9-4987-95A3-BFA4CFB16D94}"/>
               </a:ext>
             </a:extLst>
           </p:cNvPr>
@@ -2955,7 +3046,7 @@
           <p:cNvPr id="3" name="Title">
             <a:extLst xmlns:a="http://schemas.openxmlformats.org/drawingml/2006/main">
               <a:ext uri="{FF2B5EF4-FFF2-40B4-BE49-F238E27FC236}">
-                <a16:creationId xmlns:a16="http://schemas.microsoft.com/office/drawing/2014/main" id="{F9536DCC-B9BA-456B-9335-CB4B96933DAB}"/>
+                <a16:creationId xmlns:a16="http://schemas.microsoft.com/office/drawing/2014/main" id="{9DF2DB38-CD91-40A3-9524-D8A66CA5D386}"/>
               </a:ext>
             </a:extLst>
           </p:cNvPr>
@@ -3184,7 +3275,7 @@
           <p:cNvPr id="2" name="Left column">
             <a:extLst xmlns:a="http://schemas.openxmlformats.org/drawingml/2006/main">
               <a:ext uri="{FF2B5EF4-FFF2-40B4-BE49-F238E27FC236}">
-                <a16:creationId xmlns:a16="http://schemas.microsoft.com/office/drawing/2014/main" id="{66025A96-2876-4C55-A1FC-8D652400527E}"/>
+                <a16:creationId xmlns:a16="http://schemas.microsoft.com/office/drawing/2014/main" id="{28B4CAE5-6AF1-42DB-93AA-9101356C1051}"/>
               </a:ext>
             </a:extLst>
           </p:cNvPr>
@@ -3451,12 +3542,12 @@
   </p:cSld>
   <p:clrMap bg1="lt1" tx1="dk1" bg2="lt2" tx2="dk2" accent1="accent1" accent2="accent2" accent3="accent3" accent4="accent4" accent5="accent5" accent6="accent6" hlink="hlink" folHlink="folHlink"/>
   <p:sldLayoutIdLst>
-    <p:sldLayoutId xmlns:r="http://schemas.openxmlformats.org/officeDocument/2006/relationships" id="2147483649" r:id="R39c1b1178ccf4c8d"/>
-    <p:sldLayoutId xmlns:r="http://schemas.openxmlformats.org/officeDocument/2006/relationships" id="2147483650" r:id="Rcf5a030137874c92"/>
-    <p:sldLayoutId xmlns:r="http://schemas.openxmlformats.org/officeDocument/2006/relationships" id="2147483651" r:id="Rb58b430733c5488d"/>
-    <p:sldLayoutId xmlns:r="http://schemas.openxmlformats.org/officeDocument/2006/relationships" id="2147483652" r:id="Ra03d1775cde743cf"/>
-    <p:sldLayoutId xmlns:r="http://schemas.openxmlformats.org/officeDocument/2006/relationships" id="2147483653" r:id="R68494371c188411d"/>
-    <p:sldLayoutId xmlns:r="http://schemas.openxmlformats.org/officeDocument/2006/relationships" id="2147483654" r:id="Rbc91dbf58c8e47da"/>
+    <p:sldLayoutId xmlns:r="http://schemas.openxmlformats.org/officeDocument/2006/relationships" id="2147483649" r:id="R50cbed0575a1422a"/>
+    <p:sldLayoutId xmlns:r="http://schemas.openxmlformats.org/officeDocument/2006/relationships" id="2147483650" r:id="R51fc0fc760344ef9"/>
+    <p:sldLayoutId xmlns:r="http://schemas.openxmlformats.org/officeDocument/2006/relationships" id="2147483651" r:id="R3fb9812f87c64e91"/>
+    <p:sldLayoutId xmlns:r="http://schemas.openxmlformats.org/officeDocument/2006/relationships" id="2147483652" r:id="R1cb6c85dbc684beb"/>
+    <p:sldLayoutId xmlns:r="http://schemas.openxmlformats.org/officeDocument/2006/relationships" id="2147483653" r:id="Raad3d0396ef04a55"/>
+    <p:sldLayoutId xmlns:r="http://schemas.openxmlformats.org/officeDocument/2006/relationships" id="2147483654" r:id="Raa7cfdaa500746a7"/>
   </p:sldLayoutIdLst>
   <p:txStyles>
     <p:titleStyle>
@@ -4007,7 +4098,7 @@
           <p:cNvPr id="11" name="cover-orbit">
             <a:extLst xmlns:a="http://schemas.openxmlformats.org/drawingml/2006/main">
               <a:ext uri="{FF2B5EF4-FFF2-40B4-BE49-F238E27FC236}">
-                <a16:creationId xmlns:a16="http://schemas.microsoft.com/office/drawing/2014/main" id="{075002AE-C239-42AA-B29A-EA44C2826D8B}"/>
+                <a16:creationId xmlns:a16="http://schemas.microsoft.com/office/drawing/2014/main" id="{058A6101-5950-4F75-A026-83FE36B08D8C}"/>
               </a:ext>
             </a:extLst>
           </p:cNvPr>
@@ -4038,7 +4129,7 @@
           <p:cNvPr id="2" name="cover-ring">
             <a:extLst xmlns:a="http://schemas.openxmlformats.org/drawingml/2006/main">
               <a:ext uri="{FF2B5EF4-FFF2-40B4-BE49-F238E27FC236}">
-                <a16:creationId xmlns:a16="http://schemas.microsoft.com/office/drawing/2014/main" id="{5F8842DF-222D-409B-9141-BD5C8EA9EA8B}"/>
+                <a16:creationId xmlns:a16="http://schemas.microsoft.com/office/drawing/2014/main" id="{B9420CCC-BC6B-402F-9540-776278AF7CE9}"/>
               </a:ext>
             </a:extLst>
           </p:cNvPr>
@@ -4069,7 +4160,7 @@
           <p:cNvPr id="3" name="cover-core">
             <a:extLst xmlns:a="http://schemas.openxmlformats.org/drawingml/2006/main">
               <a:ext uri="{FF2B5EF4-FFF2-40B4-BE49-F238E27FC236}">
-                <a16:creationId xmlns:a16="http://schemas.microsoft.com/office/drawing/2014/main" id="{90E99DEB-5B03-419D-8CB7-CA3D86C58E41}"/>
+                <a16:creationId xmlns:a16="http://schemas.microsoft.com/office/drawing/2014/main" id="{0D3A1AB6-0FD2-4BD1-BAED-CE161B96DEEF}"/>
               </a:ext>
             </a:extLst>
           </p:cNvPr>
@@ -4100,7 +4191,7 @@
           <p:cNvPr id="4" name="">
             <a:extLst xmlns:a="http://schemas.openxmlformats.org/drawingml/2006/main">
               <a:ext uri="{FF2B5EF4-FFF2-40B4-BE49-F238E27FC236}">
-                <a16:creationId xmlns:a16="http://schemas.microsoft.com/office/drawing/2014/main" id="{90BB9F24-4DD0-4A3E-AD8C-92FDA587B209}"/>
+                <a16:creationId xmlns:a16="http://schemas.microsoft.com/office/drawing/2014/main" id="{35BEA577-91F9-4ACE-B79F-4DCA6FD4602C}"/>
               </a:ext>
             </a:extLst>
           </p:cNvPr>
@@ -4257,7 +4348,7 @@
           <p:cNvPr id="5" name="">
             <a:extLst xmlns:a="http://schemas.openxmlformats.org/drawingml/2006/main">
               <a:ext uri="{FF2B5EF4-FFF2-40B4-BE49-F238E27FC236}">
-                <a16:creationId xmlns:a16="http://schemas.microsoft.com/office/drawing/2014/main" id="{19DC700C-FDD8-4307-A14B-F84A3A43386F}"/>
+                <a16:creationId xmlns:a16="http://schemas.microsoft.com/office/drawing/2014/main" id="{C5C8B543-15C3-4CE0-9D78-6235B588CA92}"/>
               </a:ext>
             </a:extLst>
           </p:cNvPr>
@@ -4437,7 +4528,7 @@
           <p:cNvPr id="6" name="">
             <a:extLst xmlns:a="http://schemas.openxmlformats.org/drawingml/2006/main">
               <a:ext uri="{FF2B5EF4-FFF2-40B4-BE49-F238E27FC236}">
-                <a16:creationId xmlns:a16="http://schemas.microsoft.com/office/drawing/2014/main" id="{1E2CCD30-0600-4241-8A37-63B5C2E9319E}"/>
+                <a16:creationId xmlns:a16="http://schemas.microsoft.com/office/drawing/2014/main" id="{EF30BA5E-B41A-4332-8556-F71221608447}"/>
               </a:ext>
             </a:extLst>
           </p:cNvPr>
@@ -4594,7 +4685,7 @@
           <p:cNvPr id="7" name="cover-callout">
             <a:extLst xmlns:a="http://schemas.openxmlformats.org/drawingml/2006/main">
               <a:ext uri="{FF2B5EF4-FFF2-40B4-BE49-F238E27FC236}">
-                <a16:creationId xmlns:a16="http://schemas.microsoft.com/office/drawing/2014/main" id="{ABF9EEC4-085A-4F6A-870F-036C2F9A8E60}"/>
+                <a16:creationId xmlns:a16="http://schemas.microsoft.com/office/drawing/2014/main" id="{214ADBA6-BDEF-4ECB-9750-9BDB80888766}"/>
               </a:ext>
             </a:extLst>
           </p:cNvPr>
@@ -4627,7 +4718,7 @@
           <p:cNvPr id="8" name="">
             <a:extLst xmlns:a="http://schemas.openxmlformats.org/drawingml/2006/main">
               <a:ext uri="{FF2B5EF4-FFF2-40B4-BE49-F238E27FC236}">
-                <a16:creationId xmlns:a16="http://schemas.microsoft.com/office/drawing/2014/main" id="{2D35943D-D753-488F-ADBC-FEE9962DFBDA}"/>
+                <a16:creationId xmlns:a16="http://schemas.microsoft.com/office/drawing/2014/main" id="{B0EDC225-1155-4B85-AAB4-5BD9012F1098}"/>
               </a:ext>
             </a:extLst>
           </p:cNvPr>
@@ -4784,7 +4875,7 @@
           <p:cNvPr id="9" name="">
             <a:extLst xmlns:a="http://schemas.openxmlformats.org/drawingml/2006/main">
               <a:ext uri="{FF2B5EF4-FFF2-40B4-BE49-F238E27FC236}">
-                <a16:creationId xmlns:a16="http://schemas.microsoft.com/office/drawing/2014/main" id="{EB1DCB11-5A26-47E5-8C9F-288446183B7D}"/>
+                <a16:creationId xmlns:a16="http://schemas.microsoft.com/office/drawing/2014/main" id="{4999D4C5-3154-496C-AEE1-D2E7BF777D5C}"/>
               </a:ext>
             </a:extLst>
           </p:cNvPr>
@@ -4941,7 +5032,7 @@
           <p:cNvPr id="10" name="">
             <a:extLst xmlns:a="http://schemas.openxmlformats.org/drawingml/2006/main">
               <a:ext uri="{FF2B5EF4-FFF2-40B4-BE49-F238E27FC236}">
-                <a16:creationId xmlns:a16="http://schemas.microsoft.com/office/drawing/2014/main" id="{E9DC3FCA-F423-45F9-B802-41604DD6A6F7}"/>
+                <a16:creationId xmlns:a16="http://schemas.microsoft.com/office/drawing/2014/main" id="{4FC89E79-284C-4405-91BD-D741928FE69A}"/>
               </a:ext>
             </a:extLst>
           </p:cNvPr>
@@ -5096,7 +5187,7 @@
     </p:spTree>
     <p:extLst>
       <p:ext uri="{BB962C8B-B14F-4D97-AF65-F5344CB8AC3E}">
-        <p14:creationId xmlns:p14="http://schemas.microsoft.com/office/powerpoint/2010/main" val="1410752319"/>
+        <p14:creationId xmlns:p14="http://schemas.microsoft.com/office/powerpoint/2010/main" val="2011998741"/>
       </p:ext>
     </p:extLst>
   </p:cSld>
@@ -5127,7 +5218,7 @@
           <p:cNvPr id="27" name="">
             <a:extLst xmlns:a="http://schemas.openxmlformats.org/drawingml/2006/main">
               <a:ext uri="{FF2B5EF4-FFF2-40B4-BE49-F238E27FC236}">
-                <a16:creationId xmlns:a16="http://schemas.microsoft.com/office/drawing/2014/main" id="{6ED2E299-2A7A-426B-A066-59A3A0FAFA7F}"/>
+                <a16:creationId xmlns:a16="http://schemas.microsoft.com/office/drawing/2014/main" id="{84D0D8AA-0661-4AE4-BFBC-4A606605E649}"/>
               </a:ext>
             </a:extLst>
           </p:cNvPr>
@@ -5284,7 +5375,7 @@
           <p:cNvPr id="2" name="">
             <a:extLst xmlns:a="http://schemas.openxmlformats.org/drawingml/2006/main">
               <a:ext uri="{FF2B5EF4-FFF2-40B4-BE49-F238E27FC236}">
-                <a16:creationId xmlns:a16="http://schemas.microsoft.com/office/drawing/2014/main" id="{D1849457-B149-4EBE-BC69-12A0BB4CD3FC}"/>
+                <a16:creationId xmlns:a16="http://schemas.microsoft.com/office/drawing/2014/main" id="{DD7769B0-1B84-47C8-9973-AE282FC54005}"/>
               </a:ext>
             </a:extLst>
           </p:cNvPr>
@@ -5441,7 +5532,7 @@
           <p:cNvPr id="3" name="">
             <a:extLst xmlns:a="http://schemas.openxmlformats.org/drawingml/2006/main">
               <a:ext uri="{FF2B5EF4-FFF2-40B4-BE49-F238E27FC236}">
-                <a16:creationId xmlns:a16="http://schemas.microsoft.com/office/drawing/2014/main" id="{5F174E94-B0A4-4286-A9C6-77F33C2D8FAF}"/>
+                <a16:creationId xmlns:a16="http://schemas.microsoft.com/office/drawing/2014/main" id="{F94BFF10-0FBC-4D41-AB4D-5B985FD08E73}"/>
               </a:ext>
             </a:extLst>
           </p:cNvPr>
@@ -5598,7 +5689,7 @@
           <p:cNvPr id="4" name="sequence-1">
             <a:extLst xmlns:a="http://schemas.openxmlformats.org/drawingml/2006/main">
               <a:ext uri="{FF2B5EF4-FFF2-40B4-BE49-F238E27FC236}">
-                <a16:creationId xmlns:a16="http://schemas.microsoft.com/office/drawing/2014/main" id="{3F83432E-7FAC-4F73-9BAC-B413CD800BAA}"/>
+                <a16:creationId xmlns:a16="http://schemas.microsoft.com/office/drawing/2014/main" id="{C4F9DD19-7A6C-4100-92C1-FD397D4D02AF}"/>
               </a:ext>
             </a:extLst>
           </p:cNvPr>
@@ -5627,7 +5718,7 @@
           <p:cNvPr id="5" name="sequence-2">
             <a:extLst xmlns:a="http://schemas.openxmlformats.org/drawingml/2006/main">
               <a:ext uri="{FF2B5EF4-FFF2-40B4-BE49-F238E27FC236}">
-                <a16:creationId xmlns:a16="http://schemas.microsoft.com/office/drawing/2014/main" id="{0383DCB2-AC15-4B5B-B3DE-184AC32E0074}"/>
+                <a16:creationId xmlns:a16="http://schemas.microsoft.com/office/drawing/2014/main" id="{9B54BF8C-73C8-4FF3-9B9C-34D6C839C581}"/>
               </a:ext>
             </a:extLst>
           </p:cNvPr>
@@ -5656,7 +5747,7 @@
           <p:cNvPr id="6" name="sequence-3">
             <a:extLst xmlns:a="http://schemas.openxmlformats.org/drawingml/2006/main">
               <a:ext uri="{FF2B5EF4-FFF2-40B4-BE49-F238E27FC236}">
-                <a16:creationId xmlns:a16="http://schemas.microsoft.com/office/drawing/2014/main" id="{5AD4D370-3967-4913-9350-B956A4F0C978}"/>
+                <a16:creationId xmlns:a16="http://schemas.microsoft.com/office/drawing/2014/main" id="{53102701-9FE6-4816-9074-D007DA7A2845}"/>
               </a:ext>
             </a:extLst>
           </p:cNvPr>
@@ -5685,7 +5776,7 @@
           <p:cNvPr id="7" name="sequence-node-0">
             <a:extLst xmlns:a="http://schemas.openxmlformats.org/drawingml/2006/main">
               <a:ext uri="{FF2B5EF4-FFF2-40B4-BE49-F238E27FC236}">
-                <a16:creationId xmlns:a16="http://schemas.microsoft.com/office/drawing/2014/main" id="{2990304E-2328-47E7-B32F-539E252A88A0}"/>
+                <a16:creationId xmlns:a16="http://schemas.microsoft.com/office/drawing/2014/main" id="{D94873E4-B33E-4682-A8F8-C3ECDF92652B}"/>
               </a:ext>
             </a:extLst>
           </p:cNvPr>
@@ -5720,7 +5811,7 @@
           <p:cNvPr id="8" name="">
             <a:extLst xmlns:a="http://schemas.openxmlformats.org/drawingml/2006/main">
               <a:ext uri="{FF2B5EF4-FFF2-40B4-BE49-F238E27FC236}">
-                <a16:creationId xmlns:a16="http://schemas.microsoft.com/office/drawing/2014/main" id="{3A27E3D5-9EB8-46D3-A35E-8245709DEB76}"/>
+                <a16:creationId xmlns:a16="http://schemas.microsoft.com/office/drawing/2014/main" id="{5A3394C5-8A4D-49D5-A5FF-1066BE545264}"/>
               </a:ext>
             </a:extLst>
           </p:cNvPr>
@@ -5877,7 +5968,7 @@
           <p:cNvPr id="9" name="">
             <a:extLst xmlns:a="http://schemas.openxmlformats.org/drawingml/2006/main">
               <a:ext uri="{FF2B5EF4-FFF2-40B4-BE49-F238E27FC236}">
-                <a16:creationId xmlns:a16="http://schemas.microsoft.com/office/drawing/2014/main" id="{B643FFEC-2977-49D8-824E-5025EC4A096D}"/>
+                <a16:creationId xmlns:a16="http://schemas.microsoft.com/office/drawing/2014/main" id="{43439B0F-4D9B-49FF-A56F-FA897F0F479A}"/>
               </a:ext>
             </a:extLst>
           </p:cNvPr>
@@ -6034,7 +6125,7 @@
           <p:cNvPr id="10" name="">
             <a:extLst xmlns:a="http://schemas.openxmlformats.org/drawingml/2006/main">
               <a:ext uri="{FF2B5EF4-FFF2-40B4-BE49-F238E27FC236}">
-                <a16:creationId xmlns:a16="http://schemas.microsoft.com/office/drawing/2014/main" id="{5D0668B2-5385-4322-825E-58E3D7E296D0}"/>
+                <a16:creationId xmlns:a16="http://schemas.microsoft.com/office/drawing/2014/main" id="{96CC9312-1CD7-4BCF-BF18-E96686D1E76D}"/>
               </a:ext>
             </a:extLst>
           </p:cNvPr>
@@ -6191,7 +6282,7 @@
           <p:cNvPr id="11" name="sequence-node-1">
             <a:extLst xmlns:a="http://schemas.openxmlformats.org/drawingml/2006/main">
               <a:ext uri="{FF2B5EF4-FFF2-40B4-BE49-F238E27FC236}">
-                <a16:creationId xmlns:a16="http://schemas.microsoft.com/office/drawing/2014/main" id="{D2CD329A-F6B7-46EC-BC71-0E5609176183}"/>
+                <a16:creationId xmlns:a16="http://schemas.microsoft.com/office/drawing/2014/main" id="{364CE471-80E9-48AA-9197-782626DF5B26}"/>
               </a:ext>
             </a:extLst>
           </p:cNvPr>
@@ -6226,7 +6317,7 @@
           <p:cNvPr id="12" name="">
             <a:extLst xmlns:a="http://schemas.openxmlformats.org/drawingml/2006/main">
               <a:ext uri="{FF2B5EF4-FFF2-40B4-BE49-F238E27FC236}">
-                <a16:creationId xmlns:a16="http://schemas.microsoft.com/office/drawing/2014/main" id="{3022941D-4DDA-429E-BAA5-20F9B241865C}"/>
+                <a16:creationId xmlns:a16="http://schemas.microsoft.com/office/drawing/2014/main" id="{EEE46B65-2907-4437-8523-BF624D61B89D}"/>
               </a:ext>
             </a:extLst>
           </p:cNvPr>
@@ -6383,7 +6474,7 @@
           <p:cNvPr id="13" name="">
             <a:extLst xmlns:a="http://schemas.openxmlformats.org/drawingml/2006/main">
               <a:ext uri="{FF2B5EF4-FFF2-40B4-BE49-F238E27FC236}">
-                <a16:creationId xmlns:a16="http://schemas.microsoft.com/office/drawing/2014/main" id="{C992CE84-82D7-40EC-B67A-1AC5EB68210A}"/>
+                <a16:creationId xmlns:a16="http://schemas.microsoft.com/office/drawing/2014/main" id="{2AB7D4C5-9907-45C9-9C6A-5FD3F18FDCEC}"/>
               </a:ext>
             </a:extLst>
           </p:cNvPr>
@@ -6540,7 +6631,7 @@
           <p:cNvPr id="14" name="">
             <a:extLst xmlns:a="http://schemas.openxmlformats.org/drawingml/2006/main">
               <a:ext uri="{FF2B5EF4-FFF2-40B4-BE49-F238E27FC236}">
-                <a16:creationId xmlns:a16="http://schemas.microsoft.com/office/drawing/2014/main" id="{4D9E0FF5-FEBA-46EE-B607-9099E59C8C14}"/>
+                <a16:creationId xmlns:a16="http://schemas.microsoft.com/office/drawing/2014/main" id="{2D54CA0D-02B9-403C-99A9-3A22C454498A}"/>
               </a:ext>
             </a:extLst>
           </p:cNvPr>
@@ -6697,7 +6788,7 @@
           <p:cNvPr id="15" name="sequence-node-2">
             <a:extLst xmlns:a="http://schemas.openxmlformats.org/drawingml/2006/main">
               <a:ext uri="{FF2B5EF4-FFF2-40B4-BE49-F238E27FC236}">
-                <a16:creationId xmlns:a16="http://schemas.microsoft.com/office/drawing/2014/main" id="{4375F762-7E48-45AD-B6E3-E96C802DE262}"/>
+                <a16:creationId xmlns:a16="http://schemas.microsoft.com/office/drawing/2014/main" id="{09724BA3-09CE-4FF1-81F1-ACF185EC71A8}"/>
               </a:ext>
             </a:extLst>
           </p:cNvPr>
@@ -6732,7 +6823,7 @@
           <p:cNvPr id="16" name="">
             <a:extLst xmlns:a="http://schemas.openxmlformats.org/drawingml/2006/main">
               <a:ext uri="{FF2B5EF4-FFF2-40B4-BE49-F238E27FC236}">
-                <a16:creationId xmlns:a16="http://schemas.microsoft.com/office/drawing/2014/main" id="{F5BACA0B-30A0-4FAB-969B-45EBC7E29962}"/>
+                <a16:creationId xmlns:a16="http://schemas.microsoft.com/office/drawing/2014/main" id="{F77884E9-664A-414F-BBEE-8D8967E6FA99}"/>
               </a:ext>
             </a:extLst>
           </p:cNvPr>
@@ -6889,7 +6980,7 @@
           <p:cNvPr id="17" name="">
             <a:extLst xmlns:a="http://schemas.openxmlformats.org/drawingml/2006/main">
               <a:ext uri="{FF2B5EF4-FFF2-40B4-BE49-F238E27FC236}">
-                <a16:creationId xmlns:a16="http://schemas.microsoft.com/office/drawing/2014/main" id="{2A8E52E1-E359-4F95-A49C-FA7447DB488C}"/>
+                <a16:creationId xmlns:a16="http://schemas.microsoft.com/office/drawing/2014/main" id="{BE28A029-3BDC-4C75-9697-930B3EEBEACB}"/>
               </a:ext>
             </a:extLst>
           </p:cNvPr>
@@ -7046,7 +7137,7 @@
           <p:cNvPr id="18" name="">
             <a:extLst xmlns:a="http://schemas.openxmlformats.org/drawingml/2006/main">
               <a:ext uri="{FF2B5EF4-FFF2-40B4-BE49-F238E27FC236}">
-                <a16:creationId xmlns:a16="http://schemas.microsoft.com/office/drawing/2014/main" id="{68A78A08-8731-4CD8-96AB-D1E6660EFBEE}"/>
+                <a16:creationId xmlns:a16="http://schemas.microsoft.com/office/drawing/2014/main" id="{D65CC155-4D73-4717-99FB-F9CD04481425}"/>
               </a:ext>
             </a:extLst>
           </p:cNvPr>
@@ -7203,7 +7294,7 @@
           <p:cNvPr id="19" name="sequence-node-3">
             <a:extLst xmlns:a="http://schemas.openxmlformats.org/drawingml/2006/main">
               <a:ext uri="{FF2B5EF4-FFF2-40B4-BE49-F238E27FC236}">
-                <a16:creationId xmlns:a16="http://schemas.microsoft.com/office/drawing/2014/main" id="{6BB049B8-C2E7-4D5C-AC9C-6810578602F5}"/>
+                <a16:creationId xmlns:a16="http://schemas.microsoft.com/office/drawing/2014/main" id="{821A7FFC-5712-42D9-AA1A-FDAF536B4EE6}"/>
               </a:ext>
             </a:extLst>
           </p:cNvPr>
@@ -7238,7 +7329,7 @@
           <p:cNvPr id="20" name="">
             <a:extLst xmlns:a="http://schemas.openxmlformats.org/drawingml/2006/main">
               <a:ext uri="{FF2B5EF4-FFF2-40B4-BE49-F238E27FC236}">
-                <a16:creationId xmlns:a16="http://schemas.microsoft.com/office/drawing/2014/main" id="{37C1050C-1B94-44E4-8C8F-9594A4B1E572}"/>
+                <a16:creationId xmlns:a16="http://schemas.microsoft.com/office/drawing/2014/main" id="{80D89F84-C585-413E-9C06-664F1591ABA8}"/>
               </a:ext>
             </a:extLst>
           </p:cNvPr>
@@ -7395,7 +7486,7 @@
           <p:cNvPr id="21" name="">
             <a:extLst xmlns:a="http://schemas.openxmlformats.org/drawingml/2006/main">
               <a:ext uri="{FF2B5EF4-FFF2-40B4-BE49-F238E27FC236}">
-                <a16:creationId xmlns:a16="http://schemas.microsoft.com/office/drawing/2014/main" id="{1A256937-EBDA-47FE-A09E-10BE5320A884}"/>
+                <a16:creationId xmlns:a16="http://schemas.microsoft.com/office/drawing/2014/main" id="{100E6C48-18B0-457F-9131-81067ED1DD64}"/>
               </a:ext>
             </a:extLst>
           </p:cNvPr>
@@ -7552,7 +7643,7 @@
           <p:cNvPr id="22" name="">
             <a:extLst xmlns:a="http://schemas.openxmlformats.org/drawingml/2006/main">
               <a:ext uri="{FF2B5EF4-FFF2-40B4-BE49-F238E27FC236}">
-                <a16:creationId xmlns:a16="http://schemas.microsoft.com/office/drawing/2014/main" id="{A7ADA77F-17D2-480B-944E-BA926826468F}"/>
+                <a16:creationId xmlns:a16="http://schemas.microsoft.com/office/drawing/2014/main" id="{20276682-CA23-406C-B057-9608B55ED831}"/>
               </a:ext>
             </a:extLst>
           </p:cNvPr>
@@ -7709,7 +7800,7 @@
           <p:cNvPr id="23" name="sequence-caption">
             <a:extLst xmlns:a="http://schemas.openxmlformats.org/drawingml/2006/main">
               <a:ext uri="{FF2B5EF4-FFF2-40B4-BE49-F238E27FC236}">
-                <a16:creationId xmlns:a16="http://schemas.microsoft.com/office/drawing/2014/main" id="{DA131D2E-E24B-4C8C-9071-0ABAAAB12BBE}"/>
+                <a16:creationId xmlns:a16="http://schemas.microsoft.com/office/drawing/2014/main" id="{9DDA8038-26DE-43FB-BFD0-68BD618FE9FC}"/>
               </a:ext>
             </a:extLst>
           </p:cNvPr>
@@ -7742,7 +7833,7 @@
           <p:cNvPr id="24" name="">
             <a:extLst xmlns:a="http://schemas.openxmlformats.org/drawingml/2006/main">
               <a:ext uri="{FF2B5EF4-FFF2-40B4-BE49-F238E27FC236}">
-                <a16:creationId xmlns:a16="http://schemas.microsoft.com/office/drawing/2014/main" id="{A5697532-1FB0-4498-A23E-0F6FC313A657}"/>
+                <a16:creationId xmlns:a16="http://schemas.microsoft.com/office/drawing/2014/main" id="{5ECB54B2-AC49-4146-8855-A9ABA6E4C0EB}"/>
               </a:ext>
             </a:extLst>
           </p:cNvPr>
@@ -7899,7 +7990,7 @@
           <p:cNvPr id="25" name="">
             <a:extLst xmlns:a="http://schemas.openxmlformats.org/drawingml/2006/main">
               <a:ext uri="{FF2B5EF4-FFF2-40B4-BE49-F238E27FC236}">
-                <a16:creationId xmlns:a16="http://schemas.microsoft.com/office/drawing/2014/main" id="{20190CCC-CDB7-4207-9D2C-339F1C886C96}"/>
+                <a16:creationId xmlns:a16="http://schemas.microsoft.com/office/drawing/2014/main" id="{7818F0E4-8BEB-4D05-9EAE-518CC6ED0AA8}"/>
               </a:ext>
             </a:extLst>
           </p:cNvPr>
@@ -8056,7 +8147,7 @@
           <p:cNvPr id="26" name="">
             <a:extLst xmlns:a="http://schemas.openxmlformats.org/drawingml/2006/main">
               <a:ext uri="{FF2B5EF4-FFF2-40B4-BE49-F238E27FC236}">
-                <a16:creationId xmlns:a16="http://schemas.microsoft.com/office/drawing/2014/main" id="{1B7C1D70-D4BE-4DEB-9ABF-B5C609B9CABA}"/>
+                <a16:creationId xmlns:a16="http://schemas.microsoft.com/office/drawing/2014/main" id="{73D30D44-9849-460B-85C3-8F1ED49CF3FC}"/>
               </a:ext>
             </a:extLst>
           </p:cNvPr>
@@ -8203,7 +8294,7 @@
                 <a:ea typeface="Arial"/>
                 <a:cs typeface="Arial"/>
               </a:rPr>
-              <a:t>ME3 VOICE DUPLEX  •  QWEN TOOL BRAIN  •  2/7</a:t>
+              <a:t>ME3 VOICE DUPLEX  |  QWEN TOOL BRAIN  |  2/8</a:t>
             </a:r>
           </a:p>
         </p:txBody>
@@ -8211,7 +8302,7 @@
     </p:spTree>
     <p:extLst>
       <p:ext uri="{BB962C8B-B14F-4D97-AF65-F5344CB8AC3E}">
-        <p14:creationId xmlns:p14="http://schemas.microsoft.com/office/powerpoint/2010/main" val="1551131809"/>
+        <p14:creationId xmlns:p14="http://schemas.microsoft.com/office/powerpoint/2010/main" val="832531360"/>
       </p:ext>
     </p:extLst>
   </p:cSld>
@@ -8242,7 +8333,7 @@
           <p:cNvPr id="30" name="">
             <a:extLst xmlns:a="http://schemas.openxmlformats.org/drawingml/2006/main">
               <a:ext uri="{FF2B5EF4-FFF2-40B4-BE49-F238E27FC236}">
-                <a16:creationId xmlns:a16="http://schemas.microsoft.com/office/drawing/2014/main" id="{C79D3C56-5108-4617-A73A-827576B2C737}"/>
+                <a16:creationId xmlns:a16="http://schemas.microsoft.com/office/drawing/2014/main" id="{D3DCE6CB-E2E5-463E-B681-0EDF904C0D28}"/>
               </a:ext>
             </a:extLst>
           </p:cNvPr>
@@ -8399,7 +8490,7 @@
           <p:cNvPr id="2" name="">
             <a:extLst xmlns:a="http://schemas.openxmlformats.org/drawingml/2006/main">
               <a:ext uri="{FF2B5EF4-FFF2-40B4-BE49-F238E27FC236}">
-                <a16:creationId xmlns:a16="http://schemas.microsoft.com/office/drawing/2014/main" id="{34C61D5C-2574-434B-8BAA-96821E062F9A}"/>
+                <a16:creationId xmlns:a16="http://schemas.microsoft.com/office/drawing/2014/main" id="{AC2B0F38-B0EE-45A3-8796-48BE51B8931C}"/>
               </a:ext>
             </a:extLst>
           </p:cNvPr>
@@ -8556,7 +8647,7 @@
           <p:cNvPr id="3" name="">
             <a:extLst xmlns:a="http://schemas.openxmlformats.org/drawingml/2006/main">
               <a:ext uri="{FF2B5EF4-FFF2-40B4-BE49-F238E27FC236}">
-                <a16:creationId xmlns:a16="http://schemas.microsoft.com/office/drawing/2014/main" id="{29337D77-DA1E-4B53-9BD6-1D2B4339994E}"/>
+                <a16:creationId xmlns:a16="http://schemas.microsoft.com/office/drawing/2014/main" id="{8DDF70D2-8536-48DC-8DEA-443D12D7AA1A}"/>
               </a:ext>
             </a:extLst>
           </p:cNvPr>
@@ -8713,7 +8804,7 @@
           <p:cNvPr id="4" name="arch-local-to-qwen">
             <a:extLst xmlns:a="http://schemas.openxmlformats.org/drawingml/2006/main">
               <a:ext uri="{FF2B5EF4-FFF2-40B4-BE49-F238E27FC236}">
-                <a16:creationId xmlns:a16="http://schemas.microsoft.com/office/drawing/2014/main" id="{70C0B6A8-51F5-4734-9C8B-8B00E4FF0C78}"/>
+                <a16:creationId xmlns:a16="http://schemas.microsoft.com/office/drawing/2014/main" id="{9EDC2B8D-8B12-4714-BE93-FF244AF8DCB7}"/>
               </a:ext>
             </a:extLst>
           </p:cNvPr>
@@ -8742,7 +8833,7 @@
           <p:cNvPr id="5" name="arch-qwen-to-tools">
             <a:extLst xmlns:a="http://schemas.openxmlformats.org/drawingml/2006/main">
               <a:ext uri="{FF2B5EF4-FFF2-40B4-BE49-F238E27FC236}">
-                <a16:creationId xmlns:a16="http://schemas.microsoft.com/office/drawing/2014/main" id="{10FC8D20-1FBF-4F2F-BDBC-2B179CB4C7C5}"/>
+                <a16:creationId xmlns:a16="http://schemas.microsoft.com/office/drawing/2014/main" id="{03865CB6-A451-4C8C-AB3D-B1BFFF3E7BF6}"/>
               </a:ext>
             </a:extLst>
           </p:cNvPr>
@@ -8771,7 +8862,7 @@
           <p:cNvPr id="6" name="arch-tools-to-response">
             <a:extLst xmlns:a="http://schemas.openxmlformats.org/drawingml/2006/main">
               <a:ext uri="{FF2B5EF4-FFF2-40B4-BE49-F238E27FC236}">
-                <a16:creationId xmlns:a16="http://schemas.microsoft.com/office/drawing/2014/main" id="{94A1A0AB-4CFC-4281-B4E2-154B5BC03E24}"/>
+                <a16:creationId xmlns:a16="http://schemas.microsoft.com/office/drawing/2014/main" id="{30900E2B-5E92-4789-AA7D-345D6B7DB2F9}"/>
               </a:ext>
             </a:extLst>
           </p:cNvPr>
@@ -8800,7 +8891,7 @@
           <p:cNvPr id="7" name="arch-node-0">
             <a:extLst xmlns:a="http://schemas.openxmlformats.org/drawingml/2006/main">
               <a:ext uri="{FF2B5EF4-FFF2-40B4-BE49-F238E27FC236}">
-                <a16:creationId xmlns:a16="http://schemas.microsoft.com/office/drawing/2014/main" id="{A7CE0329-D12F-4678-B08E-875C6E976A72}"/>
+                <a16:creationId xmlns:a16="http://schemas.microsoft.com/office/drawing/2014/main" id="{311EA73C-C6E3-48CA-B072-786B187EAA26}"/>
               </a:ext>
             </a:extLst>
           </p:cNvPr>
@@ -8835,7 +8926,7 @@
           <p:cNvPr id="8" name="arch-accent-0">
             <a:extLst xmlns:a="http://schemas.openxmlformats.org/drawingml/2006/main">
               <a:ext uri="{FF2B5EF4-FFF2-40B4-BE49-F238E27FC236}">
-                <a16:creationId xmlns:a16="http://schemas.microsoft.com/office/drawing/2014/main" id="{FB87CBC9-C9D9-4A6A-84F0-DC2ED5F33ED8}"/>
+                <a16:creationId xmlns:a16="http://schemas.microsoft.com/office/drawing/2014/main" id="{6E62A173-55C8-4B5F-9809-65E2FB156D84}"/>
               </a:ext>
             </a:extLst>
           </p:cNvPr>
@@ -8866,7 +8957,7 @@
           <p:cNvPr id="9" name="">
             <a:extLst xmlns:a="http://schemas.openxmlformats.org/drawingml/2006/main">
               <a:ext uri="{FF2B5EF4-FFF2-40B4-BE49-F238E27FC236}">
-                <a16:creationId xmlns:a16="http://schemas.microsoft.com/office/drawing/2014/main" id="{9F1B30E7-E3C0-42B2-8474-3F0C3A02068C}"/>
+                <a16:creationId xmlns:a16="http://schemas.microsoft.com/office/drawing/2014/main" id="{7276CD42-A3E4-4008-B50C-5AF1587D0E2D}"/>
               </a:ext>
             </a:extLst>
           </p:cNvPr>
@@ -9023,7 +9114,7 @@
           <p:cNvPr id="10" name="">
             <a:extLst xmlns:a="http://schemas.openxmlformats.org/drawingml/2006/main">
               <a:ext uri="{FF2B5EF4-FFF2-40B4-BE49-F238E27FC236}">
-                <a16:creationId xmlns:a16="http://schemas.microsoft.com/office/drawing/2014/main" id="{379B6050-20B8-458B-99E3-76195ADC22E0}"/>
+                <a16:creationId xmlns:a16="http://schemas.microsoft.com/office/drawing/2014/main" id="{A6D0DE36-34B4-411E-9481-2D434B7EAB10}"/>
               </a:ext>
             </a:extLst>
           </p:cNvPr>
@@ -9203,7 +9294,7 @@
           <p:cNvPr id="11" name="">
             <a:extLst xmlns:a="http://schemas.openxmlformats.org/drawingml/2006/main">
               <a:ext uri="{FF2B5EF4-FFF2-40B4-BE49-F238E27FC236}">
-                <a16:creationId xmlns:a16="http://schemas.microsoft.com/office/drawing/2014/main" id="{16724BC7-8E22-4F21-9ED8-3B111534924E}"/>
+                <a16:creationId xmlns:a16="http://schemas.microsoft.com/office/drawing/2014/main" id="{3E8EFA52-6DE4-4F5C-8E62-0CF212550CB6}"/>
               </a:ext>
             </a:extLst>
           </p:cNvPr>
@@ -9360,7 +9451,7 @@
           <p:cNvPr id="12" name="arch-node-1">
             <a:extLst xmlns:a="http://schemas.openxmlformats.org/drawingml/2006/main">
               <a:ext uri="{FF2B5EF4-FFF2-40B4-BE49-F238E27FC236}">
-                <a16:creationId xmlns:a16="http://schemas.microsoft.com/office/drawing/2014/main" id="{987EB10B-714E-418A-B153-5D2B75975ACB}"/>
+                <a16:creationId xmlns:a16="http://schemas.microsoft.com/office/drawing/2014/main" id="{9265C312-6D67-453D-AD23-29F0AEC3A8AF}"/>
               </a:ext>
             </a:extLst>
           </p:cNvPr>
@@ -9395,7 +9486,7 @@
           <p:cNvPr id="13" name="arch-accent-1">
             <a:extLst xmlns:a="http://schemas.openxmlformats.org/drawingml/2006/main">
               <a:ext uri="{FF2B5EF4-FFF2-40B4-BE49-F238E27FC236}">
-                <a16:creationId xmlns:a16="http://schemas.microsoft.com/office/drawing/2014/main" id="{C9D4A287-3B37-4B4D-891B-9985FCC08CB0}"/>
+                <a16:creationId xmlns:a16="http://schemas.microsoft.com/office/drawing/2014/main" id="{828B617B-160C-4D3B-B3C4-53569A4C729A}"/>
               </a:ext>
             </a:extLst>
           </p:cNvPr>
@@ -9426,7 +9517,7 @@
           <p:cNvPr id="14" name="">
             <a:extLst xmlns:a="http://schemas.openxmlformats.org/drawingml/2006/main">
               <a:ext uri="{FF2B5EF4-FFF2-40B4-BE49-F238E27FC236}">
-                <a16:creationId xmlns:a16="http://schemas.microsoft.com/office/drawing/2014/main" id="{5CB38490-09CB-4FC3-91DC-12B98EEF16FB}"/>
+                <a16:creationId xmlns:a16="http://schemas.microsoft.com/office/drawing/2014/main" id="{03688AAB-2BFF-42FC-9A29-3023768BE669}"/>
               </a:ext>
             </a:extLst>
           </p:cNvPr>
@@ -9583,7 +9674,7 @@
           <p:cNvPr id="15" name="">
             <a:extLst xmlns:a="http://schemas.openxmlformats.org/drawingml/2006/main">
               <a:ext uri="{FF2B5EF4-FFF2-40B4-BE49-F238E27FC236}">
-                <a16:creationId xmlns:a16="http://schemas.microsoft.com/office/drawing/2014/main" id="{EE9DC10A-665A-467F-A23B-D05214F62835}"/>
+                <a16:creationId xmlns:a16="http://schemas.microsoft.com/office/drawing/2014/main" id="{C66780DC-0380-4EDE-BC24-D001AE827A05}"/>
               </a:ext>
             </a:extLst>
           </p:cNvPr>
@@ -9763,7 +9854,7 @@
           <p:cNvPr id="16" name="">
             <a:extLst xmlns:a="http://schemas.openxmlformats.org/drawingml/2006/main">
               <a:ext uri="{FF2B5EF4-FFF2-40B4-BE49-F238E27FC236}">
-                <a16:creationId xmlns:a16="http://schemas.microsoft.com/office/drawing/2014/main" id="{B98B6250-617D-48E7-82B6-CF52D32DFAC3}"/>
+                <a16:creationId xmlns:a16="http://schemas.microsoft.com/office/drawing/2014/main" id="{178CF9EA-291A-461A-BAF0-02C408B27FF7}"/>
               </a:ext>
             </a:extLst>
           </p:cNvPr>
@@ -9920,7 +10011,7 @@
           <p:cNvPr id="17" name="arch-node-2">
             <a:extLst xmlns:a="http://schemas.openxmlformats.org/drawingml/2006/main">
               <a:ext uri="{FF2B5EF4-FFF2-40B4-BE49-F238E27FC236}">
-                <a16:creationId xmlns:a16="http://schemas.microsoft.com/office/drawing/2014/main" id="{08011769-A1D9-4C32-9AE2-3164666A9F1A}"/>
+                <a16:creationId xmlns:a16="http://schemas.microsoft.com/office/drawing/2014/main" id="{08F8C807-8D1D-46A8-81B9-CB70570B49CA}"/>
               </a:ext>
             </a:extLst>
           </p:cNvPr>
@@ -9955,7 +10046,7 @@
           <p:cNvPr id="18" name="arch-accent-2">
             <a:extLst xmlns:a="http://schemas.openxmlformats.org/drawingml/2006/main">
               <a:ext uri="{FF2B5EF4-FFF2-40B4-BE49-F238E27FC236}">
-                <a16:creationId xmlns:a16="http://schemas.microsoft.com/office/drawing/2014/main" id="{A394E343-BE23-4B9C-B748-0A316BF6956C}"/>
+                <a16:creationId xmlns:a16="http://schemas.microsoft.com/office/drawing/2014/main" id="{DE7D41FC-6529-4C63-980D-034994E7A90A}"/>
               </a:ext>
             </a:extLst>
           </p:cNvPr>
@@ -9986,7 +10077,7 @@
           <p:cNvPr id="19" name="">
             <a:extLst xmlns:a="http://schemas.openxmlformats.org/drawingml/2006/main">
               <a:ext uri="{FF2B5EF4-FFF2-40B4-BE49-F238E27FC236}">
-                <a16:creationId xmlns:a16="http://schemas.microsoft.com/office/drawing/2014/main" id="{E695C680-ECDB-48AC-B475-D6B26C0AA50C}"/>
+                <a16:creationId xmlns:a16="http://schemas.microsoft.com/office/drawing/2014/main" id="{25F814F6-7F9A-47E5-955F-78F0F8A5EFF0}"/>
               </a:ext>
             </a:extLst>
           </p:cNvPr>
@@ -10143,7 +10234,7 @@
           <p:cNvPr id="20" name="">
             <a:extLst xmlns:a="http://schemas.openxmlformats.org/drawingml/2006/main">
               <a:ext uri="{FF2B5EF4-FFF2-40B4-BE49-F238E27FC236}">
-                <a16:creationId xmlns:a16="http://schemas.microsoft.com/office/drawing/2014/main" id="{B82E05EB-B11D-4042-9243-EB1AEBEEC504}"/>
+                <a16:creationId xmlns:a16="http://schemas.microsoft.com/office/drawing/2014/main" id="{6C3839E6-C476-4E78-84A1-7CD206E03E81}"/>
               </a:ext>
             </a:extLst>
           </p:cNvPr>
@@ -10323,7 +10414,7 @@
           <p:cNvPr id="21" name="">
             <a:extLst xmlns:a="http://schemas.openxmlformats.org/drawingml/2006/main">
               <a:ext uri="{FF2B5EF4-FFF2-40B4-BE49-F238E27FC236}">
-                <a16:creationId xmlns:a16="http://schemas.microsoft.com/office/drawing/2014/main" id="{80FFCDF7-72BA-4C9F-8C9B-744046C80A21}"/>
+                <a16:creationId xmlns:a16="http://schemas.microsoft.com/office/drawing/2014/main" id="{27FF3824-AEF6-4990-82EE-7E8604AB8E5A}"/>
               </a:ext>
             </a:extLst>
           </p:cNvPr>
@@ -10480,7 +10571,7 @@
           <p:cNvPr id="22" name="arch-node-3">
             <a:extLst xmlns:a="http://schemas.openxmlformats.org/drawingml/2006/main">
               <a:ext uri="{FF2B5EF4-FFF2-40B4-BE49-F238E27FC236}">
-                <a16:creationId xmlns:a16="http://schemas.microsoft.com/office/drawing/2014/main" id="{15763A4A-94F1-46B1-BD45-019B2A337E7D}"/>
+                <a16:creationId xmlns:a16="http://schemas.microsoft.com/office/drawing/2014/main" id="{9FEED9AF-BD94-4D13-BB7F-077D37953EED}"/>
               </a:ext>
             </a:extLst>
           </p:cNvPr>
@@ -10515,7 +10606,7 @@
           <p:cNvPr id="23" name="arch-accent-3">
             <a:extLst xmlns:a="http://schemas.openxmlformats.org/drawingml/2006/main">
               <a:ext uri="{FF2B5EF4-FFF2-40B4-BE49-F238E27FC236}">
-                <a16:creationId xmlns:a16="http://schemas.microsoft.com/office/drawing/2014/main" id="{DC39A0C9-3744-4B1B-A313-A8DC8D6503A8}"/>
+                <a16:creationId xmlns:a16="http://schemas.microsoft.com/office/drawing/2014/main" id="{EB043944-5264-418D-83C4-AD9D7B178783}"/>
               </a:ext>
             </a:extLst>
           </p:cNvPr>
@@ -10546,7 +10637,7 @@
           <p:cNvPr id="24" name="">
             <a:extLst xmlns:a="http://schemas.openxmlformats.org/drawingml/2006/main">
               <a:ext uri="{FF2B5EF4-FFF2-40B4-BE49-F238E27FC236}">
-                <a16:creationId xmlns:a16="http://schemas.microsoft.com/office/drawing/2014/main" id="{4A62A247-9F90-462C-B5F0-DB742B060C1B}"/>
+                <a16:creationId xmlns:a16="http://schemas.microsoft.com/office/drawing/2014/main" id="{17D45FFC-9189-426F-A317-B0804A1A9A38}"/>
               </a:ext>
             </a:extLst>
           </p:cNvPr>
@@ -10703,7 +10794,7 @@
           <p:cNvPr id="25" name="">
             <a:extLst xmlns:a="http://schemas.openxmlformats.org/drawingml/2006/main">
               <a:ext uri="{FF2B5EF4-FFF2-40B4-BE49-F238E27FC236}">
-                <a16:creationId xmlns:a16="http://schemas.microsoft.com/office/drawing/2014/main" id="{78A628B6-B826-4511-99C5-32B6749CF9BF}"/>
+                <a16:creationId xmlns:a16="http://schemas.microsoft.com/office/drawing/2014/main" id="{29991436-7D45-43B0-810D-27F7B5992180}"/>
               </a:ext>
             </a:extLst>
           </p:cNvPr>
@@ -10883,7 +10974,7 @@
           <p:cNvPr id="26" name="">
             <a:extLst xmlns:a="http://schemas.openxmlformats.org/drawingml/2006/main">
               <a:ext uri="{FF2B5EF4-FFF2-40B4-BE49-F238E27FC236}">
-                <a16:creationId xmlns:a16="http://schemas.microsoft.com/office/drawing/2014/main" id="{D38E3921-C4FB-4096-88ED-9136F9648552}"/>
+                <a16:creationId xmlns:a16="http://schemas.microsoft.com/office/drawing/2014/main" id="{2EFDB232-F451-4A74-BC79-0D720EAC153D}"/>
               </a:ext>
             </a:extLst>
           </p:cNvPr>
@@ -11040,7 +11131,7 @@
           <p:cNvPr id="27" name="arch-principle">
             <a:extLst xmlns:a="http://schemas.openxmlformats.org/drawingml/2006/main">
               <a:ext uri="{FF2B5EF4-FFF2-40B4-BE49-F238E27FC236}">
-                <a16:creationId xmlns:a16="http://schemas.microsoft.com/office/drawing/2014/main" id="{BC80EDA0-F4C1-4B07-87C1-C826785FB274}"/>
+                <a16:creationId xmlns:a16="http://schemas.microsoft.com/office/drawing/2014/main" id="{B683A5BF-BFB9-42F5-8341-4F901B5A0D0F}"/>
               </a:ext>
             </a:extLst>
           </p:cNvPr>
@@ -11073,7 +11164,7 @@
           <p:cNvPr id="28" name="">
             <a:extLst xmlns:a="http://schemas.openxmlformats.org/drawingml/2006/main">
               <a:ext uri="{FF2B5EF4-FFF2-40B4-BE49-F238E27FC236}">
-                <a16:creationId xmlns:a16="http://schemas.microsoft.com/office/drawing/2014/main" id="{A245DF72-065B-4F86-8FFF-770520C994A7}"/>
+                <a16:creationId xmlns:a16="http://schemas.microsoft.com/office/drawing/2014/main" id="{AC7ACD95-D58D-4C5D-975F-10DC42FD5648}"/>
               </a:ext>
             </a:extLst>
           </p:cNvPr>
@@ -11230,7 +11321,7 @@
           <p:cNvPr id="29" name="">
             <a:extLst xmlns:a="http://schemas.openxmlformats.org/drawingml/2006/main">
               <a:ext uri="{FF2B5EF4-FFF2-40B4-BE49-F238E27FC236}">
-                <a16:creationId xmlns:a16="http://schemas.microsoft.com/office/drawing/2014/main" id="{D20D684B-375A-4AA0-8D88-B7AA9188BE47}"/>
+                <a16:creationId xmlns:a16="http://schemas.microsoft.com/office/drawing/2014/main" id="{E6307FFD-1F91-4C85-A537-44A98F0AA8A0}"/>
               </a:ext>
             </a:extLst>
           </p:cNvPr>
@@ -11377,7 +11468,7 @@
                 <a:ea typeface="Arial"/>
                 <a:cs typeface="Arial"/>
               </a:rPr>
-              <a:t>ME3 VOICE DUPLEX  •  QWEN TOOL BRAIN  •  3/7</a:t>
+              <a:t>ME3 VOICE DUPLEX  |  QWEN TOOL BRAIN  |  3/8</a:t>
             </a:r>
           </a:p>
         </p:txBody>
@@ -11385,7 +11476,7 @@
     </p:spTree>
     <p:extLst>
       <p:ext uri="{BB962C8B-B14F-4D97-AF65-F5344CB8AC3E}">
-        <p14:creationId xmlns:p14="http://schemas.microsoft.com/office/powerpoint/2010/main" val="260135183"/>
+        <p14:creationId xmlns:p14="http://schemas.microsoft.com/office/powerpoint/2010/main" val="1695968070"/>
       </p:ext>
     </p:extLst>
   </p:cSld>
@@ -11416,7 +11507,7 @@
           <p:cNvPr id="19" name="">
             <a:extLst xmlns:a="http://schemas.openxmlformats.org/drawingml/2006/main">
               <a:ext uri="{FF2B5EF4-FFF2-40B4-BE49-F238E27FC236}">
-                <a16:creationId xmlns:a16="http://schemas.microsoft.com/office/drawing/2014/main" id="{5849C03F-975F-4DB9-A96D-3384F2F621E3}"/>
+                <a16:creationId xmlns:a16="http://schemas.microsoft.com/office/drawing/2014/main" id="{DAD6ECB3-F7D1-4218-BEFF-F2757053FE8C}"/>
               </a:ext>
             </a:extLst>
           </p:cNvPr>
@@ -11573,7 +11664,7 @@
           <p:cNvPr id="2" name="">
             <a:extLst xmlns:a="http://schemas.openxmlformats.org/drawingml/2006/main">
               <a:ext uri="{FF2B5EF4-FFF2-40B4-BE49-F238E27FC236}">
-                <a16:creationId xmlns:a16="http://schemas.microsoft.com/office/drawing/2014/main" id="{31A9C638-20E9-4244-98D2-1089697C6248}"/>
+                <a16:creationId xmlns:a16="http://schemas.microsoft.com/office/drawing/2014/main" id="{BCFD26AA-A77B-49B9-8F15-E820BE10AEA4}"/>
               </a:ext>
             </a:extLst>
           </p:cNvPr>
@@ -11730,7 +11821,7 @@
           <p:cNvPr id="3" name="">
             <a:extLst xmlns:a="http://schemas.openxmlformats.org/drawingml/2006/main">
               <a:ext uri="{FF2B5EF4-FFF2-40B4-BE49-F238E27FC236}">
-                <a16:creationId xmlns:a16="http://schemas.microsoft.com/office/drawing/2014/main" id="{94CFA7DD-4B9D-4125-B63D-79A8B4898940}"/>
+                <a16:creationId xmlns:a16="http://schemas.microsoft.com/office/drawing/2014/main" id="{C63C1CA1-13B6-4583-94DE-5AA360E2AE3B}"/>
               </a:ext>
             </a:extLst>
           </p:cNvPr>
@@ -11887,7 +11978,7 @@
           <p:cNvPr id="4" name="webapp-request">
             <a:extLst xmlns:a="http://schemas.openxmlformats.org/drawingml/2006/main">
               <a:ext uri="{FF2B5EF4-FFF2-40B4-BE49-F238E27FC236}">
-                <a16:creationId xmlns:a16="http://schemas.microsoft.com/office/drawing/2014/main" id="{4283C4DD-0BD5-4BBB-85B3-B3DA25BADF2C}"/>
+                <a16:creationId xmlns:a16="http://schemas.microsoft.com/office/drawing/2014/main" id="{3D4BBBCA-852C-4C69-8871-1F92801C4B85}"/>
               </a:ext>
             </a:extLst>
           </p:cNvPr>
@@ -11922,7 +12013,7 @@
           <p:cNvPr id="5" name="">
             <a:extLst xmlns:a="http://schemas.openxmlformats.org/drawingml/2006/main">
               <a:ext uri="{FF2B5EF4-FFF2-40B4-BE49-F238E27FC236}">
-                <a16:creationId xmlns:a16="http://schemas.microsoft.com/office/drawing/2014/main" id="{CCD206D5-AC67-4AE9-AC1F-A3550DF45248}"/>
+                <a16:creationId xmlns:a16="http://schemas.microsoft.com/office/drawing/2014/main" id="{A05D43F1-A433-4C6D-ADC6-6910E8F971CC}"/>
               </a:ext>
             </a:extLst>
           </p:cNvPr>
@@ -12079,7 +12170,7 @@
           <p:cNvPr id="6" name="">
             <a:extLst xmlns:a="http://schemas.openxmlformats.org/drawingml/2006/main">
               <a:ext uri="{FF2B5EF4-FFF2-40B4-BE49-F238E27FC236}">
-                <a16:creationId xmlns:a16="http://schemas.microsoft.com/office/drawing/2014/main" id="{5C77C8E0-A66E-487A-B0C2-D96519AC4AF1}"/>
+                <a16:creationId xmlns:a16="http://schemas.microsoft.com/office/drawing/2014/main" id="{3944B30C-D8D1-4812-ADA7-BF7B1A844C3F}"/>
               </a:ext>
             </a:extLst>
           </p:cNvPr>
@@ -12259,7 +12350,7 @@
           <p:cNvPr id="7" name="">
             <a:extLst xmlns:a="http://schemas.openxmlformats.org/drawingml/2006/main">
               <a:ext uri="{FF2B5EF4-FFF2-40B4-BE49-F238E27FC236}">
-                <a16:creationId xmlns:a16="http://schemas.microsoft.com/office/drawing/2014/main" id="{FDC0B631-2A3B-4C31-AE49-F64DA3C7D6C6}"/>
+                <a16:creationId xmlns:a16="http://schemas.microsoft.com/office/drawing/2014/main" id="{F947E367-27DE-4631-AF6A-87A8E80ACD80}"/>
               </a:ext>
             </a:extLst>
           </p:cNvPr>
@@ -12439,7 +12530,7 @@
           <p:cNvPr id="8" name="webapp-to-calls">
             <a:extLst xmlns:a="http://schemas.openxmlformats.org/drawingml/2006/main">
               <a:ext uri="{FF2B5EF4-FFF2-40B4-BE49-F238E27FC236}">
-                <a16:creationId xmlns:a16="http://schemas.microsoft.com/office/drawing/2014/main" id="{78D81E61-7B48-475D-8F85-5D72FB9EBA1E}"/>
+                <a16:creationId xmlns:a16="http://schemas.microsoft.com/office/drawing/2014/main" id="{9E091065-FEF6-4C0A-989E-E49F862166B1}"/>
               </a:ext>
             </a:extLst>
           </p:cNvPr>
@@ -12468,7 +12559,7 @@
           <p:cNvPr id="9" name="webapp-calls">
             <a:extLst xmlns:a="http://schemas.openxmlformats.org/drawingml/2006/main">
               <a:ext uri="{FF2B5EF4-FFF2-40B4-BE49-F238E27FC236}">
-                <a16:creationId xmlns:a16="http://schemas.microsoft.com/office/drawing/2014/main" id="{C3791684-2AD9-4BEB-BDD6-2BD2F37DFC42}"/>
+                <a16:creationId xmlns:a16="http://schemas.microsoft.com/office/drawing/2014/main" id="{CE045E5B-181F-4129-89FB-EADD771D41E9}"/>
               </a:ext>
             </a:extLst>
           </p:cNvPr>
@@ -12503,7 +12594,7 @@
           <p:cNvPr id="10" name="">
             <a:extLst xmlns:a="http://schemas.openxmlformats.org/drawingml/2006/main">
               <a:ext uri="{FF2B5EF4-FFF2-40B4-BE49-F238E27FC236}">
-                <a16:creationId xmlns:a16="http://schemas.microsoft.com/office/drawing/2014/main" id="{50FB26BB-AB77-41C8-88E7-64DFC26D2791}"/>
+                <a16:creationId xmlns:a16="http://schemas.microsoft.com/office/drawing/2014/main" id="{72E8ED9E-30FA-4216-A9B0-095A85D9A792}"/>
               </a:ext>
             </a:extLst>
           </p:cNvPr>
@@ -12660,7 +12751,7 @@
           <p:cNvPr id="11" name="">
             <a:extLst xmlns:a="http://schemas.openxmlformats.org/drawingml/2006/main">
               <a:ext uri="{FF2B5EF4-FFF2-40B4-BE49-F238E27FC236}">
-                <a16:creationId xmlns:a16="http://schemas.microsoft.com/office/drawing/2014/main" id="{7485EE48-5183-4F12-A88C-0714538E56DD}"/>
+                <a16:creationId xmlns:a16="http://schemas.microsoft.com/office/drawing/2014/main" id="{01DAFCE1-EF93-4615-8220-AE28DAA8F2B5}"/>
               </a:ext>
             </a:extLst>
           </p:cNvPr>
@@ -12886,7 +12977,7 @@
           <p:cNvPr id="12" name="">
             <a:extLst xmlns:a="http://schemas.openxmlformats.org/drawingml/2006/main">
               <a:ext uri="{FF2B5EF4-FFF2-40B4-BE49-F238E27FC236}">
-                <a16:creationId xmlns:a16="http://schemas.microsoft.com/office/drawing/2014/main" id="{59EC38A7-FDBE-44AD-A659-ABBDCE86B23D}"/>
+                <a16:creationId xmlns:a16="http://schemas.microsoft.com/office/drawing/2014/main" id="{F6F27134-D02F-4A47-9869-91398232AB67}"/>
               </a:ext>
             </a:extLst>
           </p:cNvPr>
@@ -13043,7 +13134,7 @@
           <p:cNvPr id="13" name="calls-to-files">
             <a:extLst xmlns:a="http://schemas.openxmlformats.org/drawingml/2006/main">
               <a:ext uri="{FF2B5EF4-FFF2-40B4-BE49-F238E27FC236}">
-                <a16:creationId xmlns:a16="http://schemas.microsoft.com/office/drawing/2014/main" id="{A44539F4-F6E3-4AAD-B472-AC9F7E10C286}"/>
+                <a16:creationId xmlns:a16="http://schemas.microsoft.com/office/drawing/2014/main" id="{703BB0B2-64E2-4073-AB15-2183E17655D0}"/>
               </a:ext>
             </a:extLst>
           </p:cNvPr>
@@ -13072,7 +13163,7 @@
           <p:cNvPr id="14" name="webapp-result">
             <a:extLst xmlns:a="http://schemas.openxmlformats.org/drawingml/2006/main">
               <a:ext uri="{FF2B5EF4-FFF2-40B4-BE49-F238E27FC236}">
-                <a16:creationId xmlns:a16="http://schemas.microsoft.com/office/drawing/2014/main" id="{6ECFD22D-F56F-4190-92EA-239183032809}"/>
+                <a16:creationId xmlns:a16="http://schemas.microsoft.com/office/drawing/2014/main" id="{17A7CC09-9F27-4774-9C7C-017E04CF073B}"/>
               </a:ext>
             </a:extLst>
           </p:cNvPr>
@@ -13107,7 +13198,7 @@
           <p:cNvPr id="15" name="">
             <a:extLst xmlns:a="http://schemas.openxmlformats.org/drawingml/2006/main">
               <a:ext uri="{FF2B5EF4-FFF2-40B4-BE49-F238E27FC236}">
-                <a16:creationId xmlns:a16="http://schemas.microsoft.com/office/drawing/2014/main" id="{96948E2E-6ABA-4811-BF58-B2DD392971C7}"/>
+                <a16:creationId xmlns:a16="http://schemas.microsoft.com/office/drawing/2014/main" id="{77BB1DF7-B97B-4248-A419-370139D53FC2}"/>
               </a:ext>
             </a:extLst>
           </p:cNvPr>
@@ -13264,7 +13355,7 @@
           <p:cNvPr id="16" name="">
             <a:extLst xmlns:a="http://schemas.openxmlformats.org/drawingml/2006/main">
               <a:ext uri="{FF2B5EF4-FFF2-40B4-BE49-F238E27FC236}">
-                <a16:creationId xmlns:a16="http://schemas.microsoft.com/office/drawing/2014/main" id="{394CD221-AACF-4167-8BD1-2305D81C494D}"/>
+                <a16:creationId xmlns:a16="http://schemas.microsoft.com/office/drawing/2014/main" id="{034F5DB3-C83E-436A-9A0F-FB5200A1D394}"/>
               </a:ext>
             </a:extLst>
           </p:cNvPr>
@@ -13513,7 +13604,7 @@
           <p:cNvPr id="17" name="">
             <a:extLst xmlns:a="http://schemas.openxmlformats.org/drawingml/2006/main">
               <a:ext uri="{FF2B5EF4-FFF2-40B4-BE49-F238E27FC236}">
-                <a16:creationId xmlns:a16="http://schemas.microsoft.com/office/drawing/2014/main" id="{4FE6382E-E764-49C5-B6E8-87CEC554F436}"/>
+                <a16:creationId xmlns:a16="http://schemas.microsoft.com/office/drawing/2014/main" id="{0C7D4BF2-0916-4FE2-A06F-55F41585C445}"/>
               </a:ext>
             </a:extLst>
           </p:cNvPr>
@@ -13670,7 +13761,7 @@
           <p:cNvPr id="18" name="">
             <a:extLst xmlns:a="http://schemas.openxmlformats.org/drawingml/2006/main">
               <a:ext uri="{FF2B5EF4-FFF2-40B4-BE49-F238E27FC236}">
-                <a16:creationId xmlns:a16="http://schemas.microsoft.com/office/drawing/2014/main" id="{E0B52CAC-1BD9-4509-B4E3-7B1915FD5A30}"/>
+                <a16:creationId xmlns:a16="http://schemas.microsoft.com/office/drawing/2014/main" id="{672CFD98-BAE0-41F5-914C-4BB11F9C74F0}"/>
               </a:ext>
             </a:extLst>
           </p:cNvPr>
@@ -13817,7 +13908,7 @@
                 <a:ea typeface="Arial"/>
                 <a:cs typeface="Arial"/>
               </a:rPr>
-              <a:t>ME3 VOICE DUPLEX  •  QWEN TOOL BRAIN  •  4/7</a:t>
+              <a:t>ME3 VOICE DUPLEX  |  QWEN TOOL BRAIN  |  4/8</a:t>
             </a:r>
           </a:p>
         </p:txBody>
@@ -13825,7 +13916,7 @@
     </p:spTree>
     <p:extLst>
       <p:ext uri="{BB962C8B-B14F-4D97-AF65-F5344CB8AC3E}">
-        <p14:creationId xmlns:p14="http://schemas.microsoft.com/office/powerpoint/2010/main" val="805051639"/>
+        <p14:creationId xmlns:p14="http://schemas.microsoft.com/office/powerpoint/2010/main" val="563331561"/>
       </p:ext>
     </p:extLst>
   </p:cSld>
@@ -13856,7 +13947,7 @@
           <p:cNvPr id="24" name="">
             <a:extLst xmlns:a="http://schemas.openxmlformats.org/drawingml/2006/main">
               <a:ext uri="{FF2B5EF4-FFF2-40B4-BE49-F238E27FC236}">
-                <a16:creationId xmlns:a16="http://schemas.microsoft.com/office/drawing/2014/main" id="{5494368F-F69C-4433-BAA2-FA5791E9AA8A}"/>
+                <a16:creationId xmlns:a16="http://schemas.microsoft.com/office/drawing/2014/main" id="{85BF20EF-A66E-4FA6-A0B3-7EB3EEF32BFD}"/>
               </a:ext>
             </a:extLst>
           </p:cNvPr>
@@ -14013,7 +14104,7 @@
           <p:cNvPr id="2" name="">
             <a:extLst xmlns:a="http://schemas.openxmlformats.org/drawingml/2006/main">
               <a:ext uri="{FF2B5EF4-FFF2-40B4-BE49-F238E27FC236}">
-                <a16:creationId xmlns:a16="http://schemas.microsoft.com/office/drawing/2014/main" id="{EE88203B-EBBC-49FD-A284-041FAB1135B0}"/>
+                <a16:creationId xmlns:a16="http://schemas.microsoft.com/office/drawing/2014/main" id="{B23FA654-97E5-4487-8FA5-303381E38885}"/>
               </a:ext>
             </a:extLst>
           </p:cNvPr>
@@ -14170,7 +14261,7 @@
           <p:cNvPr id="3" name="">
             <a:extLst xmlns:a="http://schemas.openxmlformats.org/drawingml/2006/main">
               <a:ext uri="{FF2B5EF4-FFF2-40B4-BE49-F238E27FC236}">
-                <a16:creationId xmlns:a16="http://schemas.microsoft.com/office/drawing/2014/main" id="{1C556AC1-7CFE-4D5E-9FD9-A5FD05911E81}"/>
+                <a16:creationId xmlns:a16="http://schemas.microsoft.com/office/drawing/2014/main" id="{734102BF-116D-4A56-B25F-AE6C40FF9615}"/>
               </a:ext>
             </a:extLst>
           </p:cNvPr>
@@ -14327,7 +14418,7 @@
           <p:cNvPr id="4" name="cap-left-0">
             <a:extLst xmlns:a="http://schemas.openxmlformats.org/drawingml/2006/main">
               <a:ext uri="{FF2B5EF4-FFF2-40B4-BE49-F238E27FC236}">
-                <a16:creationId xmlns:a16="http://schemas.microsoft.com/office/drawing/2014/main" id="{8A89428D-B7E4-4F31-A6C1-C70E278EE7D8}"/>
+                <a16:creationId xmlns:a16="http://schemas.microsoft.com/office/drawing/2014/main" id="{7D382DE5-488A-4650-87BF-EC5785867D65}"/>
               </a:ext>
             </a:extLst>
           </p:cNvPr>
@@ -14362,7 +14453,7 @@
           <p:cNvPr id="5" name="">
             <a:extLst xmlns:a="http://schemas.openxmlformats.org/drawingml/2006/main">
               <a:ext uri="{FF2B5EF4-FFF2-40B4-BE49-F238E27FC236}">
-                <a16:creationId xmlns:a16="http://schemas.microsoft.com/office/drawing/2014/main" id="{DD994533-81DF-43B6-825F-8F9A74FC01A8}"/>
+                <a16:creationId xmlns:a16="http://schemas.microsoft.com/office/drawing/2014/main" id="{1E2DE6EA-C0D9-4B32-B3EC-6DD14C6142C2}"/>
               </a:ext>
             </a:extLst>
           </p:cNvPr>
@@ -14519,7 +14610,7 @@
           <p:cNvPr id="6" name="">
             <a:extLst xmlns:a="http://schemas.openxmlformats.org/drawingml/2006/main">
               <a:ext uri="{FF2B5EF4-FFF2-40B4-BE49-F238E27FC236}">
-                <a16:creationId xmlns:a16="http://schemas.microsoft.com/office/drawing/2014/main" id="{53D59345-6B2E-414B-A925-BD5C2F8BEE3F}"/>
+                <a16:creationId xmlns:a16="http://schemas.microsoft.com/office/drawing/2014/main" id="{416132C4-5DDD-4CC4-B218-58925C1E0039}"/>
               </a:ext>
             </a:extLst>
           </p:cNvPr>
@@ -14676,7 +14767,7 @@
           <p:cNvPr id="7" name="cap-left-1">
             <a:extLst xmlns:a="http://schemas.openxmlformats.org/drawingml/2006/main">
               <a:ext uri="{FF2B5EF4-FFF2-40B4-BE49-F238E27FC236}">
-                <a16:creationId xmlns:a16="http://schemas.microsoft.com/office/drawing/2014/main" id="{CB1C8A80-6C20-4889-95F6-D906FEEC8013}"/>
+                <a16:creationId xmlns:a16="http://schemas.microsoft.com/office/drawing/2014/main" id="{1A98E213-FBDB-415C-81DC-56F971D1F2B0}"/>
               </a:ext>
             </a:extLst>
           </p:cNvPr>
@@ -14711,7 +14802,7 @@
           <p:cNvPr id="8" name="">
             <a:extLst xmlns:a="http://schemas.openxmlformats.org/drawingml/2006/main">
               <a:ext uri="{FF2B5EF4-FFF2-40B4-BE49-F238E27FC236}">
-                <a16:creationId xmlns:a16="http://schemas.microsoft.com/office/drawing/2014/main" id="{2D2D9325-2225-485E-87DB-63DE67E901A6}"/>
+                <a16:creationId xmlns:a16="http://schemas.microsoft.com/office/drawing/2014/main" id="{3982E4C2-5112-4A9E-9F62-61029075615B}"/>
               </a:ext>
             </a:extLst>
           </p:cNvPr>
@@ -14868,7 +14959,7 @@
           <p:cNvPr id="9" name="">
             <a:extLst xmlns:a="http://schemas.openxmlformats.org/drawingml/2006/main">
               <a:ext uri="{FF2B5EF4-FFF2-40B4-BE49-F238E27FC236}">
-                <a16:creationId xmlns:a16="http://schemas.microsoft.com/office/drawing/2014/main" id="{B15E5FE9-2EF9-4E52-9317-837144F3C688}"/>
+                <a16:creationId xmlns:a16="http://schemas.microsoft.com/office/drawing/2014/main" id="{56D72BC9-8C6C-44D4-9894-9B8D9D82CFBA}"/>
               </a:ext>
             </a:extLst>
           </p:cNvPr>
@@ -15025,7 +15116,7 @@
           <p:cNvPr id="10" name="cap-left-2">
             <a:extLst xmlns:a="http://schemas.openxmlformats.org/drawingml/2006/main">
               <a:ext uri="{FF2B5EF4-FFF2-40B4-BE49-F238E27FC236}">
-                <a16:creationId xmlns:a16="http://schemas.microsoft.com/office/drawing/2014/main" id="{4C63CE13-7341-41B2-82CD-2D5030DA76B7}"/>
+                <a16:creationId xmlns:a16="http://schemas.microsoft.com/office/drawing/2014/main" id="{7125AA88-74A5-4EF4-9841-1EA1F31AC775}"/>
               </a:ext>
             </a:extLst>
           </p:cNvPr>
@@ -15060,7 +15151,7 @@
           <p:cNvPr id="11" name="">
             <a:extLst xmlns:a="http://schemas.openxmlformats.org/drawingml/2006/main">
               <a:ext uri="{FF2B5EF4-FFF2-40B4-BE49-F238E27FC236}">
-                <a16:creationId xmlns:a16="http://schemas.microsoft.com/office/drawing/2014/main" id="{9BC0CBF6-81FB-4720-909F-35902913CFA3}"/>
+                <a16:creationId xmlns:a16="http://schemas.microsoft.com/office/drawing/2014/main" id="{D7850A80-08CF-463B-9FE9-D8E58D968311}"/>
               </a:ext>
             </a:extLst>
           </p:cNvPr>
@@ -15217,7 +15308,7 @@
           <p:cNvPr id="12" name="">
             <a:extLst xmlns:a="http://schemas.openxmlformats.org/drawingml/2006/main">
               <a:ext uri="{FF2B5EF4-FFF2-40B4-BE49-F238E27FC236}">
-                <a16:creationId xmlns:a16="http://schemas.microsoft.com/office/drawing/2014/main" id="{34A4F802-2D6D-4C5B-86FB-87E07189D9BE}"/>
+                <a16:creationId xmlns:a16="http://schemas.microsoft.com/office/drawing/2014/main" id="{DE5E06FD-0294-4C22-9C50-564A991F7E54}"/>
               </a:ext>
             </a:extLst>
           </p:cNvPr>
@@ -15374,7 +15465,7 @@
           <p:cNvPr id="13" name="cap-left-3">
             <a:extLst xmlns:a="http://schemas.openxmlformats.org/drawingml/2006/main">
               <a:ext uri="{FF2B5EF4-FFF2-40B4-BE49-F238E27FC236}">
-                <a16:creationId xmlns:a16="http://schemas.microsoft.com/office/drawing/2014/main" id="{0D793FC3-46AE-45BA-890A-9135B3D2DD3A}"/>
+                <a16:creationId xmlns:a16="http://schemas.microsoft.com/office/drawing/2014/main" id="{BC1E8E40-DC21-45A8-B92F-E5F7B65950A6}"/>
               </a:ext>
             </a:extLst>
           </p:cNvPr>
@@ -15409,7 +15500,7 @@
           <p:cNvPr id="14" name="">
             <a:extLst xmlns:a="http://schemas.openxmlformats.org/drawingml/2006/main">
               <a:ext uri="{FF2B5EF4-FFF2-40B4-BE49-F238E27FC236}">
-                <a16:creationId xmlns:a16="http://schemas.microsoft.com/office/drawing/2014/main" id="{566560C8-2B14-4CAB-9C5B-B622D7C182B7}"/>
+                <a16:creationId xmlns:a16="http://schemas.microsoft.com/office/drawing/2014/main" id="{79CCEDC3-A09C-474D-8990-BEB526240FEE}"/>
               </a:ext>
             </a:extLst>
           </p:cNvPr>
@@ -15566,7 +15657,7 @@
           <p:cNvPr id="15" name="">
             <a:extLst xmlns:a="http://schemas.openxmlformats.org/drawingml/2006/main">
               <a:ext uri="{FF2B5EF4-FFF2-40B4-BE49-F238E27FC236}">
-                <a16:creationId xmlns:a16="http://schemas.microsoft.com/office/drawing/2014/main" id="{9566E1CF-E99D-4EE3-9B63-03760B832C9F}"/>
+                <a16:creationId xmlns:a16="http://schemas.microsoft.com/office/drawing/2014/main" id="{2D9B2C53-CE50-4341-8260-4162BCC41A27}"/>
               </a:ext>
             </a:extLst>
           </p:cNvPr>
@@ -15723,7 +15814,7 @@
           <p:cNvPr id="16" name="cap-left-4">
             <a:extLst xmlns:a="http://schemas.openxmlformats.org/drawingml/2006/main">
               <a:ext uri="{FF2B5EF4-FFF2-40B4-BE49-F238E27FC236}">
-                <a16:creationId xmlns:a16="http://schemas.microsoft.com/office/drawing/2014/main" id="{48C8036D-5FAB-4A97-9E16-8E23100BA845}"/>
+                <a16:creationId xmlns:a16="http://schemas.microsoft.com/office/drawing/2014/main" id="{5347D3C1-7587-4830-BC5A-444748670864}"/>
               </a:ext>
             </a:extLst>
           </p:cNvPr>
@@ -15758,7 +15849,7 @@
           <p:cNvPr id="17" name="">
             <a:extLst xmlns:a="http://schemas.openxmlformats.org/drawingml/2006/main">
               <a:ext uri="{FF2B5EF4-FFF2-40B4-BE49-F238E27FC236}">
-                <a16:creationId xmlns:a16="http://schemas.microsoft.com/office/drawing/2014/main" id="{CE0E7512-1275-4748-AA53-EC815CB103C6}"/>
+                <a16:creationId xmlns:a16="http://schemas.microsoft.com/office/drawing/2014/main" id="{5EE7296A-4176-46A7-8CAB-5243AA3F6099}"/>
               </a:ext>
             </a:extLst>
           </p:cNvPr>
@@ -15915,7 +16006,7 @@
           <p:cNvPr id="18" name="">
             <a:extLst xmlns:a="http://schemas.openxmlformats.org/drawingml/2006/main">
               <a:ext uri="{FF2B5EF4-FFF2-40B4-BE49-F238E27FC236}">
-                <a16:creationId xmlns:a16="http://schemas.microsoft.com/office/drawing/2014/main" id="{C628E76C-4EEB-432C-AA2E-4C11B6542874}"/>
+                <a16:creationId xmlns:a16="http://schemas.microsoft.com/office/drawing/2014/main" id="{CED73585-DAA2-4EA6-8C47-A8F95D4C4430}"/>
               </a:ext>
             </a:extLst>
           </p:cNvPr>
@@ -16072,7 +16163,7 @@
           <p:cNvPr id="19" name="boundary-callout">
             <a:extLst xmlns:a="http://schemas.openxmlformats.org/drawingml/2006/main">
               <a:ext uri="{FF2B5EF4-FFF2-40B4-BE49-F238E27FC236}">
-                <a16:creationId xmlns:a16="http://schemas.microsoft.com/office/drawing/2014/main" id="{B8DCB37D-9BB6-4916-A814-7C544BF40B1E}"/>
+                <a16:creationId xmlns:a16="http://schemas.microsoft.com/office/drawing/2014/main" id="{C9CD9D66-AFFE-4AEC-ABA1-61EA39260BE7}"/>
               </a:ext>
             </a:extLst>
           </p:cNvPr>
@@ -16107,7 +16198,7 @@
           <p:cNvPr id="20" name="">
             <a:extLst xmlns:a="http://schemas.openxmlformats.org/drawingml/2006/main">
               <a:ext uri="{FF2B5EF4-FFF2-40B4-BE49-F238E27FC236}">
-                <a16:creationId xmlns:a16="http://schemas.microsoft.com/office/drawing/2014/main" id="{ABB9AAB1-AF54-45B2-AC4F-EF53E90D965A}"/>
+                <a16:creationId xmlns:a16="http://schemas.microsoft.com/office/drawing/2014/main" id="{F20AB15B-2DA7-45C5-91D7-151029D407AA}"/>
               </a:ext>
             </a:extLst>
           </p:cNvPr>
@@ -16310,7 +16401,7 @@
           <p:cNvPr id="21" name="">
             <a:extLst xmlns:a="http://schemas.openxmlformats.org/drawingml/2006/main">
               <a:ext uri="{FF2B5EF4-FFF2-40B4-BE49-F238E27FC236}">
-                <a16:creationId xmlns:a16="http://schemas.microsoft.com/office/drawing/2014/main" id="{021DD84F-755F-4559-A9B8-A4E0CCE8AE4D}"/>
+                <a16:creationId xmlns:a16="http://schemas.microsoft.com/office/drawing/2014/main" id="{E3328A9E-7F51-4117-9699-D8740A4202E7}"/>
               </a:ext>
             </a:extLst>
           </p:cNvPr>
@@ -16536,7 +16627,7 @@
           <p:cNvPr id="22" name="">
             <a:extLst xmlns:a="http://schemas.openxmlformats.org/drawingml/2006/main">
               <a:ext uri="{FF2B5EF4-FFF2-40B4-BE49-F238E27FC236}">
-                <a16:creationId xmlns:a16="http://schemas.microsoft.com/office/drawing/2014/main" id="{9E94840E-11AE-407E-BDB0-5E81B5110DE0}"/>
+                <a16:creationId xmlns:a16="http://schemas.microsoft.com/office/drawing/2014/main" id="{38AB70EE-1437-4404-885E-AB5A306054DD}"/>
               </a:ext>
             </a:extLst>
           </p:cNvPr>
@@ -16693,7 +16784,7 @@
           <p:cNvPr id="23" name="">
             <a:extLst xmlns:a="http://schemas.openxmlformats.org/drawingml/2006/main">
               <a:ext uri="{FF2B5EF4-FFF2-40B4-BE49-F238E27FC236}">
-                <a16:creationId xmlns:a16="http://schemas.microsoft.com/office/drawing/2014/main" id="{F976D0CC-5604-446F-BC0F-EAAFAA6D4361}"/>
+                <a16:creationId xmlns:a16="http://schemas.microsoft.com/office/drawing/2014/main" id="{B8C7E3E2-C28D-45A0-8A92-7BD54A3270F0}"/>
               </a:ext>
             </a:extLst>
           </p:cNvPr>
@@ -16840,7 +16931,7 @@
                 <a:ea typeface="Arial"/>
                 <a:cs typeface="Arial"/>
               </a:rPr>
-              <a:t>ME3 VOICE DUPLEX  •  QWEN TOOL BRAIN  •  5/7</a:t>
+              <a:t>ME3 VOICE DUPLEX  |  QWEN TOOL BRAIN  |  5/8</a:t>
             </a:r>
           </a:p>
         </p:txBody>
@@ -16848,7 +16939,7 @@
     </p:spTree>
     <p:extLst>
       <p:ext uri="{BB962C8B-B14F-4D97-AF65-F5344CB8AC3E}">
-        <p14:creationId xmlns:p14="http://schemas.microsoft.com/office/powerpoint/2010/main" val="1831135385"/>
+        <p14:creationId xmlns:p14="http://schemas.microsoft.com/office/powerpoint/2010/main" val="684739544"/>
       </p:ext>
     </p:extLst>
   </p:cSld>
@@ -16879,7 +16970,7 @@
           <p:cNvPr id="18" name="">
             <a:extLst xmlns:a="http://schemas.openxmlformats.org/drawingml/2006/main">
               <a:ext uri="{FF2B5EF4-FFF2-40B4-BE49-F238E27FC236}">
-                <a16:creationId xmlns:a16="http://schemas.microsoft.com/office/drawing/2014/main" id="{321343C7-B562-4CDA-A7AF-11C5664575F5}"/>
+                <a16:creationId xmlns:a16="http://schemas.microsoft.com/office/drawing/2014/main" id="{5916AADC-60C1-47AC-A3EB-8AFDE234A93A}"/>
               </a:ext>
             </a:extLst>
           </p:cNvPr>
@@ -17036,7 +17127,7 @@
           <p:cNvPr id="2" name="">
             <a:extLst xmlns:a="http://schemas.openxmlformats.org/drawingml/2006/main">
               <a:ext uri="{FF2B5EF4-FFF2-40B4-BE49-F238E27FC236}">
-                <a16:creationId xmlns:a16="http://schemas.microsoft.com/office/drawing/2014/main" id="{ED231482-C788-47EC-B346-12D4843A917D}"/>
+                <a16:creationId xmlns:a16="http://schemas.microsoft.com/office/drawing/2014/main" id="{14B86661-33CF-415C-BF84-1DFCC12F5A06}"/>
               </a:ext>
             </a:extLst>
           </p:cNvPr>
@@ -17193,7 +17284,7 @@
           <p:cNvPr id="3" name="">
             <a:extLst xmlns:a="http://schemas.openxmlformats.org/drawingml/2006/main">
               <a:ext uri="{FF2B5EF4-FFF2-40B4-BE49-F238E27FC236}">
-                <a16:creationId xmlns:a16="http://schemas.microsoft.com/office/drawing/2014/main" id="{E77C7522-5CA4-4544-9701-6105A7738564}"/>
+                <a16:creationId xmlns:a16="http://schemas.microsoft.com/office/drawing/2014/main" id="{C24F6020-EC78-4639-B21E-8BB9A8E860E6}"/>
               </a:ext>
             </a:extLst>
           </p:cNvPr>
@@ -17350,7 +17441,7 @@
           <p:cNvPr id="4" name="verified-now">
             <a:extLst xmlns:a="http://schemas.openxmlformats.org/drawingml/2006/main">
               <a:ext uri="{FF2B5EF4-FFF2-40B4-BE49-F238E27FC236}">
-                <a16:creationId xmlns:a16="http://schemas.microsoft.com/office/drawing/2014/main" id="{2B4F63E0-680A-4E7B-9AC9-470BEBF184D7}"/>
+                <a16:creationId xmlns:a16="http://schemas.microsoft.com/office/drawing/2014/main" id="{0D60A09E-1250-48B9-8259-B9EFDE20636F}"/>
               </a:ext>
             </a:extLst>
           </p:cNvPr>
@@ -17385,7 +17476,7 @@
           <p:cNvPr id="5" name="">
             <a:extLst xmlns:a="http://schemas.openxmlformats.org/drawingml/2006/main">
               <a:ext uri="{FF2B5EF4-FFF2-40B4-BE49-F238E27FC236}">
-                <a16:creationId xmlns:a16="http://schemas.microsoft.com/office/drawing/2014/main" id="{C43C17C8-B9B5-4B37-911B-75B8485C084E}"/>
+                <a16:creationId xmlns:a16="http://schemas.microsoft.com/office/drawing/2014/main" id="{1FAD0CCE-4E5A-4664-98AA-CABA0399E4EE}"/>
               </a:ext>
             </a:extLst>
           </p:cNvPr>
@@ -17542,7 +17633,7 @@
           <p:cNvPr id="6" name="">
             <a:extLst xmlns:a="http://schemas.openxmlformats.org/drawingml/2006/main">
               <a:ext uri="{FF2B5EF4-FFF2-40B4-BE49-F238E27FC236}">
-                <a16:creationId xmlns:a16="http://schemas.microsoft.com/office/drawing/2014/main" id="{5F7B9EDA-7500-4565-8515-61334C3C5D78}"/>
+                <a16:creationId xmlns:a16="http://schemas.microsoft.com/office/drawing/2014/main" id="{913336AB-4001-4AA6-819F-CD27F992CA63}"/>
               </a:ext>
             </a:extLst>
           </p:cNvPr>
@@ -17699,7 +17790,7 @@
           <p:cNvPr id="7" name="">
             <a:extLst xmlns:a="http://schemas.openxmlformats.org/drawingml/2006/main">
               <a:ext uri="{FF2B5EF4-FFF2-40B4-BE49-F238E27FC236}">
-                <a16:creationId xmlns:a16="http://schemas.microsoft.com/office/drawing/2014/main" id="{4B8AD622-F11E-457E-98B7-53B89C494743}"/>
+                <a16:creationId xmlns:a16="http://schemas.microsoft.com/office/drawing/2014/main" id="{03498390-96B5-401E-B17C-23BC7FFFAFC5}"/>
               </a:ext>
             </a:extLst>
           </p:cNvPr>
@@ -17856,7 +17947,7 @@
           <p:cNvPr id="8" name="">
             <a:extLst xmlns:a="http://schemas.openxmlformats.org/drawingml/2006/main">
               <a:ext uri="{FF2B5EF4-FFF2-40B4-BE49-F238E27FC236}">
-                <a16:creationId xmlns:a16="http://schemas.microsoft.com/office/drawing/2014/main" id="{C53C7E84-D1AC-4103-87F9-7401C06436F5}"/>
+                <a16:creationId xmlns:a16="http://schemas.microsoft.com/office/drawing/2014/main" id="{91B359A4-846A-42B8-8BF0-7731B2593572}"/>
               </a:ext>
             </a:extLst>
           </p:cNvPr>
@@ -18003,7 +18094,7 @@
                 <a:ea typeface="Arial"/>
                 <a:cs typeface="Arial"/>
               </a:rPr>
-              <a:t>•  Pi text E2E: Qwen built + served a web app, URL LAN-verified</a:t>
+              <a:t>•  Fifine USB capture visible: PortAudio device 0 + ALSA card</a:t>
             </a:r>
           </a:p>
         </p:txBody>
@@ -18013,7 +18104,7 @@
           <p:cNvPr id="9" name="">
             <a:extLst xmlns:a="http://schemas.openxmlformats.org/drawingml/2006/main">
               <a:ext uri="{FF2B5EF4-FFF2-40B4-BE49-F238E27FC236}">
-                <a16:creationId xmlns:a16="http://schemas.microsoft.com/office/drawing/2014/main" id="{0514FF94-E2F3-48F3-89E6-978F6AE53468}"/>
+                <a16:creationId xmlns:a16="http://schemas.microsoft.com/office/drawing/2014/main" id="{47EAE54A-D2D3-4C23-8D29-24567141C220}"/>
               </a:ext>
             </a:extLst>
           </p:cNvPr>
@@ -18160,7 +18251,7 @@
                 <a:ea typeface="Arial"/>
                 <a:cs typeface="Arial"/>
               </a:rPr>
-              <a:t>•  Dev box: Qwen web-app file creation + read-back; 4 tooling tests</a:t>
+              <a:t>•  Voice injection: Qwen called tools and served a web app on the Pi</a:t>
             </a:r>
           </a:p>
         </p:txBody>
@@ -18170,7 +18261,7 @@
           <p:cNvPr id="10" name="">
             <a:extLst xmlns:a="http://schemas.openxmlformats.org/drawingml/2006/main">
               <a:ext uri="{FF2B5EF4-FFF2-40B4-BE49-F238E27FC236}">
-                <a16:creationId xmlns:a16="http://schemas.microsoft.com/office/drawing/2014/main" id="{6E6923F6-A860-4DE8-8627-78DE386E92FD}"/>
+                <a16:creationId xmlns:a16="http://schemas.microsoft.com/office/drawing/2014/main" id="{113E90DB-4566-4ED0-B9BC-3C277EB8366B}"/>
               </a:ext>
             </a:extLst>
           </p:cNvPr>
@@ -18317,7 +18408,7 @@
                 <a:ea typeface="Arial"/>
                 <a:cs typeface="Arial"/>
               </a:rPr>
-              <a:t>•  All 4 MCP services + PortAudio smoke + v1.5 contract checks</a:t>
+              <a:t>•  Split-device path: Pi mic stream -&gt; workstation speaker output</a:t>
             </a:r>
           </a:p>
         </p:txBody>
@@ -18327,7 +18418,7 @@
           <p:cNvPr id="11" name="next-gates">
             <a:extLst xmlns:a="http://schemas.openxmlformats.org/drawingml/2006/main">
               <a:ext uri="{FF2B5EF4-FFF2-40B4-BE49-F238E27FC236}">
-                <a16:creationId xmlns:a16="http://schemas.microsoft.com/office/drawing/2014/main" id="{5F377040-C23E-44B5-9D3D-0EA483DD507C}"/>
+                <a16:creationId xmlns:a16="http://schemas.microsoft.com/office/drawing/2014/main" id="{725D116E-3531-406F-8443-5C80058CD6B7}"/>
               </a:ext>
             </a:extLst>
           </p:cNvPr>
@@ -18362,7 +18453,7 @@
           <p:cNvPr id="12" name="">
             <a:extLst xmlns:a="http://schemas.openxmlformats.org/drawingml/2006/main">
               <a:ext uri="{FF2B5EF4-FFF2-40B4-BE49-F238E27FC236}">
-                <a16:creationId xmlns:a16="http://schemas.microsoft.com/office/drawing/2014/main" id="{951C55E0-AEF4-4CEA-86FE-8A778ECA72D9}"/>
+                <a16:creationId xmlns:a16="http://schemas.microsoft.com/office/drawing/2014/main" id="{FCE6E587-759F-4019-93F9-F0A243F9BF14}"/>
               </a:ext>
             </a:extLst>
           </p:cNvPr>
@@ -18519,7 +18610,7 @@
           <p:cNvPr id="13" name="">
             <a:extLst xmlns:a="http://schemas.openxmlformats.org/drawingml/2006/main">
               <a:ext uri="{FF2B5EF4-FFF2-40B4-BE49-F238E27FC236}">
-                <a16:creationId xmlns:a16="http://schemas.microsoft.com/office/drawing/2014/main" id="{0AE318E2-C0E7-4AF1-8DA1-1BB9739B9D2C}"/>
+                <a16:creationId xmlns:a16="http://schemas.microsoft.com/office/drawing/2014/main" id="{0D47C7E5-8918-47AF-9104-B1763484A229}"/>
               </a:ext>
             </a:extLst>
           </p:cNvPr>
@@ -18666,7 +18757,7 @@
                 <a:ea typeface="Arial"/>
                 <a:cs typeface="Arial"/>
               </a:rPr>
-              <a:t>•  Pi live audio run on installed hardware (0 audio devices now)</a:t>
+              <a:t>•  Physical Pi speaker playback and a human spoken turn</a:t>
             </a:r>
           </a:p>
         </p:txBody>
@@ -18676,7 +18767,7 @@
           <p:cNvPr id="14" name="">
             <a:extLst xmlns:a="http://schemas.openxmlformats.org/drawingml/2006/main">
               <a:ext uri="{FF2B5EF4-FFF2-40B4-BE49-F238E27FC236}">
-                <a16:creationId xmlns:a16="http://schemas.microsoft.com/office/drawing/2014/main" id="{955B1452-34FD-4607-A5B4-C981246BB77D}"/>
+                <a16:creationId xmlns:a16="http://schemas.microsoft.com/office/drawing/2014/main" id="{30FFCB00-B9EF-46F9-8F77-CAD2B04FF117}"/>
               </a:ext>
             </a:extLst>
           </p:cNvPr>
@@ -18823,7 +18914,7 @@
                 <a:ea typeface="Arial"/>
                 <a:cs typeface="Arial"/>
               </a:rPr>
-              <a:t>•  Clean, unaudited FULL-DUPLEX-BENCH v1.5 capture</a:t>
+              <a:t>•  Approved Filipino ElevenLabs key + voice ID for live provider proof</a:t>
             </a:r>
           </a:p>
         </p:txBody>
@@ -18833,7 +18924,7 @@
           <p:cNvPr id="15" name="">
             <a:extLst xmlns:a="http://schemas.openxmlformats.org/drawingml/2006/main">
               <a:ext uri="{FF2B5EF4-FFF2-40B4-BE49-F238E27FC236}">
-                <a16:creationId xmlns:a16="http://schemas.microsoft.com/office/drawing/2014/main" id="{190CB0D8-C1F1-40E2-839A-8FA6022D27DC}"/>
+                <a16:creationId xmlns:a16="http://schemas.microsoft.com/office/drawing/2014/main" id="{1F9BFAA0-D5F7-402F-BBA3-2425CCC2AFF0}"/>
               </a:ext>
             </a:extLst>
           </p:cNvPr>
@@ -18980,7 +19071,7 @@
                 <a:ea typeface="Arial"/>
                 <a:cs typeface="Arial"/>
               </a:rPr>
-              <a:t>•  HTTPS endpoint when an administrator provides one</a:t>
+              <a:t>•  Clean, unaudited FULL-DUPLEX-BENCH v1.5 capture</a:t>
             </a:r>
           </a:p>
         </p:txBody>
@@ -18990,7 +19081,7 @@
           <p:cNvPr id="16" name="">
             <a:extLst xmlns:a="http://schemas.openxmlformats.org/drawingml/2006/main">
               <a:ext uri="{FF2B5EF4-FFF2-40B4-BE49-F238E27FC236}">
-                <a16:creationId xmlns:a16="http://schemas.microsoft.com/office/drawing/2014/main" id="{71FCC0F2-921B-4725-8A6C-6EDFE40B1EA3}"/>
+                <a16:creationId xmlns:a16="http://schemas.microsoft.com/office/drawing/2014/main" id="{5C5AF5B4-B62E-47DB-9917-8B2471B69C59}"/>
               </a:ext>
             </a:extLst>
           </p:cNvPr>
@@ -19147,7 +19238,7 @@
           <p:cNvPr id="17" name="">
             <a:extLst xmlns:a="http://schemas.openxmlformats.org/drawingml/2006/main">
               <a:ext uri="{FF2B5EF4-FFF2-40B4-BE49-F238E27FC236}">
-                <a16:creationId xmlns:a16="http://schemas.microsoft.com/office/drawing/2014/main" id="{407DC0AD-BA28-48DA-9313-8C8FF3B1A859}"/>
+                <a16:creationId xmlns:a16="http://schemas.microsoft.com/office/drawing/2014/main" id="{2D3A3214-8514-4615-93B4-FAF68CFE1AE9}"/>
               </a:ext>
             </a:extLst>
           </p:cNvPr>
@@ -19294,7 +19385,7 @@
                 <a:ea typeface="Arial"/>
                 <a:cs typeface="Arial"/>
               </a:rPr>
-              <a:t>ME3 VOICE DUPLEX  •  QWEN TOOL BRAIN  •  6/7</a:t>
+              <a:t>ME3 VOICE DUPLEX  |  QWEN TOOL BRAIN  |  6/8</a:t>
             </a:r>
           </a:p>
         </p:txBody>
@@ -19302,7 +19393,7 @@
     </p:spTree>
     <p:extLst>
       <p:ext uri="{BB962C8B-B14F-4D97-AF65-F5344CB8AC3E}">
-        <p14:creationId xmlns:p14="http://schemas.microsoft.com/office/powerpoint/2010/main" val="195164306"/>
+        <p14:creationId xmlns:p14="http://schemas.microsoft.com/office/powerpoint/2010/main" val="1644513749"/>
       </p:ext>
     </p:extLst>
   </p:cSld>
@@ -19330,10 +19421,2219 @@
       </p:grpSpPr>
       <p:sp>
         <p:nvSpPr>
+          <p:cNvPr id="16" name="">
+            <a:extLst xmlns:a="http://schemas.openxmlformats.org/drawingml/2006/main">
+              <a:ext uri="{FF2B5EF4-FFF2-40B4-BE49-F238E27FC236}">
+                <a16:creationId xmlns:a16="http://schemas.microsoft.com/office/drawing/2014/main" id="{43FE6AD1-DA9D-4508-BF64-BE39286345B4}"/>
+              </a:ext>
+            </a:extLst>
+          </p:cNvPr>
+          <p:cNvSpPr>
+            <a:spLocks xmlns:a="http://schemas.openxmlformats.org/drawingml/2006/main" noGrp="1"/>
+          </p:cNvSpPr>
+          <p:nvPr/>
+        </p:nvSpPr>
+        <p:spPr>
+          <a:xfrm xmlns:a="http://schemas.openxmlformats.org/drawingml/2006/main">
+            <a:off x="609600" y="400050"/>
+            <a:ext cx="4762500" cy="228600"/>
+          </a:xfrm>
+          <a:prstGeom xmlns:a="http://schemas.openxmlformats.org/drawingml/2006/main" prst="rect">
+            <a:avLst/>
+          </a:prstGeom>
+          <a:noFill xmlns:a="http://schemas.openxmlformats.org/drawingml/2006/main"/>
+          <a:ln xmlns:a="http://schemas.openxmlformats.org/drawingml/2006/main" w="0">
+            <a:noFill/>
+            <a:prstDash val="solid"/>
+          </a:ln>
+        </p:spPr>
+        <p:txBody>
+          <a:bodyPr xmlns:a="http://schemas.openxmlformats.org/drawingml/2006/main"/>
+          <a:lstStyle xmlns:a="http://schemas.openxmlformats.org/drawingml/2006/main">
+            <a:defPPr>
+              <a:defRPr sz="975" b="1">
+                <a:solidFill>
+                  <a:srgbClr val="5EEAD4"/>
+                </a:solidFill>
+                <a:latin typeface="Arial"/>
+                <a:ea typeface="Arial"/>
+                <a:cs typeface="Arial"/>
+              </a:defRPr>
+            </a:defPPr>
+            <a:lvl1pPr>
+              <a:defRPr sz="975" b="1">
+                <a:solidFill>
+                  <a:srgbClr val="5EEAD4"/>
+                </a:solidFill>
+                <a:latin typeface="Arial"/>
+                <a:ea typeface="Arial"/>
+                <a:cs typeface="Arial"/>
+              </a:defRPr>
+            </a:lvl1pPr>
+            <a:lvl2pPr>
+              <a:defRPr sz="975" b="1">
+                <a:solidFill>
+                  <a:srgbClr val="5EEAD4"/>
+                </a:solidFill>
+                <a:latin typeface="Arial"/>
+                <a:ea typeface="Arial"/>
+                <a:cs typeface="Arial"/>
+              </a:defRPr>
+            </a:lvl2pPr>
+            <a:lvl3pPr>
+              <a:defRPr sz="975" b="1">
+                <a:solidFill>
+                  <a:srgbClr val="5EEAD4"/>
+                </a:solidFill>
+                <a:latin typeface="Arial"/>
+                <a:ea typeface="Arial"/>
+                <a:cs typeface="Arial"/>
+              </a:defRPr>
+            </a:lvl3pPr>
+            <a:lvl4pPr>
+              <a:defRPr sz="975" b="1">
+                <a:solidFill>
+                  <a:srgbClr val="5EEAD4"/>
+                </a:solidFill>
+                <a:latin typeface="Arial"/>
+                <a:ea typeface="Arial"/>
+                <a:cs typeface="Arial"/>
+              </a:defRPr>
+            </a:lvl4pPr>
+            <a:lvl5pPr>
+              <a:defRPr sz="975" b="1">
+                <a:solidFill>
+                  <a:srgbClr val="5EEAD4"/>
+                </a:solidFill>
+                <a:latin typeface="Arial"/>
+                <a:ea typeface="Arial"/>
+                <a:cs typeface="Arial"/>
+              </a:defRPr>
+            </a:lvl5pPr>
+            <a:lvl6pPr>
+              <a:defRPr sz="975" b="1">
+                <a:solidFill>
+                  <a:srgbClr val="5EEAD4"/>
+                </a:solidFill>
+                <a:latin typeface="Arial"/>
+                <a:ea typeface="Arial"/>
+                <a:cs typeface="Arial"/>
+              </a:defRPr>
+            </a:lvl6pPr>
+            <a:lvl7pPr>
+              <a:defRPr sz="975" b="1">
+                <a:solidFill>
+                  <a:srgbClr val="5EEAD4"/>
+                </a:solidFill>
+                <a:latin typeface="Arial"/>
+                <a:ea typeface="Arial"/>
+                <a:cs typeface="Arial"/>
+              </a:defRPr>
+            </a:lvl7pPr>
+            <a:lvl8pPr>
+              <a:defRPr sz="975" b="1">
+                <a:solidFill>
+                  <a:srgbClr val="5EEAD4"/>
+                </a:solidFill>
+                <a:latin typeface="Arial"/>
+                <a:ea typeface="Arial"/>
+                <a:cs typeface="Arial"/>
+              </a:defRPr>
+            </a:lvl8pPr>
+            <a:lvl9pPr>
+              <a:defRPr sz="975" b="1">
+                <a:solidFill>
+                  <a:srgbClr val="5EEAD4"/>
+                </a:solidFill>
+                <a:latin typeface="Arial"/>
+                <a:ea typeface="Arial"/>
+                <a:cs typeface="Arial"/>
+              </a:defRPr>
+            </a:lvl9pPr>
+          </a:lstStyle>
+          <a:p xmlns:a="http://schemas.openxmlformats.org/drawingml/2006/main">
+            <a:pPr>
+              <a:defRPr sz="975" b="1">
+                <a:solidFill>
+                  <a:srgbClr val="5EEAD4"/>
+                </a:solidFill>
+                <a:latin typeface="Arial"/>
+                <a:ea typeface="Arial"/>
+                <a:cs typeface="Arial"/>
+              </a:defRPr>
+            </a:pPr>
+            <a:r>
+              <a:rPr sz="975" b="1">
+                <a:solidFill>
+                  <a:srgbClr val="5EEAD4"/>
+                </a:solidFill>
+                <a:latin typeface="Arial"/>
+                <a:ea typeface="Arial"/>
+                <a:cs typeface="Arial"/>
+              </a:rPr>
+              <a:t>MARKET PROFILE</a:t>
+            </a:r>
+          </a:p>
+        </p:txBody>
+      </p:sp>
+      <p:sp>
+        <p:nvSpPr>
+          <p:cNvPr id="2" name="">
+            <a:extLst xmlns:a="http://schemas.openxmlformats.org/drawingml/2006/main">
+              <a:ext uri="{FF2B5EF4-FFF2-40B4-BE49-F238E27FC236}">
+                <a16:creationId xmlns:a16="http://schemas.microsoft.com/office/drawing/2014/main" id="{CD0EDC9D-0606-458A-BF56-3813E37473D1}"/>
+              </a:ext>
+            </a:extLst>
+          </p:cNvPr>
+          <p:cNvSpPr>
+            <a:spLocks xmlns:a="http://schemas.openxmlformats.org/drawingml/2006/main" noGrp="1"/>
+          </p:cNvSpPr>
+          <p:nvPr/>
+        </p:nvSpPr>
+        <p:spPr>
+          <a:xfrm xmlns:a="http://schemas.openxmlformats.org/drawingml/2006/main">
+            <a:off x="609600" y="723900"/>
+            <a:ext cx="10668000" cy="571500"/>
+          </a:xfrm>
+          <a:prstGeom xmlns:a="http://schemas.openxmlformats.org/drawingml/2006/main" prst="rect">
+            <a:avLst/>
+          </a:prstGeom>
+          <a:noFill xmlns:a="http://schemas.openxmlformats.org/drawingml/2006/main"/>
+          <a:ln xmlns:a="http://schemas.openxmlformats.org/drawingml/2006/main" w="0">
+            <a:noFill/>
+            <a:prstDash val="solid"/>
+          </a:ln>
+        </p:spPr>
+        <p:txBody>
+          <a:bodyPr xmlns:a="http://schemas.openxmlformats.org/drawingml/2006/main"/>
+          <a:lstStyle xmlns:a="http://schemas.openxmlformats.org/drawingml/2006/main">
+            <a:defPPr>
+              <a:defRPr sz="2700" b="1">
+                <a:solidFill>
+                  <a:srgbClr val="F7FAFC"/>
+                </a:solidFill>
+                <a:latin typeface="Arial"/>
+                <a:ea typeface="Arial"/>
+                <a:cs typeface="Arial"/>
+              </a:defRPr>
+            </a:defPPr>
+            <a:lvl1pPr>
+              <a:defRPr sz="2700" b="1">
+                <a:solidFill>
+                  <a:srgbClr val="F7FAFC"/>
+                </a:solidFill>
+                <a:latin typeface="Arial"/>
+                <a:ea typeface="Arial"/>
+                <a:cs typeface="Arial"/>
+              </a:defRPr>
+            </a:lvl1pPr>
+            <a:lvl2pPr>
+              <a:defRPr sz="2700" b="1">
+                <a:solidFill>
+                  <a:srgbClr val="F7FAFC"/>
+                </a:solidFill>
+                <a:latin typeface="Arial"/>
+                <a:ea typeface="Arial"/>
+                <a:cs typeface="Arial"/>
+              </a:defRPr>
+            </a:lvl2pPr>
+            <a:lvl3pPr>
+              <a:defRPr sz="2700" b="1">
+                <a:solidFill>
+                  <a:srgbClr val="F7FAFC"/>
+                </a:solidFill>
+                <a:latin typeface="Arial"/>
+                <a:ea typeface="Arial"/>
+                <a:cs typeface="Arial"/>
+              </a:defRPr>
+            </a:lvl3pPr>
+            <a:lvl4pPr>
+              <a:defRPr sz="2700" b="1">
+                <a:solidFill>
+                  <a:srgbClr val="F7FAFC"/>
+                </a:solidFill>
+                <a:latin typeface="Arial"/>
+                <a:ea typeface="Arial"/>
+                <a:cs typeface="Arial"/>
+              </a:defRPr>
+            </a:lvl4pPr>
+            <a:lvl5pPr>
+              <a:defRPr sz="2700" b="1">
+                <a:solidFill>
+                  <a:srgbClr val="F7FAFC"/>
+                </a:solidFill>
+                <a:latin typeface="Arial"/>
+                <a:ea typeface="Arial"/>
+                <a:cs typeface="Arial"/>
+              </a:defRPr>
+            </a:lvl5pPr>
+            <a:lvl6pPr>
+              <a:defRPr sz="2700" b="1">
+                <a:solidFill>
+                  <a:srgbClr val="F7FAFC"/>
+                </a:solidFill>
+                <a:latin typeface="Arial"/>
+                <a:ea typeface="Arial"/>
+                <a:cs typeface="Arial"/>
+              </a:defRPr>
+            </a:lvl6pPr>
+            <a:lvl7pPr>
+              <a:defRPr sz="2700" b="1">
+                <a:solidFill>
+                  <a:srgbClr val="F7FAFC"/>
+                </a:solidFill>
+                <a:latin typeface="Arial"/>
+                <a:ea typeface="Arial"/>
+                <a:cs typeface="Arial"/>
+              </a:defRPr>
+            </a:lvl7pPr>
+            <a:lvl8pPr>
+              <a:defRPr sz="2700" b="1">
+                <a:solidFill>
+                  <a:srgbClr val="F7FAFC"/>
+                </a:solidFill>
+                <a:latin typeface="Arial"/>
+                <a:ea typeface="Arial"/>
+                <a:cs typeface="Arial"/>
+              </a:defRPr>
+            </a:lvl8pPr>
+            <a:lvl9pPr>
+              <a:defRPr sz="2700" b="1">
+                <a:solidFill>
+                  <a:srgbClr val="F7FAFC"/>
+                </a:solidFill>
+                <a:latin typeface="Arial"/>
+                <a:ea typeface="Arial"/>
+                <a:cs typeface="Arial"/>
+              </a:defRPr>
+            </a:lvl9pPr>
+          </a:lstStyle>
+          <a:p xmlns:a="http://schemas.openxmlformats.org/drawingml/2006/main">
+            <a:pPr>
+              <a:defRPr sz="2700" b="1">
+                <a:solidFill>
+                  <a:srgbClr val="F7FAFC"/>
+                </a:solidFill>
+                <a:latin typeface="Arial"/>
+                <a:ea typeface="Arial"/>
+                <a:cs typeface="Arial"/>
+              </a:defRPr>
+            </a:pPr>
+            <a:r>
+              <a:rPr sz="2700" b="1">
+                <a:solidFill>
+                  <a:srgbClr val="F7FAFC"/>
+                </a:solidFill>
+                <a:latin typeface="Arial"/>
+                <a:ea typeface="Arial"/>
+                <a:cs typeface="Arial"/>
+              </a:rPr>
+              <a:t>Filipino voice, Taglish understanding, human handoff</a:t>
+            </a:r>
+          </a:p>
+        </p:txBody>
+      </p:sp>
+      <p:sp>
+        <p:nvSpPr>
+          <p:cNvPr id="3" name="">
+            <a:extLst xmlns:a="http://schemas.openxmlformats.org/drawingml/2006/main">
+              <a:ext uri="{FF2B5EF4-FFF2-40B4-BE49-F238E27FC236}">
+                <a16:creationId xmlns:a16="http://schemas.microsoft.com/office/drawing/2014/main" id="{DA5C69A9-1518-4F3E-A1F5-D75A6644EFC4}"/>
+              </a:ext>
+            </a:extLst>
+          </p:cNvPr>
+          <p:cNvSpPr>
+            <a:spLocks xmlns:a="http://schemas.openxmlformats.org/drawingml/2006/main" noGrp="1"/>
+          </p:cNvSpPr>
+          <p:nvPr/>
+        </p:nvSpPr>
+        <p:spPr>
+          <a:xfrm xmlns:a="http://schemas.openxmlformats.org/drawingml/2006/main">
+            <a:off x="609600" y="1333500"/>
+            <a:ext cx="9906000" cy="342900"/>
+          </a:xfrm>
+          <a:prstGeom xmlns:a="http://schemas.openxmlformats.org/drawingml/2006/main" prst="rect">
+            <a:avLst/>
+          </a:prstGeom>
+          <a:noFill xmlns:a="http://schemas.openxmlformats.org/drawingml/2006/main"/>
+          <a:ln xmlns:a="http://schemas.openxmlformats.org/drawingml/2006/main" w="0">
+            <a:noFill/>
+            <a:prstDash val="solid"/>
+          </a:ln>
+        </p:spPr>
+        <p:txBody>
+          <a:bodyPr xmlns:a="http://schemas.openxmlformats.org/drawingml/2006/main"/>
+          <a:lstStyle xmlns:a="http://schemas.openxmlformats.org/drawingml/2006/main">
+            <a:defPPr>
+              <a:defRPr sz="1425">
+                <a:solidFill>
+                  <a:srgbClr val="A8B8CA"/>
+                </a:solidFill>
+                <a:latin typeface="Arial"/>
+                <a:ea typeface="Arial"/>
+                <a:cs typeface="Arial"/>
+              </a:defRPr>
+            </a:defPPr>
+            <a:lvl1pPr>
+              <a:defRPr sz="1425">
+                <a:solidFill>
+                  <a:srgbClr val="A8B8CA"/>
+                </a:solidFill>
+                <a:latin typeface="Arial"/>
+                <a:ea typeface="Arial"/>
+                <a:cs typeface="Arial"/>
+              </a:defRPr>
+            </a:lvl1pPr>
+            <a:lvl2pPr>
+              <a:defRPr sz="1425">
+                <a:solidFill>
+                  <a:srgbClr val="A8B8CA"/>
+                </a:solidFill>
+                <a:latin typeface="Arial"/>
+                <a:ea typeface="Arial"/>
+                <a:cs typeface="Arial"/>
+              </a:defRPr>
+            </a:lvl2pPr>
+            <a:lvl3pPr>
+              <a:defRPr sz="1425">
+                <a:solidFill>
+                  <a:srgbClr val="A8B8CA"/>
+                </a:solidFill>
+                <a:latin typeface="Arial"/>
+                <a:ea typeface="Arial"/>
+                <a:cs typeface="Arial"/>
+              </a:defRPr>
+            </a:lvl3pPr>
+            <a:lvl4pPr>
+              <a:defRPr sz="1425">
+                <a:solidFill>
+                  <a:srgbClr val="A8B8CA"/>
+                </a:solidFill>
+                <a:latin typeface="Arial"/>
+                <a:ea typeface="Arial"/>
+                <a:cs typeface="Arial"/>
+              </a:defRPr>
+            </a:lvl4pPr>
+            <a:lvl5pPr>
+              <a:defRPr sz="1425">
+                <a:solidFill>
+                  <a:srgbClr val="A8B8CA"/>
+                </a:solidFill>
+                <a:latin typeface="Arial"/>
+                <a:ea typeface="Arial"/>
+                <a:cs typeface="Arial"/>
+              </a:defRPr>
+            </a:lvl5pPr>
+            <a:lvl6pPr>
+              <a:defRPr sz="1425">
+                <a:solidFill>
+                  <a:srgbClr val="A8B8CA"/>
+                </a:solidFill>
+                <a:latin typeface="Arial"/>
+                <a:ea typeface="Arial"/>
+                <a:cs typeface="Arial"/>
+              </a:defRPr>
+            </a:lvl6pPr>
+            <a:lvl7pPr>
+              <a:defRPr sz="1425">
+                <a:solidFill>
+                  <a:srgbClr val="A8B8CA"/>
+                </a:solidFill>
+                <a:latin typeface="Arial"/>
+                <a:ea typeface="Arial"/>
+                <a:cs typeface="Arial"/>
+              </a:defRPr>
+            </a:lvl7pPr>
+            <a:lvl8pPr>
+              <a:defRPr sz="1425">
+                <a:solidFill>
+                  <a:srgbClr val="A8B8CA"/>
+                </a:solidFill>
+                <a:latin typeface="Arial"/>
+                <a:ea typeface="Arial"/>
+                <a:cs typeface="Arial"/>
+              </a:defRPr>
+            </a:lvl8pPr>
+            <a:lvl9pPr>
+              <a:defRPr sz="1425">
+                <a:solidFill>
+                  <a:srgbClr val="A8B8CA"/>
+                </a:solidFill>
+                <a:latin typeface="Arial"/>
+                <a:ea typeface="Arial"/>
+                <a:cs typeface="Arial"/>
+              </a:defRPr>
+            </a:lvl9pPr>
+          </a:lstStyle>
+          <a:p xmlns:a="http://schemas.openxmlformats.org/drawingml/2006/main">
+            <a:pPr>
+              <a:defRPr sz="1425">
+                <a:solidFill>
+                  <a:srgbClr val="A8B8CA"/>
+                </a:solidFill>
+                <a:latin typeface="Arial"/>
+                <a:ea typeface="Arial"/>
+                <a:cs typeface="Arial"/>
+              </a:defRPr>
+            </a:pPr>
+            <a:r>
+              <a:rPr sz="1425">
+                <a:solidFill>
+                  <a:srgbClr val="A8B8CA"/>
+                </a:solidFill>
+                <a:latin typeface="Arial"/>
+                <a:ea typeface="Arial"/>
+                <a:cs typeface="Arial"/>
+              </a:rPr>
+              <a:t>A Philippines customer-support pilot with bounded automation and an explicit escalation path.</a:t>
+            </a:r>
+          </a:p>
+        </p:txBody>
+      </p:sp>
+      <p:sp>
+        <p:nvSpPr>
+          <p:cNvPr id="4" name="ph-language">
+            <a:extLst xmlns:a="http://schemas.openxmlformats.org/drawingml/2006/main">
+              <a:ext uri="{FF2B5EF4-FFF2-40B4-BE49-F238E27FC236}">
+                <a16:creationId xmlns:a16="http://schemas.microsoft.com/office/drawing/2014/main" id="{874ACA08-28F1-4B9D-9108-396CBC83BFF5}"/>
+              </a:ext>
+            </a:extLst>
+          </p:cNvPr>
+          <p:cNvSpPr>
+            <a:spLocks xmlns:a="http://schemas.openxmlformats.org/drawingml/2006/main" noGrp="1"/>
+          </p:cNvSpPr>
+          <p:nvPr/>
+        </p:nvSpPr>
+        <p:spPr>
+          <a:xfrm xmlns:a="http://schemas.openxmlformats.org/drawingml/2006/main">
+            <a:off x="723900" y="2095500"/>
+            <a:ext cx="4953000" cy="2952750"/>
+          </a:xfrm>
+          <a:prstGeom xmlns:a="http://schemas.openxmlformats.org/drawingml/2006/main" prst="roundRect">
+            <a:avLst>
+              <a:gd name="adj" fmla="val 3871"/>
+            </a:avLst>
+          </a:prstGeom>
+          <a:solidFill xmlns:a="http://schemas.openxmlformats.org/drawingml/2006/main">
+            <a:srgbClr val="14324A"/>
+          </a:solidFill>
+          <a:ln xmlns:a="http://schemas.openxmlformats.org/drawingml/2006/main" w="9525">
+            <a:solidFill>
+              <a:srgbClr val="5EEAD4"/>
+            </a:solidFill>
+            <a:prstDash val="solid"/>
+          </a:ln>
+        </p:spPr>
+      </p:sp>
+      <p:sp>
+        <p:nvSpPr>
+          <p:cNvPr id="5" name="">
+            <a:extLst xmlns:a="http://schemas.openxmlformats.org/drawingml/2006/main">
+              <a:ext uri="{FF2B5EF4-FFF2-40B4-BE49-F238E27FC236}">
+                <a16:creationId xmlns:a16="http://schemas.microsoft.com/office/drawing/2014/main" id="{A23FA0FE-EAF8-4D42-AD7C-FA36C8E44028}"/>
+              </a:ext>
+            </a:extLst>
+          </p:cNvPr>
+          <p:cNvSpPr>
+            <a:spLocks xmlns:a="http://schemas.openxmlformats.org/drawingml/2006/main" noGrp="1"/>
+          </p:cNvSpPr>
+          <p:nvPr/>
+        </p:nvSpPr>
+        <p:spPr>
+          <a:xfrm xmlns:a="http://schemas.openxmlformats.org/drawingml/2006/main">
+            <a:off x="1028700" y="2381250"/>
+            <a:ext cx="2857500" cy="228600"/>
+          </a:xfrm>
+          <a:prstGeom xmlns:a="http://schemas.openxmlformats.org/drawingml/2006/main" prst="rect">
+            <a:avLst/>
+          </a:prstGeom>
+          <a:noFill xmlns:a="http://schemas.openxmlformats.org/drawingml/2006/main"/>
+          <a:ln xmlns:a="http://schemas.openxmlformats.org/drawingml/2006/main" w="0">
+            <a:noFill/>
+            <a:prstDash val="solid"/>
+          </a:ln>
+        </p:spPr>
+        <p:txBody>
+          <a:bodyPr xmlns:a="http://schemas.openxmlformats.org/drawingml/2006/main"/>
+          <a:lstStyle xmlns:a="http://schemas.openxmlformats.org/drawingml/2006/main">
+            <a:defPPr>
+              <a:defRPr sz="1050" b="1">
+                <a:solidFill>
+                  <a:srgbClr val="5EEAD4"/>
+                </a:solidFill>
+                <a:latin typeface="Arial"/>
+                <a:ea typeface="Arial"/>
+                <a:cs typeface="Arial"/>
+              </a:defRPr>
+            </a:defPPr>
+            <a:lvl1pPr>
+              <a:defRPr sz="1050" b="1">
+                <a:solidFill>
+                  <a:srgbClr val="5EEAD4"/>
+                </a:solidFill>
+                <a:latin typeface="Arial"/>
+                <a:ea typeface="Arial"/>
+                <a:cs typeface="Arial"/>
+              </a:defRPr>
+            </a:lvl1pPr>
+            <a:lvl2pPr>
+              <a:defRPr sz="1050" b="1">
+                <a:solidFill>
+                  <a:srgbClr val="5EEAD4"/>
+                </a:solidFill>
+                <a:latin typeface="Arial"/>
+                <a:ea typeface="Arial"/>
+                <a:cs typeface="Arial"/>
+              </a:defRPr>
+            </a:lvl2pPr>
+            <a:lvl3pPr>
+              <a:defRPr sz="1050" b="1">
+                <a:solidFill>
+                  <a:srgbClr val="5EEAD4"/>
+                </a:solidFill>
+                <a:latin typeface="Arial"/>
+                <a:ea typeface="Arial"/>
+                <a:cs typeface="Arial"/>
+              </a:defRPr>
+            </a:lvl3pPr>
+            <a:lvl4pPr>
+              <a:defRPr sz="1050" b="1">
+                <a:solidFill>
+                  <a:srgbClr val="5EEAD4"/>
+                </a:solidFill>
+                <a:latin typeface="Arial"/>
+                <a:ea typeface="Arial"/>
+                <a:cs typeface="Arial"/>
+              </a:defRPr>
+            </a:lvl4pPr>
+            <a:lvl5pPr>
+              <a:defRPr sz="1050" b="1">
+                <a:solidFill>
+                  <a:srgbClr val="5EEAD4"/>
+                </a:solidFill>
+                <a:latin typeface="Arial"/>
+                <a:ea typeface="Arial"/>
+                <a:cs typeface="Arial"/>
+              </a:defRPr>
+            </a:lvl5pPr>
+            <a:lvl6pPr>
+              <a:defRPr sz="1050" b="1">
+                <a:solidFill>
+                  <a:srgbClr val="5EEAD4"/>
+                </a:solidFill>
+                <a:latin typeface="Arial"/>
+                <a:ea typeface="Arial"/>
+                <a:cs typeface="Arial"/>
+              </a:defRPr>
+            </a:lvl6pPr>
+            <a:lvl7pPr>
+              <a:defRPr sz="1050" b="1">
+                <a:solidFill>
+                  <a:srgbClr val="5EEAD4"/>
+                </a:solidFill>
+                <a:latin typeface="Arial"/>
+                <a:ea typeface="Arial"/>
+                <a:cs typeface="Arial"/>
+              </a:defRPr>
+            </a:lvl7pPr>
+            <a:lvl8pPr>
+              <a:defRPr sz="1050" b="1">
+                <a:solidFill>
+                  <a:srgbClr val="5EEAD4"/>
+                </a:solidFill>
+                <a:latin typeface="Arial"/>
+                <a:ea typeface="Arial"/>
+                <a:cs typeface="Arial"/>
+              </a:defRPr>
+            </a:lvl8pPr>
+            <a:lvl9pPr>
+              <a:defRPr sz="1050" b="1">
+                <a:solidFill>
+                  <a:srgbClr val="5EEAD4"/>
+                </a:solidFill>
+                <a:latin typeface="Arial"/>
+                <a:ea typeface="Arial"/>
+                <a:cs typeface="Arial"/>
+              </a:defRPr>
+            </a:lvl9pPr>
+          </a:lstStyle>
+          <a:p xmlns:a="http://schemas.openxmlformats.org/drawingml/2006/main">
+            <a:pPr>
+              <a:defRPr sz="1050" b="1">
+                <a:solidFill>
+                  <a:srgbClr val="5EEAD4"/>
+                </a:solidFill>
+                <a:latin typeface="Arial"/>
+                <a:ea typeface="Arial"/>
+                <a:cs typeface="Arial"/>
+              </a:defRPr>
+            </a:pPr>
+            <a:r>
+              <a:rPr sz="1050" b="1">
+                <a:solidFill>
+                  <a:srgbClr val="5EEAD4"/>
+                </a:solidFill>
+                <a:latin typeface="Arial"/>
+                <a:ea typeface="Arial"/>
+                <a:cs typeface="Arial"/>
+              </a:rPr>
+              <a:t>LANGUAGE + VOICE</a:t>
+            </a:r>
+          </a:p>
+        </p:txBody>
+      </p:sp>
+      <p:sp>
+        <p:nvSpPr>
+          <p:cNvPr id="6" name="">
+            <a:extLst xmlns:a="http://schemas.openxmlformats.org/drawingml/2006/main">
+              <a:ext uri="{FF2B5EF4-FFF2-40B4-BE49-F238E27FC236}">
+                <a16:creationId xmlns:a16="http://schemas.microsoft.com/office/drawing/2014/main" id="{12854375-0F86-495F-94DC-4B114B0B5A87}"/>
+              </a:ext>
+            </a:extLst>
+          </p:cNvPr>
+          <p:cNvSpPr>
+            <a:spLocks xmlns:a="http://schemas.openxmlformats.org/drawingml/2006/main" noGrp="1"/>
+          </p:cNvSpPr>
+          <p:nvPr/>
+        </p:nvSpPr>
+        <p:spPr>
+          <a:xfrm xmlns:a="http://schemas.openxmlformats.org/drawingml/2006/main">
+            <a:off x="1028700" y="2857500"/>
+            <a:ext cx="3905250" cy="1066800"/>
+          </a:xfrm>
+          <a:prstGeom xmlns:a="http://schemas.openxmlformats.org/drawingml/2006/main" prst="rect">
+            <a:avLst/>
+          </a:prstGeom>
+          <a:noFill xmlns:a="http://schemas.openxmlformats.org/drawingml/2006/main"/>
+          <a:ln xmlns:a="http://schemas.openxmlformats.org/drawingml/2006/main" w="0">
+            <a:noFill/>
+            <a:prstDash val="solid"/>
+          </a:ln>
+        </p:spPr>
+        <p:txBody>
+          <a:bodyPr xmlns:a="http://schemas.openxmlformats.org/drawingml/2006/main"/>
+          <a:lstStyle xmlns:a="http://schemas.openxmlformats.org/drawingml/2006/main">
+            <a:defPPr>
+              <a:defRPr sz="2025" b="1">
+                <a:solidFill>
+                  <a:srgbClr val="F7FAFC"/>
+                </a:solidFill>
+                <a:latin typeface="Arial"/>
+                <a:ea typeface="Arial"/>
+                <a:cs typeface="Arial"/>
+              </a:defRPr>
+            </a:defPPr>
+            <a:lvl1pPr>
+              <a:defRPr sz="2025" b="1">
+                <a:solidFill>
+                  <a:srgbClr val="F7FAFC"/>
+                </a:solidFill>
+                <a:latin typeface="Arial"/>
+                <a:ea typeface="Arial"/>
+                <a:cs typeface="Arial"/>
+              </a:defRPr>
+            </a:lvl1pPr>
+            <a:lvl2pPr>
+              <a:defRPr sz="2025" b="1">
+                <a:solidFill>
+                  <a:srgbClr val="F7FAFC"/>
+                </a:solidFill>
+                <a:latin typeface="Arial"/>
+                <a:ea typeface="Arial"/>
+                <a:cs typeface="Arial"/>
+              </a:defRPr>
+            </a:lvl2pPr>
+            <a:lvl3pPr>
+              <a:defRPr sz="2025" b="1">
+                <a:solidFill>
+                  <a:srgbClr val="F7FAFC"/>
+                </a:solidFill>
+                <a:latin typeface="Arial"/>
+                <a:ea typeface="Arial"/>
+                <a:cs typeface="Arial"/>
+              </a:defRPr>
+            </a:lvl3pPr>
+            <a:lvl4pPr>
+              <a:defRPr sz="2025" b="1">
+                <a:solidFill>
+                  <a:srgbClr val="F7FAFC"/>
+                </a:solidFill>
+                <a:latin typeface="Arial"/>
+                <a:ea typeface="Arial"/>
+                <a:cs typeface="Arial"/>
+              </a:defRPr>
+            </a:lvl4pPr>
+            <a:lvl5pPr>
+              <a:defRPr sz="2025" b="1">
+                <a:solidFill>
+                  <a:srgbClr val="F7FAFC"/>
+                </a:solidFill>
+                <a:latin typeface="Arial"/>
+                <a:ea typeface="Arial"/>
+                <a:cs typeface="Arial"/>
+              </a:defRPr>
+            </a:lvl5pPr>
+            <a:lvl6pPr>
+              <a:defRPr sz="2025" b="1">
+                <a:solidFill>
+                  <a:srgbClr val="F7FAFC"/>
+                </a:solidFill>
+                <a:latin typeface="Arial"/>
+                <a:ea typeface="Arial"/>
+                <a:cs typeface="Arial"/>
+              </a:defRPr>
+            </a:lvl6pPr>
+            <a:lvl7pPr>
+              <a:defRPr sz="2025" b="1">
+                <a:solidFill>
+                  <a:srgbClr val="F7FAFC"/>
+                </a:solidFill>
+                <a:latin typeface="Arial"/>
+                <a:ea typeface="Arial"/>
+                <a:cs typeface="Arial"/>
+              </a:defRPr>
+            </a:lvl7pPr>
+            <a:lvl8pPr>
+              <a:defRPr sz="2025" b="1">
+                <a:solidFill>
+                  <a:srgbClr val="F7FAFC"/>
+                </a:solidFill>
+                <a:latin typeface="Arial"/>
+                <a:ea typeface="Arial"/>
+                <a:cs typeface="Arial"/>
+              </a:defRPr>
+            </a:lvl8pPr>
+            <a:lvl9pPr>
+              <a:defRPr sz="2025" b="1">
+                <a:solidFill>
+                  <a:srgbClr val="F7FAFC"/>
+                </a:solidFill>
+                <a:latin typeface="Arial"/>
+                <a:ea typeface="Arial"/>
+                <a:cs typeface="Arial"/>
+              </a:defRPr>
+            </a:lvl9pPr>
+          </a:lstStyle>
+          <a:p xmlns:a="http://schemas.openxmlformats.org/drawingml/2006/main">
+            <a:pPr>
+              <a:defRPr sz="2025" b="1">
+                <a:solidFill>
+                  <a:srgbClr val="F7FAFC"/>
+                </a:solidFill>
+                <a:latin typeface="Arial"/>
+                <a:ea typeface="Arial"/>
+                <a:cs typeface="Arial"/>
+              </a:defRPr>
+            </a:pPr>
+            <a:r>
+              <a:rPr sz="2025" b="1">
+                <a:solidFill>
+                  <a:srgbClr val="F7FAFC"/>
+                </a:solidFill>
+                <a:latin typeface="Arial"/>
+                <a:ea typeface="Arial"/>
+                <a:cs typeface="Arial"/>
+              </a:rPr>
+              <a:t>fil-PH</a:t>
+            </a:r>
+          </a:p>
+          <a:p xmlns:a="http://schemas.openxmlformats.org/drawingml/2006/main">
+            <a:pPr>
+              <a:defRPr sz="2025" b="1">
+                <a:solidFill>
+                  <a:srgbClr val="F7FAFC"/>
+                </a:solidFill>
+                <a:latin typeface="Arial"/>
+                <a:ea typeface="Arial"/>
+                <a:cs typeface="Arial"/>
+              </a:defRPr>
+            </a:pPr>
+            <a:r>
+              <a:rPr sz="2025" b="1">
+                <a:solidFill>
+                  <a:srgbClr val="F7FAFC"/>
+                </a:solidFill>
+                <a:latin typeface="Arial"/>
+                <a:ea typeface="Arial"/>
+                <a:cs typeface="Arial"/>
+              </a:rPr>
+              <a:t>Filipino by default</a:t>
+            </a:r>
+          </a:p>
+          <a:p xmlns:a="http://schemas.openxmlformats.org/drawingml/2006/main">
+            <a:pPr>
+              <a:defRPr sz="2025" b="1">
+                <a:solidFill>
+                  <a:srgbClr val="F7FAFC"/>
+                </a:solidFill>
+                <a:latin typeface="Arial"/>
+                <a:ea typeface="Arial"/>
+                <a:cs typeface="Arial"/>
+              </a:defRPr>
+            </a:pPr>
+            <a:r>
+              <a:rPr sz="2025" b="1">
+                <a:solidFill>
+                  <a:srgbClr val="F7FAFC"/>
+                </a:solidFill>
+                <a:latin typeface="Arial"/>
+                <a:ea typeface="Arial"/>
+                <a:cs typeface="Arial"/>
+              </a:rPr>
+              <a:t>English + Taglish understood</a:t>
+            </a:r>
+          </a:p>
+        </p:txBody>
+      </p:sp>
+      <p:sp>
+        <p:nvSpPr>
+          <p:cNvPr id="7" name="">
+            <a:extLst xmlns:a="http://schemas.openxmlformats.org/drawingml/2006/main">
+              <a:ext uri="{FF2B5EF4-FFF2-40B4-BE49-F238E27FC236}">
+                <a16:creationId xmlns:a16="http://schemas.microsoft.com/office/drawing/2014/main" id="{7825C530-AD11-494C-8C22-651ACB44373C}"/>
+              </a:ext>
+            </a:extLst>
+          </p:cNvPr>
+          <p:cNvSpPr>
+            <a:spLocks xmlns:a="http://schemas.openxmlformats.org/drawingml/2006/main" noGrp="1"/>
+          </p:cNvSpPr>
+          <p:nvPr/>
+        </p:nvSpPr>
+        <p:spPr>
+          <a:xfrm xmlns:a="http://schemas.openxmlformats.org/drawingml/2006/main">
+            <a:off x="1028700" y="4286250"/>
+            <a:ext cx="4095750" cy="438150"/>
+          </a:xfrm>
+          <a:prstGeom xmlns:a="http://schemas.openxmlformats.org/drawingml/2006/main" prst="rect">
+            <a:avLst/>
+          </a:prstGeom>
+          <a:noFill xmlns:a="http://schemas.openxmlformats.org/drawingml/2006/main"/>
+          <a:ln xmlns:a="http://schemas.openxmlformats.org/drawingml/2006/main" w="0">
+            <a:noFill/>
+            <a:prstDash val="solid"/>
+          </a:ln>
+        </p:spPr>
+        <p:txBody>
+          <a:bodyPr xmlns:a="http://schemas.openxmlformats.org/drawingml/2006/main"/>
+          <a:lstStyle xmlns:a="http://schemas.openxmlformats.org/drawingml/2006/main">
+            <a:defPPr>
+              <a:defRPr sz="1200">
+                <a:solidFill>
+                  <a:srgbClr val="A8B8CA"/>
+                </a:solidFill>
+                <a:latin typeface="Arial"/>
+                <a:ea typeface="Arial"/>
+                <a:cs typeface="Arial"/>
+              </a:defRPr>
+            </a:defPPr>
+            <a:lvl1pPr>
+              <a:defRPr sz="1200">
+                <a:solidFill>
+                  <a:srgbClr val="A8B8CA"/>
+                </a:solidFill>
+                <a:latin typeface="Arial"/>
+                <a:ea typeface="Arial"/>
+                <a:cs typeface="Arial"/>
+              </a:defRPr>
+            </a:lvl1pPr>
+            <a:lvl2pPr>
+              <a:defRPr sz="1200">
+                <a:solidFill>
+                  <a:srgbClr val="A8B8CA"/>
+                </a:solidFill>
+                <a:latin typeface="Arial"/>
+                <a:ea typeface="Arial"/>
+                <a:cs typeface="Arial"/>
+              </a:defRPr>
+            </a:lvl2pPr>
+            <a:lvl3pPr>
+              <a:defRPr sz="1200">
+                <a:solidFill>
+                  <a:srgbClr val="A8B8CA"/>
+                </a:solidFill>
+                <a:latin typeface="Arial"/>
+                <a:ea typeface="Arial"/>
+                <a:cs typeface="Arial"/>
+              </a:defRPr>
+            </a:lvl3pPr>
+            <a:lvl4pPr>
+              <a:defRPr sz="1200">
+                <a:solidFill>
+                  <a:srgbClr val="A8B8CA"/>
+                </a:solidFill>
+                <a:latin typeface="Arial"/>
+                <a:ea typeface="Arial"/>
+                <a:cs typeface="Arial"/>
+              </a:defRPr>
+            </a:lvl4pPr>
+            <a:lvl5pPr>
+              <a:defRPr sz="1200">
+                <a:solidFill>
+                  <a:srgbClr val="A8B8CA"/>
+                </a:solidFill>
+                <a:latin typeface="Arial"/>
+                <a:ea typeface="Arial"/>
+                <a:cs typeface="Arial"/>
+              </a:defRPr>
+            </a:lvl5pPr>
+            <a:lvl6pPr>
+              <a:defRPr sz="1200">
+                <a:solidFill>
+                  <a:srgbClr val="A8B8CA"/>
+                </a:solidFill>
+                <a:latin typeface="Arial"/>
+                <a:ea typeface="Arial"/>
+                <a:cs typeface="Arial"/>
+              </a:defRPr>
+            </a:lvl6pPr>
+            <a:lvl7pPr>
+              <a:defRPr sz="1200">
+                <a:solidFill>
+                  <a:srgbClr val="A8B8CA"/>
+                </a:solidFill>
+                <a:latin typeface="Arial"/>
+                <a:ea typeface="Arial"/>
+                <a:cs typeface="Arial"/>
+              </a:defRPr>
+            </a:lvl7pPr>
+            <a:lvl8pPr>
+              <a:defRPr sz="1200">
+                <a:solidFill>
+                  <a:srgbClr val="A8B8CA"/>
+                </a:solidFill>
+                <a:latin typeface="Arial"/>
+                <a:ea typeface="Arial"/>
+                <a:cs typeface="Arial"/>
+              </a:defRPr>
+            </a:lvl8pPr>
+            <a:lvl9pPr>
+              <a:defRPr sz="1200">
+                <a:solidFill>
+                  <a:srgbClr val="A8B8CA"/>
+                </a:solidFill>
+                <a:latin typeface="Arial"/>
+                <a:ea typeface="Arial"/>
+                <a:cs typeface="Arial"/>
+              </a:defRPr>
+            </a:lvl9pPr>
+          </a:lstStyle>
+          <a:p xmlns:a="http://schemas.openxmlformats.org/drawingml/2006/main">
+            <a:pPr>
+              <a:defRPr sz="1200">
+                <a:solidFill>
+                  <a:srgbClr val="A8B8CA"/>
+                </a:solidFill>
+                <a:latin typeface="Arial"/>
+                <a:ea typeface="Arial"/>
+                <a:cs typeface="Arial"/>
+              </a:defRPr>
+            </a:pPr>
+            <a:r>
+              <a:rPr sz="1200">
+                <a:solidFill>
+                  <a:srgbClr val="A8B8CA"/>
+                </a:solidFill>
+                <a:latin typeface="Arial"/>
+                <a:ea typeface="Arial"/>
+                <a:cs typeface="Arial"/>
+              </a:rPr>
+              <a:t>ElevenLabs Flash v2.5 + language_code=fil</a:t>
+            </a:r>
+          </a:p>
+          <a:p xmlns:a="http://schemas.openxmlformats.org/drawingml/2006/main">
+            <a:pPr>
+              <a:defRPr sz="1200">
+                <a:solidFill>
+                  <a:srgbClr val="A8B8CA"/>
+                </a:solidFill>
+                <a:latin typeface="Arial"/>
+                <a:ea typeface="Arial"/>
+                <a:cs typeface="Arial"/>
+              </a:defRPr>
+            </a:pPr>
+            <a:r>
+              <a:rPr sz="1200">
+                <a:solidFill>
+                  <a:srgbClr val="A8B8CA"/>
+                </a:solidFill>
+                <a:latin typeface="Arial"/>
+                <a:ea typeface="Arial"/>
+                <a:cs typeface="Arial"/>
+              </a:rPr>
+              <a:t>Voice ID stays in the protected operator environment.</a:t>
+            </a:r>
+          </a:p>
+        </p:txBody>
+      </p:sp>
+      <p:sp>
+        <p:nvSpPr>
+          <p:cNvPr id="8" name="ph-boundary">
+            <a:extLst xmlns:a="http://schemas.openxmlformats.org/drawingml/2006/main">
+              <a:ext uri="{FF2B5EF4-FFF2-40B4-BE49-F238E27FC236}">
+                <a16:creationId xmlns:a16="http://schemas.microsoft.com/office/drawing/2014/main" id="{64B8ABEB-AF96-4D80-B4E7-ADA60BA49EB0}"/>
+              </a:ext>
+            </a:extLst>
+          </p:cNvPr>
+          <p:cNvSpPr>
+            <a:spLocks xmlns:a="http://schemas.openxmlformats.org/drawingml/2006/main" noGrp="1"/>
+          </p:cNvSpPr>
+          <p:nvPr/>
+        </p:nvSpPr>
+        <p:spPr>
+          <a:xfrm xmlns:a="http://schemas.openxmlformats.org/drawingml/2006/main">
+            <a:off x="6191250" y="2095500"/>
+            <a:ext cx="5276850" cy="2952750"/>
+          </a:xfrm>
+          <a:prstGeom xmlns:a="http://schemas.openxmlformats.org/drawingml/2006/main" prst="roundRect">
+            <a:avLst>
+              <a:gd name="adj" fmla="val 3871"/>
+            </a:avLst>
+          </a:prstGeom>
+          <a:solidFill xmlns:a="http://schemas.openxmlformats.org/drawingml/2006/main">
+            <a:srgbClr val="14324A"/>
+          </a:solidFill>
+          <a:ln xmlns:a="http://schemas.openxmlformats.org/drawingml/2006/main" w="9525">
+            <a:solidFill>
+              <a:srgbClr val="FCD34D"/>
+            </a:solidFill>
+            <a:prstDash val="solid"/>
+          </a:ln>
+        </p:spPr>
+      </p:sp>
+      <p:sp>
+        <p:nvSpPr>
+          <p:cNvPr id="9" name="">
+            <a:extLst xmlns:a="http://schemas.openxmlformats.org/drawingml/2006/main">
+              <a:ext uri="{FF2B5EF4-FFF2-40B4-BE49-F238E27FC236}">
+                <a16:creationId xmlns:a16="http://schemas.microsoft.com/office/drawing/2014/main" id="{08425C39-A0E0-44D6-B5DB-20ED276BD0A7}"/>
+              </a:ext>
+            </a:extLst>
+          </p:cNvPr>
+          <p:cNvSpPr>
+            <a:spLocks xmlns:a="http://schemas.openxmlformats.org/drawingml/2006/main" noGrp="1"/>
+          </p:cNvSpPr>
+          <p:nvPr/>
+        </p:nvSpPr>
+        <p:spPr>
+          <a:xfrm xmlns:a="http://schemas.openxmlformats.org/drawingml/2006/main">
+            <a:off x="6496050" y="2381250"/>
+            <a:ext cx="2857500" cy="228600"/>
+          </a:xfrm>
+          <a:prstGeom xmlns:a="http://schemas.openxmlformats.org/drawingml/2006/main" prst="rect">
+            <a:avLst/>
+          </a:prstGeom>
+          <a:noFill xmlns:a="http://schemas.openxmlformats.org/drawingml/2006/main"/>
+          <a:ln xmlns:a="http://schemas.openxmlformats.org/drawingml/2006/main" w="0">
+            <a:noFill/>
+            <a:prstDash val="solid"/>
+          </a:ln>
+        </p:spPr>
+        <p:txBody>
+          <a:bodyPr xmlns:a="http://schemas.openxmlformats.org/drawingml/2006/main"/>
+          <a:lstStyle xmlns:a="http://schemas.openxmlformats.org/drawingml/2006/main">
+            <a:defPPr>
+              <a:defRPr sz="1050" b="1">
+                <a:solidFill>
+                  <a:srgbClr val="FCD34D"/>
+                </a:solidFill>
+                <a:latin typeface="Arial"/>
+                <a:ea typeface="Arial"/>
+                <a:cs typeface="Arial"/>
+              </a:defRPr>
+            </a:defPPr>
+            <a:lvl1pPr>
+              <a:defRPr sz="1050" b="1">
+                <a:solidFill>
+                  <a:srgbClr val="FCD34D"/>
+                </a:solidFill>
+                <a:latin typeface="Arial"/>
+                <a:ea typeface="Arial"/>
+                <a:cs typeface="Arial"/>
+              </a:defRPr>
+            </a:lvl1pPr>
+            <a:lvl2pPr>
+              <a:defRPr sz="1050" b="1">
+                <a:solidFill>
+                  <a:srgbClr val="FCD34D"/>
+                </a:solidFill>
+                <a:latin typeface="Arial"/>
+                <a:ea typeface="Arial"/>
+                <a:cs typeface="Arial"/>
+              </a:defRPr>
+            </a:lvl2pPr>
+            <a:lvl3pPr>
+              <a:defRPr sz="1050" b="1">
+                <a:solidFill>
+                  <a:srgbClr val="FCD34D"/>
+                </a:solidFill>
+                <a:latin typeface="Arial"/>
+                <a:ea typeface="Arial"/>
+                <a:cs typeface="Arial"/>
+              </a:defRPr>
+            </a:lvl3pPr>
+            <a:lvl4pPr>
+              <a:defRPr sz="1050" b="1">
+                <a:solidFill>
+                  <a:srgbClr val="FCD34D"/>
+                </a:solidFill>
+                <a:latin typeface="Arial"/>
+                <a:ea typeface="Arial"/>
+                <a:cs typeface="Arial"/>
+              </a:defRPr>
+            </a:lvl4pPr>
+            <a:lvl5pPr>
+              <a:defRPr sz="1050" b="1">
+                <a:solidFill>
+                  <a:srgbClr val="FCD34D"/>
+                </a:solidFill>
+                <a:latin typeface="Arial"/>
+                <a:ea typeface="Arial"/>
+                <a:cs typeface="Arial"/>
+              </a:defRPr>
+            </a:lvl5pPr>
+            <a:lvl6pPr>
+              <a:defRPr sz="1050" b="1">
+                <a:solidFill>
+                  <a:srgbClr val="FCD34D"/>
+                </a:solidFill>
+                <a:latin typeface="Arial"/>
+                <a:ea typeface="Arial"/>
+                <a:cs typeface="Arial"/>
+              </a:defRPr>
+            </a:lvl6pPr>
+            <a:lvl7pPr>
+              <a:defRPr sz="1050" b="1">
+                <a:solidFill>
+                  <a:srgbClr val="FCD34D"/>
+                </a:solidFill>
+                <a:latin typeface="Arial"/>
+                <a:ea typeface="Arial"/>
+                <a:cs typeface="Arial"/>
+              </a:defRPr>
+            </a:lvl7pPr>
+            <a:lvl8pPr>
+              <a:defRPr sz="1050" b="1">
+                <a:solidFill>
+                  <a:srgbClr val="FCD34D"/>
+                </a:solidFill>
+                <a:latin typeface="Arial"/>
+                <a:ea typeface="Arial"/>
+                <a:cs typeface="Arial"/>
+              </a:defRPr>
+            </a:lvl8pPr>
+            <a:lvl9pPr>
+              <a:defRPr sz="1050" b="1">
+                <a:solidFill>
+                  <a:srgbClr val="FCD34D"/>
+                </a:solidFill>
+                <a:latin typeface="Arial"/>
+                <a:ea typeface="Arial"/>
+                <a:cs typeface="Arial"/>
+              </a:defRPr>
+            </a:lvl9pPr>
+          </a:lstStyle>
+          <a:p xmlns:a="http://schemas.openxmlformats.org/drawingml/2006/main">
+            <a:pPr>
+              <a:defRPr sz="1050" b="1">
+                <a:solidFill>
+                  <a:srgbClr val="FCD34D"/>
+                </a:solidFill>
+                <a:latin typeface="Arial"/>
+                <a:ea typeface="Arial"/>
+                <a:cs typeface="Arial"/>
+              </a:defRPr>
+            </a:pPr>
+            <a:r>
+              <a:rPr sz="1050" b="1">
+                <a:solidFill>
+                  <a:srgbClr val="FCD34D"/>
+                </a:solidFill>
+                <a:latin typeface="Arial"/>
+                <a:ea typeface="Arial"/>
+                <a:cs typeface="Arial"/>
+              </a:rPr>
+              <a:t>CALL-CENTER PILOT</a:t>
+            </a:r>
+          </a:p>
+        </p:txBody>
+      </p:sp>
+      <p:sp>
+        <p:nvSpPr>
+          <p:cNvPr id="10" name="">
+            <a:extLst xmlns:a="http://schemas.openxmlformats.org/drawingml/2006/main">
+              <a:ext uri="{FF2B5EF4-FFF2-40B4-BE49-F238E27FC236}">
+                <a16:creationId xmlns:a16="http://schemas.microsoft.com/office/drawing/2014/main" id="{BC786907-B332-40B5-9E8C-77DFD3FA78AD}"/>
+              </a:ext>
+            </a:extLst>
+          </p:cNvPr>
+          <p:cNvSpPr>
+            <a:spLocks xmlns:a="http://schemas.openxmlformats.org/drawingml/2006/main" noGrp="1"/>
+          </p:cNvSpPr>
+          <p:nvPr/>
+        </p:nvSpPr>
+        <p:spPr>
+          <a:xfrm xmlns:a="http://schemas.openxmlformats.org/drawingml/2006/main">
+            <a:off x="6496050" y="2857500"/>
+            <a:ext cx="4514850" cy="514350"/>
+          </a:xfrm>
+          <a:prstGeom xmlns:a="http://schemas.openxmlformats.org/drawingml/2006/main" prst="rect">
+            <a:avLst/>
+          </a:prstGeom>
+          <a:noFill xmlns:a="http://schemas.openxmlformats.org/drawingml/2006/main"/>
+          <a:ln xmlns:a="http://schemas.openxmlformats.org/drawingml/2006/main" w="0">
+            <a:noFill/>
+            <a:prstDash val="solid"/>
+          </a:ln>
+        </p:spPr>
+        <p:txBody>
+          <a:bodyPr xmlns:a="http://schemas.openxmlformats.org/drawingml/2006/main"/>
+          <a:lstStyle xmlns:a="http://schemas.openxmlformats.org/drawingml/2006/main">
+            <a:defPPr>
+              <a:defRPr sz="1350">
+                <a:solidFill>
+                  <a:srgbClr val="F7FAFC"/>
+                </a:solidFill>
+                <a:latin typeface="Arial"/>
+                <a:ea typeface="Arial"/>
+                <a:cs typeface="Arial"/>
+              </a:defRPr>
+            </a:defPPr>
+            <a:lvl1pPr>
+              <a:defRPr sz="1350">
+                <a:solidFill>
+                  <a:srgbClr val="F7FAFC"/>
+                </a:solidFill>
+                <a:latin typeface="Arial"/>
+                <a:ea typeface="Arial"/>
+                <a:cs typeface="Arial"/>
+              </a:defRPr>
+            </a:lvl1pPr>
+            <a:lvl2pPr>
+              <a:defRPr sz="1350">
+                <a:solidFill>
+                  <a:srgbClr val="F7FAFC"/>
+                </a:solidFill>
+                <a:latin typeface="Arial"/>
+                <a:ea typeface="Arial"/>
+                <a:cs typeface="Arial"/>
+              </a:defRPr>
+            </a:lvl2pPr>
+            <a:lvl3pPr>
+              <a:defRPr sz="1350">
+                <a:solidFill>
+                  <a:srgbClr val="F7FAFC"/>
+                </a:solidFill>
+                <a:latin typeface="Arial"/>
+                <a:ea typeface="Arial"/>
+                <a:cs typeface="Arial"/>
+              </a:defRPr>
+            </a:lvl3pPr>
+            <a:lvl4pPr>
+              <a:defRPr sz="1350">
+                <a:solidFill>
+                  <a:srgbClr val="F7FAFC"/>
+                </a:solidFill>
+                <a:latin typeface="Arial"/>
+                <a:ea typeface="Arial"/>
+                <a:cs typeface="Arial"/>
+              </a:defRPr>
+            </a:lvl4pPr>
+            <a:lvl5pPr>
+              <a:defRPr sz="1350">
+                <a:solidFill>
+                  <a:srgbClr val="F7FAFC"/>
+                </a:solidFill>
+                <a:latin typeface="Arial"/>
+                <a:ea typeface="Arial"/>
+                <a:cs typeface="Arial"/>
+              </a:defRPr>
+            </a:lvl5pPr>
+            <a:lvl6pPr>
+              <a:defRPr sz="1350">
+                <a:solidFill>
+                  <a:srgbClr val="F7FAFC"/>
+                </a:solidFill>
+                <a:latin typeface="Arial"/>
+                <a:ea typeface="Arial"/>
+                <a:cs typeface="Arial"/>
+              </a:defRPr>
+            </a:lvl6pPr>
+            <a:lvl7pPr>
+              <a:defRPr sz="1350">
+                <a:solidFill>
+                  <a:srgbClr val="F7FAFC"/>
+                </a:solidFill>
+                <a:latin typeface="Arial"/>
+                <a:ea typeface="Arial"/>
+                <a:cs typeface="Arial"/>
+              </a:defRPr>
+            </a:lvl7pPr>
+            <a:lvl8pPr>
+              <a:defRPr sz="1350">
+                <a:solidFill>
+                  <a:srgbClr val="F7FAFC"/>
+                </a:solidFill>
+                <a:latin typeface="Arial"/>
+                <a:ea typeface="Arial"/>
+                <a:cs typeface="Arial"/>
+              </a:defRPr>
+            </a:lvl8pPr>
+            <a:lvl9pPr>
+              <a:defRPr sz="1350">
+                <a:solidFill>
+                  <a:srgbClr val="F7FAFC"/>
+                </a:solidFill>
+                <a:latin typeface="Arial"/>
+                <a:ea typeface="Arial"/>
+                <a:cs typeface="Arial"/>
+              </a:defRPr>
+            </a:lvl9pPr>
+          </a:lstStyle>
+          <a:p xmlns:a="http://schemas.openxmlformats.org/drawingml/2006/main">
+            <a:pPr>
+              <a:defRPr sz="1350">
+                <a:solidFill>
+                  <a:srgbClr val="F7FAFC"/>
+                </a:solidFill>
+                <a:latin typeface="Arial"/>
+                <a:ea typeface="Arial"/>
+                <a:cs typeface="Arial"/>
+              </a:defRPr>
+            </a:pPr>
+            <a:r>
+              <a:rPr sz="1350">
+                <a:solidFill>
+                  <a:srgbClr val="F7FAFC"/>
+                </a:solidFill>
+                <a:latin typeface="Arial"/>
+                <a:ea typeface="Arial"/>
+                <a:cs typeface="Arial"/>
+              </a:rPr>
+              <a:t>•  FAQ, status, scheduling, and ticket routing</a:t>
+            </a:r>
+          </a:p>
+        </p:txBody>
+      </p:sp>
+      <p:sp>
+        <p:nvSpPr>
+          <p:cNvPr id="11" name="">
+            <a:extLst xmlns:a="http://schemas.openxmlformats.org/drawingml/2006/main">
+              <a:ext uri="{FF2B5EF4-FFF2-40B4-BE49-F238E27FC236}">
+                <a16:creationId xmlns:a16="http://schemas.microsoft.com/office/drawing/2014/main" id="{BF2E9D64-ACF6-4481-A0F2-8625B190A90A}"/>
+              </a:ext>
+            </a:extLst>
+          </p:cNvPr>
+          <p:cNvSpPr>
+            <a:spLocks xmlns:a="http://schemas.openxmlformats.org/drawingml/2006/main" noGrp="1"/>
+          </p:cNvSpPr>
+          <p:nvPr/>
+        </p:nvSpPr>
+        <p:spPr>
+          <a:xfrm xmlns:a="http://schemas.openxmlformats.org/drawingml/2006/main">
+            <a:off x="6496050" y="3314700"/>
+            <a:ext cx="4514850" cy="514350"/>
+          </a:xfrm>
+          <a:prstGeom xmlns:a="http://schemas.openxmlformats.org/drawingml/2006/main" prst="rect">
+            <a:avLst/>
+          </a:prstGeom>
+          <a:noFill xmlns:a="http://schemas.openxmlformats.org/drawingml/2006/main"/>
+          <a:ln xmlns:a="http://schemas.openxmlformats.org/drawingml/2006/main" w="0">
+            <a:noFill/>
+            <a:prstDash val="solid"/>
+          </a:ln>
+        </p:spPr>
+        <p:txBody>
+          <a:bodyPr xmlns:a="http://schemas.openxmlformats.org/drawingml/2006/main"/>
+          <a:lstStyle xmlns:a="http://schemas.openxmlformats.org/drawingml/2006/main">
+            <a:defPPr>
+              <a:defRPr sz="1350">
+                <a:solidFill>
+                  <a:srgbClr val="F7FAFC"/>
+                </a:solidFill>
+                <a:latin typeface="Arial"/>
+                <a:ea typeface="Arial"/>
+                <a:cs typeface="Arial"/>
+              </a:defRPr>
+            </a:defPPr>
+            <a:lvl1pPr>
+              <a:defRPr sz="1350">
+                <a:solidFill>
+                  <a:srgbClr val="F7FAFC"/>
+                </a:solidFill>
+                <a:latin typeface="Arial"/>
+                <a:ea typeface="Arial"/>
+                <a:cs typeface="Arial"/>
+              </a:defRPr>
+            </a:lvl1pPr>
+            <a:lvl2pPr>
+              <a:defRPr sz="1350">
+                <a:solidFill>
+                  <a:srgbClr val="F7FAFC"/>
+                </a:solidFill>
+                <a:latin typeface="Arial"/>
+                <a:ea typeface="Arial"/>
+                <a:cs typeface="Arial"/>
+              </a:defRPr>
+            </a:lvl2pPr>
+            <a:lvl3pPr>
+              <a:defRPr sz="1350">
+                <a:solidFill>
+                  <a:srgbClr val="F7FAFC"/>
+                </a:solidFill>
+                <a:latin typeface="Arial"/>
+                <a:ea typeface="Arial"/>
+                <a:cs typeface="Arial"/>
+              </a:defRPr>
+            </a:lvl3pPr>
+            <a:lvl4pPr>
+              <a:defRPr sz="1350">
+                <a:solidFill>
+                  <a:srgbClr val="F7FAFC"/>
+                </a:solidFill>
+                <a:latin typeface="Arial"/>
+                <a:ea typeface="Arial"/>
+                <a:cs typeface="Arial"/>
+              </a:defRPr>
+            </a:lvl4pPr>
+            <a:lvl5pPr>
+              <a:defRPr sz="1350">
+                <a:solidFill>
+                  <a:srgbClr val="F7FAFC"/>
+                </a:solidFill>
+                <a:latin typeface="Arial"/>
+                <a:ea typeface="Arial"/>
+                <a:cs typeface="Arial"/>
+              </a:defRPr>
+            </a:lvl5pPr>
+            <a:lvl6pPr>
+              <a:defRPr sz="1350">
+                <a:solidFill>
+                  <a:srgbClr val="F7FAFC"/>
+                </a:solidFill>
+                <a:latin typeface="Arial"/>
+                <a:ea typeface="Arial"/>
+                <a:cs typeface="Arial"/>
+              </a:defRPr>
+            </a:lvl6pPr>
+            <a:lvl7pPr>
+              <a:defRPr sz="1350">
+                <a:solidFill>
+                  <a:srgbClr val="F7FAFC"/>
+                </a:solidFill>
+                <a:latin typeface="Arial"/>
+                <a:ea typeface="Arial"/>
+                <a:cs typeface="Arial"/>
+              </a:defRPr>
+            </a:lvl7pPr>
+            <a:lvl8pPr>
+              <a:defRPr sz="1350">
+                <a:solidFill>
+                  <a:srgbClr val="F7FAFC"/>
+                </a:solidFill>
+                <a:latin typeface="Arial"/>
+                <a:ea typeface="Arial"/>
+                <a:cs typeface="Arial"/>
+              </a:defRPr>
+            </a:lvl8pPr>
+            <a:lvl9pPr>
+              <a:defRPr sz="1350">
+                <a:solidFill>
+                  <a:srgbClr val="F7FAFC"/>
+                </a:solidFill>
+                <a:latin typeface="Arial"/>
+                <a:ea typeface="Arial"/>
+                <a:cs typeface="Arial"/>
+              </a:defRPr>
+            </a:lvl9pPr>
+          </a:lstStyle>
+          <a:p xmlns:a="http://schemas.openxmlformats.org/drawingml/2006/main">
+            <a:pPr>
+              <a:defRPr sz="1350">
+                <a:solidFill>
+                  <a:srgbClr val="F7FAFC"/>
+                </a:solidFill>
+                <a:latin typeface="Arial"/>
+                <a:ea typeface="Arial"/>
+                <a:cs typeface="Arial"/>
+              </a:defRPr>
+            </a:pPr>
+            <a:r>
+              <a:rPr sz="1350">
+                <a:solidFill>
+                  <a:srgbClr val="F7FAFC"/>
+                </a:solidFill>
+                <a:latin typeface="Arial"/>
+                <a:ea typeface="Arial"/>
+                <a:cs typeface="Arial"/>
+              </a:rPr>
+              <a:t>•  AI disclosure and consent-aware handling</a:t>
+            </a:r>
+          </a:p>
+        </p:txBody>
+      </p:sp>
+      <p:sp>
+        <p:nvSpPr>
+          <p:cNvPr id="12" name="">
+            <a:extLst xmlns:a="http://schemas.openxmlformats.org/drawingml/2006/main">
+              <a:ext uri="{FF2B5EF4-FFF2-40B4-BE49-F238E27FC236}">
+                <a16:creationId xmlns:a16="http://schemas.microsoft.com/office/drawing/2014/main" id="{745951F2-48F2-4EC3-9F7F-FF15CA6B0143}"/>
+              </a:ext>
+            </a:extLst>
+          </p:cNvPr>
+          <p:cNvSpPr>
+            <a:spLocks xmlns:a="http://schemas.openxmlformats.org/drawingml/2006/main" noGrp="1"/>
+          </p:cNvSpPr>
+          <p:nvPr/>
+        </p:nvSpPr>
+        <p:spPr>
+          <a:xfrm xmlns:a="http://schemas.openxmlformats.org/drawingml/2006/main">
+            <a:off x="6496050" y="3771900"/>
+            <a:ext cx="4514850" cy="514350"/>
+          </a:xfrm>
+          <a:prstGeom xmlns:a="http://schemas.openxmlformats.org/drawingml/2006/main" prst="rect">
+            <a:avLst/>
+          </a:prstGeom>
+          <a:noFill xmlns:a="http://schemas.openxmlformats.org/drawingml/2006/main"/>
+          <a:ln xmlns:a="http://schemas.openxmlformats.org/drawingml/2006/main" w="0">
+            <a:noFill/>
+            <a:prstDash val="solid"/>
+          </a:ln>
+        </p:spPr>
+        <p:txBody>
+          <a:bodyPr xmlns:a="http://schemas.openxmlformats.org/drawingml/2006/main"/>
+          <a:lstStyle xmlns:a="http://schemas.openxmlformats.org/drawingml/2006/main">
+            <a:defPPr>
+              <a:defRPr sz="1350">
+                <a:solidFill>
+                  <a:srgbClr val="F7FAFC"/>
+                </a:solidFill>
+                <a:latin typeface="Arial"/>
+                <a:ea typeface="Arial"/>
+                <a:cs typeface="Arial"/>
+              </a:defRPr>
+            </a:defPPr>
+            <a:lvl1pPr>
+              <a:defRPr sz="1350">
+                <a:solidFill>
+                  <a:srgbClr val="F7FAFC"/>
+                </a:solidFill>
+                <a:latin typeface="Arial"/>
+                <a:ea typeface="Arial"/>
+                <a:cs typeface="Arial"/>
+              </a:defRPr>
+            </a:lvl1pPr>
+            <a:lvl2pPr>
+              <a:defRPr sz="1350">
+                <a:solidFill>
+                  <a:srgbClr val="F7FAFC"/>
+                </a:solidFill>
+                <a:latin typeface="Arial"/>
+                <a:ea typeface="Arial"/>
+                <a:cs typeface="Arial"/>
+              </a:defRPr>
+            </a:lvl2pPr>
+            <a:lvl3pPr>
+              <a:defRPr sz="1350">
+                <a:solidFill>
+                  <a:srgbClr val="F7FAFC"/>
+                </a:solidFill>
+                <a:latin typeface="Arial"/>
+                <a:ea typeface="Arial"/>
+                <a:cs typeface="Arial"/>
+              </a:defRPr>
+            </a:lvl3pPr>
+            <a:lvl4pPr>
+              <a:defRPr sz="1350">
+                <a:solidFill>
+                  <a:srgbClr val="F7FAFC"/>
+                </a:solidFill>
+                <a:latin typeface="Arial"/>
+                <a:ea typeface="Arial"/>
+                <a:cs typeface="Arial"/>
+              </a:defRPr>
+            </a:lvl4pPr>
+            <a:lvl5pPr>
+              <a:defRPr sz="1350">
+                <a:solidFill>
+                  <a:srgbClr val="F7FAFC"/>
+                </a:solidFill>
+                <a:latin typeface="Arial"/>
+                <a:ea typeface="Arial"/>
+                <a:cs typeface="Arial"/>
+              </a:defRPr>
+            </a:lvl5pPr>
+            <a:lvl6pPr>
+              <a:defRPr sz="1350">
+                <a:solidFill>
+                  <a:srgbClr val="F7FAFC"/>
+                </a:solidFill>
+                <a:latin typeface="Arial"/>
+                <a:ea typeface="Arial"/>
+                <a:cs typeface="Arial"/>
+              </a:defRPr>
+            </a:lvl6pPr>
+            <a:lvl7pPr>
+              <a:defRPr sz="1350">
+                <a:solidFill>
+                  <a:srgbClr val="F7FAFC"/>
+                </a:solidFill>
+                <a:latin typeface="Arial"/>
+                <a:ea typeface="Arial"/>
+                <a:cs typeface="Arial"/>
+              </a:defRPr>
+            </a:lvl7pPr>
+            <a:lvl8pPr>
+              <a:defRPr sz="1350">
+                <a:solidFill>
+                  <a:srgbClr val="F7FAFC"/>
+                </a:solidFill>
+                <a:latin typeface="Arial"/>
+                <a:ea typeface="Arial"/>
+                <a:cs typeface="Arial"/>
+              </a:defRPr>
+            </a:lvl8pPr>
+            <a:lvl9pPr>
+              <a:defRPr sz="1350">
+                <a:solidFill>
+                  <a:srgbClr val="F7FAFC"/>
+                </a:solidFill>
+                <a:latin typeface="Arial"/>
+                <a:ea typeface="Arial"/>
+                <a:cs typeface="Arial"/>
+              </a:defRPr>
+            </a:lvl9pPr>
+          </a:lstStyle>
+          <a:p xmlns:a="http://schemas.openxmlformats.org/drawingml/2006/main">
+            <a:pPr>
+              <a:defRPr sz="1350">
+                <a:solidFill>
+                  <a:srgbClr val="F7FAFC"/>
+                </a:solidFill>
+                <a:latin typeface="Arial"/>
+                <a:ea typeface="Arial"/>
+                <a:cs typeface="Arial"/>
+              </a:defRPr>
+            </a:pPr>
+            <a:r>
+              <a:rPr sz="1350">
+                <a:solidFill>
+                  <a:srgbClr val="F7FAFC"/>
+                </a:solidFill>
+                <a:latin typeface="Arial"/>
+                <a:ea typeface="Arial"/>
+                <a:cs typeface="Arial"/>
+              </a:rPr>
+              <a:t>•  Human escalation for uncertainty or regulated cases</a:t>
+            </a:r>
+          </a:p>
+        </p:txBody>
+      </p:sp>
+      <p:sp>
+        <p:nvSpPr>
+          <p:cNvPr id="13" name="">
+            <a:extLst xmlns:a="http://schemas.openxmlformats.org/drawingml/2006/main">
+              <a:ext uri="{FF2B5EF4-FFF2-40B4-BE49-F238E27FC236}">
+                <a16:creationId xmlns:a16="http://schemas.microsoft.com/office/drawing/2014/main" id="{32AB52C5-B325-4BA4-90B4-D98E8B7317B8}"/>
+              </a:ext>
+            </a:extLst>
+          </p:cNvPr>
+          <p:cNvSpPr>
+            <a:spLocks xmlns:a="http://schemas.openxmlformats.org/drawingml/2006/main" noGrp="1"/>
+          </p:cNvSpPr>
+          <p:nvPr/>
+        </p:nvSpPr>
+        <p:spPr>
+          <a:xfrm xmlns:a="http://schemas.openxmlformats.org/drawingml/2006/main">
+            <a:off x="6496050" y="4229100"/>
+            <a:ext cx="4514850" cy="514350"/>
+          </a:xfrm>
+          <a:prstGeom xmlns:a="http://schemas.openxmlformats.org/drawingml/2006/main" prst="rect">
+            <a:avLst/>
+          </a:prstGeom>
+          <a:noFill xmlns:a="http://schemas.openxmlformats.org/drawingml/2006/main"/>
+          <a:ln xmlns:a="http://schemas.openxmlformats.org/drawingml/2006/main" w="0">
+            <a:noFill/>
+            <a:prstDash val="solid"/>
+          </a:ln>
+        </p:spPr>
+        <p:txBody>
+          <a:bodyPr xmlns:a="http://schemas.openxmlformats.org/drawingml/2006/main"/>
+          <a:lstStyle xmlns:a="http://schemas.openxmlformats.org/drawingml/2006/main">
+            <a:defPPr>
+              <a:defRPr sz="1350">
+                <a:solidFill>
+                  <a:srgbClr val="F7FAFC"/>
+                </a:solidFill>
+                <a:latin typeface="Arial"/>
+                <a:ea typeface="Arial"/>
+                <a:cs typeface="Arial"/>
+              </a:defRPr>
+            </a:defPPr>
+            <a:lvl1pPr>
+              <a:defRPr sz="1350">
+                <a:solidFill>
+                  <a:srgbClr val="F7FAFC"/>
+                </a:solidFill>
+                <a:latin typeface="Arial"/>
+                <a:ea typeface="Arial"/>
+                <a:cs typeface="Arial"/>
+              </a:defRPr>
+            </a:lvl1pPr>
+            <a:lvl2pPr>
+              <a:defRPr sz="1350">
+                <a:solidFill>
+                  <a:srgbClr val="F7FAFC"/>
+                </a:solidFill>
+                <a:latin typeface="Arial"/>
+                <a:ea typeface="Arial"/>
+                <a:cs typeface="Arial"/>
+              </a:defRPr>
+            </a:lvl2pPr>
+            <a:lvl3pPr>
+              <a:defRPr sz="1350">
+                <a:solidFill>
+                  <a:srgbClr val="F7FAFC"/>
+                </a:solidFill>
+                <a:latin typeface="Arial"/>
+                <a:ea typeface="Arial"/>
+                <a:cs typeface="Arial"/>
+              </a:defRPr>
+            </a:lvl3pPr>
+            <a:lvl4pPr>
+              <a:defRPr sz="1350">
+                <a:solidFill>
+                  <a:srgbClr val="F7FAFC"/>
+                </a:solidFill>
+                <a:latin typeface="Arial"/>
+                <a:ea typeface="Arial"/>
+                <a:cs typeface="Arial"/>
+              </a:defRPr>
+            </a:lvl4pPr>
+            <a:lvl5pPr>
+              <a:defRPr sz="1350">
+                <a:solidFill>
+                  <a:srgbClr val="F7FAFC"/>
+                </a:solidFill>
+                <a:latin typeface="Arial"/>
+                <a:ea typeface="Arial"/>
+                <a:cs typeface="Arial"/>
+              </a:defRPr>
+            </a:lvl5pPr>
+            <a:lvl6pPr>
+              <a:defRPr sz="1350">
+                <a:solidFill>
+                  <a:srgbClr val="F7FAFC"/>
+                </a:solidFill>
+                <a:latin typeface="Arial"/>
+                <a:ea typeface="Arial"/>
+                <a:cs typeface="Arial"/>
+              </a:defRPr>
+            </a:lvl6pPr>
+            <a:lvl7pPr>
+              <a:defRPr sz="1350">
+                <a:solidFill>
+                  <a:srgbClr val="F7FAFC"/>
+                </a:solidFill>
+                <a:latin typeface="Arial"/>
+                <a:ea typeface="Arial"/>
+                <a:cs typeface="Arial"/>
+              </a:defRPr>
+            </a:lvl7pPr>
+            <a:lvl8pPr>
+              <a:defRPr sz="1350">
+                <a:solidFill>
+                  <a:srgbClr val="F7FAFC"/>
+                </a:solidFill>
+                <a:latin typeface="Arial"/>
+                <a:ea typeface="Arial"/>
+                <a:cs typeface="Arial"/>
+              </a:defRPr>
+            </a:lvl8pPr>
+            <a:lvl9pPr>
+              <a:defRPr sz="1350">
+                <a:solidFill>
+                  <a:srgbClr val="F7FAFC"/>
+                </a:solidFill>
+                <a:latin typeface="Arial"/>
+                <a:ea typeface="Arial"/>
+                <a:cs typeface="Arial"/>
+              </a:defRPr>
+            </a:lvl9pPr>
+          </a:lstStyle>
+          <a:p xmlns:a="http://schemas.openxmlformats.org/drawingml/2006/main">
+            <a:pPr>
+              <a:defRPr sz="1350">
+                <a:solidFill>
+                  <a:srgbClr val="F7FAFC"/>
+                </a:solidFill>
+                <a:latin typeface="Arial"/>
+                <a:ea typeface="Arial"/>
+                <a:cs typeface="Arial"/>
+              </a:defRPr>
+            </a:pPr>
+            <a:r>
+              <a:rPr sz="1350">
+                <a:solidFill>
+                  <a:srgbClr val="F7FAFC"/>
+                </a:solidFill>
+                <a:latin typeface="Arial"/>
+                <a:ea typeface="Arial"/>
+                <a:cs typeface="Arial"/>
+              </a:rPr>
+              <a:t>•  Audit, kill switch, privacy, and service-level review</a:t>
+            </a:r>
+          </a:p>
+        </p:txBody>
+      </p:sp>
+      <p:sp>
+        <p:nvSpPr>
+          <p:cNvPr id="14" name="">
+            <a:extLst xmlns:a="http://schemas.openxmlformats.org/drawingml/2006/main">
+              <a:ext uri="{FF2B5EF4-FFF2-40B4-BE49-F238E27FC236}">
+                <a16:creationId xmlns:a16="http://schemas.microsoft.com/office/drawing/2014/main" id="{8B1CE57C-562A-4085-B899-DBCAFFDC685C}"/>
+              </a:ext>
+            </a:extLst>
+          </p:cNvPr>
+          <p:cNvSpPr>
+            <a:spLocks xmlns:a="http://schemas.openxmlformats.org/drawingml/2006/main" noGrp="1"/>
+          </p:cNvSpPr>
+          <p:nvPr/>
+        </p:nvSpPr>
+        <p:spPr>
+          <a:xfrm xmlns:a="http://schemas.openxmlformats.org/drawingml/2006/main">
+            <a:off x="6496050" y="4724400"/>
+            <a:ext cx="4514850" cy="228600"/>
+          </a:xfrm>
+          <a:prstGeom xmlns:a="http://schemas.openxmlformats.org/drawingml/2006/main" prst="rect">
+            <a:avLst/>
+          </a:prstGeom>
+          <a:noFill xmlns:a="http://schemas.openxmlformats.org/drawingml/2006/main"/>
+          <a:ln xmlns:a="http://schemas.openxmlformats.org/drawingml/2006/main" w="0">
+            <a:noFill/>
+            <a:prstDash val="solid"/>
+          </a:ln>
+        </p:spPr>
+        <p:txBody>
+          <a:bodyPr xmlns:a="http://schemas.openxmlformats.org/drawingml/2006/main"/>
+          <a:lstStyle xmlns:a="http://schemas.openxmlformats.org/drawingml/2006/main">
+            <a:defPPr>
+              <a:defRPr sz="1350" b="1">
+                <a:solidFill>
+                  <a:srgbClr val="A7F3D0"/>
+                </a:solidFill>
+                <a:latin typeface="Arial"/>
+                <a:ea typeface="Arial"/>
+                <a:cs typeface="Arial"/>
+              </a:defRPr>
+            </a:defPPr>
+            <a:lvl1pPr>
+              <a:defRPr sz="1350" b="1">
+                <a:solidFill>
+                  <a:srgbClr val="A7F3D0"/>
+                </a:solidFill>
+                <a:latin typeface="Arial"/>
+                <a:ea typeface="Arial"/>
+                <a:cs typeface="Arial"/>
+              </a:defRPr>
+            </a:lvl1pPr>
+            <a:lvl2pPr>
+              <a:defRPr sz="1350" b="1">
+                <a:solidFill>
+                  <a:srgbClr val="A7F3D0"/>
+                </a:solidFill>
+                <a:latin typeface="Arial"/>
+                <a:ea typeface="Arial"/>
+                <a:cs typeface="Arial"/>
+              </a:defRPr>
+            </a:lvl2pPr>
+            <a:lvl3pPr>
+              <a:defRPr sz="1350" b="1">
+                <a:solidFill>
+                  <a:srgbClr val="A7F3D0"/>
+                </a:solidFill>
+                <a:latin typeface="Arial"/>
+                <a:ea typeface="Arial"/>
+                <a:cs typeface="Arial"/>
+              </a:defRPr>
+            </a:lvl3pPr>
+            <a:lvl4pPr>
+              <a:defRPr sz="1350" b="1">
+                <a:solidFill>
+                  <a:srgbClr val="A7F3D0"/>
+                </a:solidFill>
+                <a:latin typeface="Arial"/>
+                <a:ea typeface="Arial"/>
+                <a:cs typeface="Arial"/>
+              </a:defRPr>
+            </a:lvl4pPr>
+            <a:lvl5pPr>
+              <a:defRPr sz="1350" b="1">
+                <a:solidFill>
+                  <a:srgbClr val="A7F3D0"/>
+                </a:solidFill>
+                <a:latin typeface="Arial"/>
+                <a:ea typeface="Arial"/>
+                <a:cs typeface="Arial"/>
+              </a:defRPr>
+            </a:lvl5pPr>
+            <a:lvl6pPr>
+              <a:defRPr sz="1350" b="1">
+                <a:solidFill>
+                  <a:srgbClr val="A7F3D0"/>
+                </a:solidFill>
+                <a:latin typeface="Arial"/>
+                <a:ea typeface="Arial"/>
+                <a:cs typeface="Arial"/>
+              </a:defRPr>
+            </a:lvl6pPr>
+            <a:lvl7pPr>
+              <a:defRPr sz="1350" b="1">
+                <a:solidFill>
+                  <a:srgbClr val="A7F3D0"/>
+                </a:solidFill>
+                <a:latin typeface="Arial"/>
+                <a:ea typeface="Arial"/>
+                <a:cs typeface="Arial"/>
+              </a:defRPr>
+            </a:lvl7pPr>
+            <a:lvl8pPr>
+              <a:defRPr sz="1350" b="1">
+                <a:solidFill>
+                  <a:srgbClr val="A7F3D0"/>
+                </a:solidFill>
+                <a:latin typeface="Arial"/>
+                <a:ea typeface="Arial"/>
+                <a:cs typeface="Arial"/>
+              </a:defRPr>
+            </a:lvl8pPr>
+            <a:lvl9pPr>
+              <a:defRPr sz="1350" b="1">
+                <a:solidFill>
+                  <a:srgbClr val="A7F3D0"/>
+                </a:solidFill>
+                <a:latin typeface="Arial"/>
+                <a:ea typeface="Arial"/>
+                <a:cs typeface="Arial"/>
+              </a:defRPr>
+            </a:lvl9pPr>
+          </a:lstStyle>
+          <a:p xmlns:a="http://schemas.openxmlformats.org/drawingml/2006/main">
+            <a:pPr>
+              <a:defRPr sz="1350" b="1">
+                <a:solidFill>
+                  <a:srgbClr val="A7F3D0"/>
+                </a:solidFill>
+                <a:latin typeface="Arial"/>
+                <a:ea typeface="Arial"/>
+                <a:cs typeface="Arial"/>
+              </a:defRPr>
+            </a:pPr>
+            <a:r>
+              <a:rPr sz="1350" b="1">
+                <a:solidFill>
+                  <a:srgbClr val="A7F3D0"/>
+                </a:solidFill>
+                <a:latin typeface="Arial"/>
+                <a:ea typeface="Arial"/>
+                <a:cs typeface="Arial"/>
+              </a:rPr>
+              <a:t>Pilot first. Measure quality, safety, cost, and handoff before scale.</a:t>
+            </a:r>
+          </a:p>
+        </p:txBody>
+      </p:sp>
+      <p:sp>
+        <p:nvSpPr>
+          <p:cNvPr id="15" name="">
+            <a:extLst xmlns:a="http://schemas.openxmlformats.org/drawingml/2006/main">
+              <a:ext uri="{FF2B5EF4-FFF2-40B4-BE49-F238E27FC236}">
+                <a16:creationId xmlns:a16="http://schemas.microsoft.com/office/drawing/2014/main" id="{1E42B8CE-4E84-4F5C-8BC8-EEB64473714B}"/>
+              </a:ext>
+            </a:extLst>
+          </p:cNvPr>
+          <p:cNvSpPr>
+            <a:spLocks xmlns:a="http://schemas.openxmlformats.org/drawingml/2006/main" noGrp="1"/>
+          </p:cNvSpPr>
+          <p:nvPr/>
+        </p:nvSpPr>
+        <p:spPr>
+          <a:xfrm xmlns:a="http://schemas.openxmlformats.org/drawingml/2006/main">
+            <a:off x="609600" y="6496050"/>
+            <a:ext cx="4000500" cy="171450"/>
+          </a:xfrm>
+          <a:prstGeom xmlns:a="http://schemas.openxmlformats.org/drawingml/2006/main" prst="rect">
+            <a:avLst/>
+          </a:prstGeom>
+          <a:noFill xmlns:a="http://schemas.openxmlformats.org/drawingml/2006/main"/>
+          <a:ln xmlns:a="http://schemas.openxmlformats.org/drawingml/2006/main" w="0">
+            <a:noFill/>
+            <a:prstDash val="solid"/>
+          </a:ln>
+        </p:spPr>
+        <p:txBody>
+          <a:bodyPr xmlns:a="http://schemas.openxmlformats.org/drawingml/2006/main"/>
+          <a:lstStyle xmlns:a="http://schemas.openxmlformats.org/drawingml/2006/main">
+            <a:defPPr>
+              <a:defRPr sz="825" b="1">
+                <a:solidFill>
+                  <a:srgbClr val="A8B8CA"/>
+                </a:solidFill>
+                <a:latin typeface="Arial"/>
+                <a:ea typeface="Arial"/>
+                <a:cs typeface="Arial"/>
+              </a:defRPr>
+            </a:defPPr>
+            <a:lvl1pPr>
+              <a:defRPr sz="825" b="1">
+                <a:solidFill>
+                  <a:srgbClr val="A8B8CA"/>
+                </a:solidFill>
+                <a:latin typeface="Arial"/>
+                <a:ea typeface="Arial"/>
+                <a:cs typeface="Arial"/>
+              </a:defRPr>
+            </a:lvl1pPr>
+            <a:lvl2pPr>
+              <a:defRPr sz="825" b="1">
+                <a:solidFill>
+                  <a:srgbClr val="A8B8CA"/>
+                </a:solidFill>
+                <a:latin typeface="Arial"/>
+                <a:ea typeface="Arial"/>
+                <a:cs typeface="Arial"/>
+              </a:defRPr>
+            </a:lvl2pPr>
+            <a:lvl3pPr>
+              <a:defRPr sz="825" b="1">
+                <a:solidFill>
+                  <a:srgbClr val="A8B8CA"/>
+                </a:solidFill>
+                <a:latin typeface="Arial"/>
+                <a:ea typeface="Arial"/>
+                <a:cs typeface="Arial"/>
+              </a:defRPr>
+            </a:lvl3pPr>
+            <a:lvl4pPr>
+              <a:defRPr sz="825" b="1">
+                <a:solidFill>
+                  <a:srgbClr val="A8B8CA"/>
+                </a:solidFill>
+                <a:latin typeface="Arial"/>
+                <a:ea typeface="Arial"/>
+                <a:cs typeface="Arial"/>
+              </a:defRPr>
+            </a:lvl4pPr>
+            <a:lvl5pPr>
+              <a:defRPr sz="825" b="1">
+                <a:solidFill>
+                  <a:srgbClr val="A8B8CA"/>
+                </a:solidFill>
+                <a:latin typeface="Arial"/>
+                <a:ea typeface="Arial"/>
+                <a:cs typeface="Arial"/>
+              </a:defRPr>
+            </a:lvl5pPr>
+            <a:lvl6pPr>
+              <a:defRPr sz="825" b="1">
+                <a:solidFill>
+                  <a:srgbClr val="A8B8CA"/>
+                </a:solidFill>
+                <a:latin typeface="Arial"/>
+                <a:ea typeface="Arial"/>
+                <a:cs typeface="Arial"/>
+              </a:defRPr>
+            </a:lvl6pPr>
+            <a:lvl7pPr>
+              <a:defRPr sz="825" b="1">
+                <a:solidFill>
+                  <a:srgbClr val="A8B8CA"/>
+                </a:solidFill>
+                <a:latin typeface="Arial"/>
+                <a:ea typeface="Arial"/>
+                <a:cs typeface="Arial"/>
+              </a:defRPr>
+            </a:lvl7pPr>
+            <a:lvl8pPr>
+              <a:defRPr sz="825" b="1">
+                <a:solidFill>
+                  <a:srgbClr val="A8B8CA"/>
+                </a:solidFill>
+                <a:latin typeface="Arial"/>
+                <a:ea typeface="Arial"/>
+                <a:cs typeface="Arial"/>
+              </a:defRPr>
+            </a:lvl8pPr>
+            <a:lvl9pPr>
+              <a:defRPr sz="825" b="1">
+                <a:solidFill>
+                  <a:srgbClr val="A8B8CA"/>
+                </a:solidFill>
+                <a:latin typeface="Arial"/>
+                <a:ea typeface="Arial"/>
+                <a:cs typeface="Arial"/>
+              </a:defRPr>
+            </a:lvl9pPr>
+          </a:lstStyle>
+          <a:p xmlns:a="http://schemas.openxmlformats.org/drawingml/2006/main">
+            <a:pPr>
+              <a:defRPr sz="825" b="1">
+                <a:solidFill>
+                  <a:srgbClr val="A8B8CA"/>
+                </a:solidFill>
+                <a:latin typeface="Arial"/>
+                <a:ea typeface="Arial"/>
+                <a:cs typeface="Arial"/>
+              </a:defRPr>
+            </a:pPr>
+            <a:r>
+              <a:rPr sz="825" b="1">
+                <a:solidFill>
+                  <a:srgbClr val="A8B8CA"/>
+                </a:solidFill>
+                <a:latin typeface="Arial"/>
+                <a:ea typeface="Arial"/>
+                <a:cs typeface="Arial"/>
+              </a:rPr>
+              <a:t>ME3 VOICE DUPLEX  |  QWEN TOOL BRAIN  |  7/8</a:t>
+            </a:r>
+          </a:p>
+        </p:txBody>
+      </p:sp>
+    </p:spTree>
+    <p:extLst>
+      <p:ext uri="{BB962C8B-B14F-4D97-AF65-F5344CB8AC3E}">
+        <p14:creationId xmlns:p14="http://schemas.microsoft.com/office/powerpoint/2010/main" val="1471264058"/>
+      </p:ext>
+    </p:extLst>
+  </p:cSld>
+</p:sld>
+</file>
+
+<file path=ppt/slides/slide8.xml><?xml version="1.0" encoding="utf-8"?>
+<p:sld xmlns:p="http://schemas.openxmlformats.org/presentationml/2006/main">
+  <p:cSld>
+    <p:bg>
+      <p:bgPr>
+        <a:solidFill xmlns:a="http://schemas.openxmlformats.org/drawingml/2006/main">
+          <a:srgbClr val="081827"/>
+        </a:solidFill>
+      </p:bgPr>
+    </p:bg>
+    <p:spTree>
+      <p:nvGrpSpPr>
+        <p:cNvPr id="1" name=""/>
+        <p:cNvGrpSpPr/>
+        <p:nvPr/>
+      </p:nvGrpSpPr>
+      <p:grpSpPr>
+        <a:xfrm xmlns:a="http://schemas.openxmlformats.org/drawingml/2006/main"/>
+      </p:grpSpPr>
+      <p:sp>
+        <p:nvSpPr>
           <p:cNvPr id="10" name="close-rule">
             <a:extLst xmlns:a="http://schemas.openxmlformats.org/drawingml/2006/main">
               <a:ext uri="{FF2B5EF4-FFF2-40B4-BE49-F238E27FC236}">
-                <a16:creationId xmlns:a16="http://schemas.microsoft.com/office/drawing/2014/main" id="{CCC7C9A3-5CEE-4BD6-B4F0-EC56376D2A3A}"/>
+                <a16:creationId xmlns:a16="http://schemas.microsoft.com/office/drawing/2014/main" id="{31F84FE3-1DFA-49B7-B717-429CD99D2422}"/>
               </a:ext>
             </a:extLst>
           </p:cNvPr>
@@ -19364,7 +21664,7 @@
           <p:cNvPr id="2" name="">
             <a:extLst xmlns:a="http://schemas.openxmlformats.org/drawingml/2006/main">
               <a:ext uri="{FF2B5EF4-FFF2-40B4-BE49-F238E27FC236}">
-                <a16:creationId xmlns:a16="http://schemas.microsoft.com/office/drawing/2014/main" id="{7C1C765A-079E-4212-BD43-8A1BE6E279F7}"/>
+                <a16:creationId xmlns:a16="http://schemas.microsoft.com/office/drawing/2014/main" id="{3B8FD775-8B40-46BD-9B0B-1E29AEA71685}"/>
               </a:ext>
             </a:extLst>
           </p:cNvPr>
@@ -19521,7 +21821,7 @@
           <p:cNvPr id="3" name="">
             <a:extLst xmlns:a="http://schemas.openxmlformats.org/drawingml/2006/main">
               <a:ext uri="{FF2B5EF4-FFF2-40B4-BE49-F238E27FC236}">
-                <a16:creationId xmlns:a16="http://schemas.microsoft.com/office/drawing/2014/main" id="{8B5D6890-30A1-4A08-8B5A-BF2CA249B96E}"/>
+                <a16:creationId xmlns:a16="http://schemas.microsoft.com/office/drawing/2014/main" id="{60CBD0FD-C528-4C6E-B5AD-919AB2BE946A}"/>
               </a:ext>
             </a:extLst>
           </p:cNvPr>
@@ -19724,7 +22024,7 @@
           <p:cNvPr id="4" name="">
             <a:extLst xmlns:a="http://schemas.openxmlformats.org/drawingml/2006/main">
               <a:ext uri="{FF2B5EF4-FFF2-40B4-BE49-F238E27FC236}">
-                <a16:creationId xmlns:a16="http://schemas.microsoft.com/office/drawing/2014/main" id="{A944AE1E-0E28-4AE2-A22C-4188F76397EF}"/>
+                <a16:creationId xmlns:a16="http://schemas.microsoft.com/office/drawing/2014/main" id="{DC92ED7D-EC72-45F2-8EA4-1BD54C732DA6}"/>
               </a:ext>
             </a:extLst>
           </p:cNvPr>
@@ -19881,7 +22181,7 @@
           <p:cNvPr id="5" name="close-card">
             <a:extLst xmlns:a="http://schemas.openxmlformats.org/drawingml/2006/main">
               <a:ext uri="{FF2B5EF4-FFF2-40B4-BE49-F238E27FC236}">
-                <a16:creationId xmlns:a16="http://schemas.microsoft.com/office/drawing/2014/main" id="{B29A9F0B-C2AE-40C5-8B8B-A101D0C6C72B}"/>
+                <a16:creationId xmlns:a16="http://schemas.microsoft.com/office/drawing/2014/main" id="{0CABABD4-6468-4436-B60E-1F02CF18F947}"/>
               </a:ext>
             </a:extLst>
           </p:cNvPr>
@@ -19916,7 +22216,7 @@
           <p:cNvPr id="6" name="">
             <a:extLst xmlns:a="http://schemas.openxmlformats.org/drawingml/2006/main">
               <a:ext uri="{FF2B5EF4-FFF2-40B4-BE49-F238E27FC236}">
-                <a16:creationId xmlns:a16="http://schemas.microsoft.com/office/drawing/2014/main" id="{B061F487-9704-4A59-82A4-E78459FE72A4}"/>
+                <a16:creationId xmlns:a16="http://schemas.microsoft.com/office/drawing/2014/main" id="{BE8F2FAF-C849-4C8A-851C-505763D9DEEC}"/>
               </a:ext>
             </a:extLst>
           </p:cNvPr>
@@ -20165,7 +22465,7 @@
           <p:cNvPr id="7" name="">
             <a:extLst xmlns:a="http://schemas.openxmlformats.org/drawingml/2006/main">
               <a:ext uri="{FF2B5EF4-FFF2-40B4-BE49-F238E27FC236}">
-                <a16:creationId xmlns:a16="http://schemas.microsoft.com/office/drawing/2014/main" id="{16249A66-E8E8-4FA5-8796-3A82A6947877}"/>
+                <a16:creationId xmlns:a16="http://schemas.microsoft.com/office/drawing/2014/main" id="{39B907BA-2816-4B1A-845D-DD8E98E63097}"/>
               </a:ext>
             </a:extLst>
           </p:cNvPr>
@@ -20177,7 +22477,7 @@
         <p:spPr>
           <a:xfrm xmlns:a="http://schemas.openxmlformats.org/drawingml/2006/main">
             <a:off x="1104900" y="5143500"/>
-            <a:ext cx="5715000" cy="228600"/>
+            <a:ext cx="7239000" cy="228600"/>
           </a:xfrm>
           <a:prstGeom xmlns:a="http://schemas.openxmlformats.org/drawingml/2006/main" prst="rect">
             <a:avLst/>
@@ -20312,7 +22612,7 @@
                 <a:ea typeface="Arial"/>
                 <a:cs typeface="Arial"/>
               </a:rPr>
-              <a:t>Next: Pi audio + clean benchmark</a:t>
+              <a:t>Next: Filipino provider voice + Pi speaker + clean benchmark</a:t>
             </a:r>
           </a:p>
         </p:txBody>
@@ -20322,7 +22622,7 @@
           <p:cNvPr id="8" name="">
             <a:extLst xmlns:a="http://schemas.openxmlformats.org/drawingml/2006/main">
               <a:ext uri="{FF2B5EF4-FFF2-40B4-BE49-F238E27FC236}">
-                <a16:creationId xmlns:a16="http://schemas.microsoft.com/office/drawing/2014/main" id="{E208203D-B7AF-445F-8B18-DB1857614600}"/>
+                <a16:creationId xmlns:a16="http://schemas.microsoft.com/office/drawing/2014/main" id="{FFE9B116-B209-44F6-A50E-05D111C9E42F}"/>
               </a:ext>
             </a:extLst>
           </p:cNvPr>
@@ -20479,7 +22779,7 @@
           <p:cNvPr id="9" name="">
             <a:extLst xmlns:a="http://schemas.openxmlformats.org/drawingml/2006/main">
               <a:ext uri="{FF2B5EF4-FFF2-40B4-BE49-F238E27FC236}">
-                <a16:creationId xmlns:a16="http://schemas.microsoft.com/office/drawing/2014/main" id="{501B442A-F667-4633-AD7F-860601308AD6}"/>
+                <a16:creationId xmlns:a16="http://schemas.microsoft.com/office/drawing/2014/main" id="{5C1B705A-729C-446C-80F5-DCAC9BCA658B}"/>
               </a:ext>
             </a:extLst>
           </p:cNvPr>
@@ -20626,7 +22926,7 @@
                 <a:ea typeface="Arial"/>
                 <a:cs typeface="Arial"/>
               </a:rPr>
-              <a:t>ME3 VOICE DUPLEX  •  QWEN TOOL BRAIN  •  7/7</a:t>
+              <a:t>ME3 VOICE DUPLEX  |  QWEN TOOL BRAIN  |  8/8</a:t>
             </a:r>
           </a:p>
         </p:txBody>
@@ -20634,7 +22934,7 @@
     </p:spTree>
     <p:extLst>
       <p:ext uri="{BB962C8B-B14F-4D97-AF65-F5344CB8AC3E}">
-        <p14:creationId xmlns:p14="http://schemas.microsoft.com/office/powerpoint/2010/main" val="587759242"/>
+        <p14:creationId xmlns:p14="http://schemas.microsoft.com/office/powerpoint/2010/main" val="134344059"/>
       </p:ext>
     </p:extLst>
   </p:cSld>

</xml_diff>